<commit_message>
Introdução curso: adiciona slide de apresentação do Vitor Passos
Co-Authored-By: Claude Opus 5.5 <noreply@anthropic.com>
</commit_message>
<xml_diff>
--- a/00. Introdução curso/Introdução_Curso.pptx
+++ b/00. Introdução curso/Introdução_Curso.pptx
@@ -5,7 +5,7 @@
     <p:sldMasterId id="2147483648" r:id="rId5"/>
   </p:sldMasterIdLst>
   <p:notesMasterIdLst>
-    <p:notesMasterId r:id="rId11"/>
+    <p:notesMasterId r:id="rId12"/>
   </p:notesMasterIdLst>
   <p:sldIdLst>
     <p:sldId id="8051" r:id="rId6"/>
@@ -13,18 +13,19 @@
     <p:sldId id="8053" r:id="rId8"/>
     <p:sldId id="8054" r:id="rId9"/>
     <p:sldId id="8055" r:id="rId10"/>
+    <p:sldId id="442" r:id="rId11"/>
   </p:sldIdLst>
   <p:sldSz cx="12192000" cy="6858000"/>
   <p:notesSz cx="6858000" cy="9144000"/>
   <p:embeddedFontLst>
     <p:embeddedFont>
       <p:font typeface="Franklin Gothic Book" panose="020B0503020102020204" pitchFamily="34" charset="0"/>
-      <p:regular r:id="rId12"/>
-      <p:italic r:id="rId13"/>
+      <p:regular r:id="rId13"/>
+      <p:italic r:id="rId14"/>
     </p:embeddedFont>
   </p:embeddedFontLst>
   <p:custDataLst>
-    <p:tags r:id="rId14"/>
+    <p:tags r:id="rId15"/>
   </p:custDataLst>
   <p:defaultTextStyle>
     <a:defPPr>
@@ -151,434 +152,6 @@
     <p1510:client id="{336C66E5-7053-456A-AABF-189EEADFA1A8}" v="11" dt="2026-10-29T13:00:25.966"/>
   </p1510:revLst>
 </p1510:revInfo>
-</file>
-
-<file path=ppt/changesInfos/changesInfo1.xml><?xml version="1.0" encoding="utf-8"?>
-<pc:chgInfo xmlns:a="http://schemas.openxmlformats.org/drawingml/2006/main" xmlns:r="http://schemas.openxmlformats.org/officeDocument/2006/relationships" xmlns:ac="http://schemas.microsoft.com/office/drawing/2013/main/command" xmlns:pc="http://schemas.microsoft.com/office/powerpoint/2013/main/command">
-  <pc:docChgLst>
-    <pc:chgData name="Eder Silva" userId="9b7f41b4-798d-40cf-8f87-8e33ae7a0417" providerId="ADAL" clId="{DFF9E84E-5922-4F26-9EAD-8AB4E668133E}"/>
-    <pc:docChg chg="undo custSel addSld delSld modSld delMainMaster">
-      <pc:chgData name="Eder Silva" userId="9b7f41b4-798d-40cf-8f87-8e33ae7a0417" providerId="ADAL" clId="{DFF9E84E-5922-4F26-9EAD-8AB4E668133E}" dt="2026-10-29T13:00:31.721" v="135" actId="27636"/>
-      <pc:docMkLst>
-        <pc:docMk/>
-      </pc:docMkLst>
-      <pc:sldChg chg="del">
-        <pc:chgData name="Eder Silva" userId="9b7f41b4-798d-40cf-8f87-8e33ae7a0417" providerId="ADAL" clId="{DFF9E84E-5922-4F26-9EAD-8AB4E668133E}" dt="2026-10-29T12:55:26.321" v="0" actId="47"/>
-        <pc:sldMkLst>
-          <pc:docMk/>
-          <pc:sldMk cId="1973319289" sldId="259"/>
-        </pc:sldMkLst>
-      </pc:sldChg>
-      <pc:sldChg chg="del">
-        <pc:chgData name="Eder Silva" userId="9b7f41b4-798d-40cf-8f87-8e33ae7a0417" providerId="ADAL" clId="{DFF9E84E-5922-4F26-9EAD-8AB4E668133E}" dt="2026-10-29T12:55:32.952" v="1" actId="47"/>
-        <pc:sldMkLst>
-          <pc:docMk/>
-          <pc:sldMk cId="725936582" sldId="273"/>
-        </pc:sldMkLst>
-      </pc:sldChg>
-      <pc:sldChg chg="del">
-        <pc:chgData name="Eder Silva" userId="9b7f41b4-798d-40cf-8f87-8e33ae7a0417" providerId="ADAL" clId="{DFF9E84E-5922-4F26-9EAD-8AB4E668133E}" dt="2026-10-29T12:55:32.952" v="1" actId="47"/>
-        <pc:sldMkLst>
-          <pc:docMk/>
-          <pc:sldMk cId="606404912" sldId="274"/>
-        </pc:sldMkLst>
-      </pc:sldChg>
-      <pc:sldChg chg="del">
-        <pc:chgData name="Eder Silva" userId="9b7f41b4-798d-40cf-8f87-8e33ae7a0417" providerId="ADAL" clId="{DFF9E84E-5922-4F26-9EAD-8AB4E668133E}" dt="2026-10-29T12:55:26.321" v="0" actId="47"/>
-        <pc:sldMkLst>
-          <pc:docMk/>
-          <pc:sldMk cId="191867972" sldId="284"/>
-        </pc:sldMkLst>
-      </pc:sldChg>
-      <pc:sldChg chg="del">
-        <pc:chgData name="Eder Silva" userId="9b7f41b4-798d-40cf-8f87-8e33ae7a0417" providerId="ADAL" clId="{DFF9E84E-5922-4F26-9EAD-8AB4E668133E}" dt="2026-10-29T12:55:32.952" v="1" actId="47"/>
-        <pc:sldMkLst>
-          <pc:docMk/>
-          <pc:sldMk cId="0" sldId="604"/>
-        </pc:sldMkLst>
-      </pc:sldChg>
-      <pc:sldChg chg="del">
-        <pc:chgData name="Eder Silva" userId="9b7f41b4-798d-40cf-8f87-8e33ae7a0417" providerId="ADAL" clId="{DFF9E84E-5922-4F26-9EAD-8AB4E668133E}" dt="2026-10-29T12:55:26.321" v="0" actId="47"/>
-        <pc:sldMkLst>
-          <pc:docMk/>
-          <pc:sldMk cId="3204094010" sldId="3414"/>
-        </pc:sldMkLst>
-      </pc:sldChg>
-      <pc:sldChg chg="del">
-        <pc:chgData name="Eder Silva" userId="9b7f41b4-798d-40cf-8f87-8e33ae7a0417" providerId="ADAL" clId="{DFF9E84E-5922-4F26-9EAD-8AB4E668133E}" dt="2026-10-29T12:55:26.321" v="0" actId="47"/>
-        <pc:sldMkLst>
-          <pc:docMk/>
-          <pc:sldMk cId="4164921247" sldId="3418"/>
-        </pc:sldMkLst>
-      </pc:sldChg>
-      <pc:sldChg chg="del">
-        <pc:chgData name="Eder Silva" userId="9b7f41b4-798d-40cf-8f87-8e33ae7a0417" providerId="ADAL" clId="{DFF9E84E-5922-4F26-9EAD-8AB4E668133E}" dt="2026-10-29T12:55:26.321" v="0" actId="47"/>
-        <pc:sldMkLst>
-          <pc:docMk/>
-          <pc:sldMk cId="1307113214" sldId="7982"/>
-        </pc:sldMkLst>
-      </pc:sldChg>
-      <pc:sldChg chg="del">
-        <pc:chgData name="Eder Silva" userId="9b7f41b4-798d-40cf-8f87-8e33ae7a0417" providerId="ADAL" clId="{DFF9E84E-5922-4F26-9EAD-8AB4E668133E}" dt="2026-10-29T12:55:26.321" v="0" actId="47"/>
-        <pc:sldMkLst>
-          <pc:docMk/>
-          <pc:sldMk cId="2962016144" sldId="8035"/>
-        </pc:sldMkLst>
-      </pc:sldChg>
-      <pc:sldChg chg="del">
-        <pc:chgData name="Eder Silva" userId="9b7f41b4-798d-40cf-8f87-8e33ae7a0417" providerId="ADAL" clId="{DFF9E84E-5922-4F26-9EAD-8AB4E668133E}" dt="2026-10-29T12:55:26.321" v="0" actId="47"/>
-        <pc:sldMkLst>
-          <pc:docMk/>
-          <pc:sldMk cId="621901527" sldId="8041"/>
-        </pc:sldMkLst>
-      </pc:sldChg>
-      <pc:sldChg chg="addSp delSp modSp mod">
-        <pc:chgData name="Eder Silva" userId="9b7f41b4-798d-40cf-8f87-8e33ae7a0417" providerId="ADAL" clId="{DFF9E84E-5922-4F26-9EAD-8AB4E668133E}" dt="2026-10-29T12:59:53.806" v="88"/>
-        <pc:sldMkLst>
-          <pc:docMk/>
-          <pc:sldMk cId="4140195550" sldId="8051"/>
-        </pc:sldMkLst>
-        <pc:spChg chg="add mod">
-          <ac:chgData name="Eder Silva" userId="9b7f41b4-798d-40cf-8f87-8e33ae7a0417" providerId="ADAL" clId="{DFF9E84E-5922-4F26-9EAD-8AB4E668133E}" dt="2026-10-29T12:57:54.652" v="14" actId="1076"/>
-          <ac:spMkLst>
-            <pc:docMk/>
-            <pc:sldMk cId="4140195550" sldId="8051"/>
-            <ac:spMk id="3" creationId="{B61FCB71-833B-AE7F-5132-230251B232C5}"/>
-          </ac:spMkLst>
-        </pc:spChg>
-        <pc:spChg chg="add mod">
-          <ac:chgData name="Eder Silva" userId="9b7f41b4-798d-40cf-8f87-8e33ae7a0417" providerId="ADAL" clId="{DFF9E84E-5922-4F26-9EAD-8AB4E668133E}" dt="2026-10-29T12:58:00.238" v="15" actId="14100"/>
-          <ac:spMkLst>
-            <pc:docMk/>
-            <pc:sldMk cId="4140195550" sldId="8051"/>
-            <ac:spMk id="5" creationId="{45935CC1-F070-6C63-18A0-0F529747B649}"/>
-          </ac:spMkLst>
-        </pc:spChg>
-        <pc:spChg chg="add mod">
-          <ac:chgData name="Eder Silva" userId="9b7f41b4-798d-40cf-8f87-8e33ae7a0417" providerId="ADAL" clId="{DFF9E84E-5922-4F26-9EAD-8AB4E668133E}" dt="2026-10-29T12:58:59.701" v="18" actId="20577"/>
-          <ac:spMkLst>
-            <pc:docMk/>
-            <pc:sldMk cId="4140195550" sldId="8051"/>
-            <ac:spMk id="8" creationId="{DE9333E7-3DE5-3E2F-C3C9-7F054430DC91}"/>
-          </ac:spMkLst>
-        </pc:spChg>
-        <pc:spChg chg="add mod">
-          <ac:chgData name="Eder Silva" userId="9b7f41b4-798d-40cf-8f87-8e33ae7a0417" providerId="ADAL" clId="{DFF9E84E-5922-4F26-9EAD-8AB4E668133E}" dt="2026-10-29T12:59:40.754" v="85" actId="6549"/>
-          <ac:spMkLst>
-            <pc:docMk/>
-            <pc:sldMk cId="4140195550" sldId="8051"/>
-            <ac:spMk id="10" creationId="{18B584B9-0815-0156-89AF-7DC834707FEA}"/>
-          </ac:spMkLst>
-        </pc:spChg>
-        <pc:spChg chg="add del mod">
-          <ac:chgData name="Eder Silva" userId="9b7f41b4-798d-40cf-8f87-8e33ae7a0417" providerId="ADAL" clId="{DFF9E84E-5922-4F26-9EAD-8AB4E668133E}" dt="2026-10-29T12:59:53.806" v="88"/>
-          <ac:spMkLst>
-            <pc:docMk/>
-            <pc:sldMk cId="4140195550" sldId="8051"/>
-            <ac:spMk id="11" creationId="{30F2DC13-88DC-675D-C147-775E7A69EC75}"/>
-          </ac:spMkLst>
-        </pc:spChg>
-      </pc:sldChg>
-      <pc:sldChg chg="modSp new mod">
-        <pc:chgData name="Eder Silva" userId="9b7f41b4-798d-40cf-8f87-8e33ae7a0417" providerId="ADAL" clId="{DFF9E84E-5922-4F26-9EAD-8AB4E668133E}" dt="2026-10-29T13:00:11.887" v="104" actId="27636"/>
-        <pc:sldMkLst>
-          <pc:docMk/>
-          <pc:sldMk cId="2522586401" sldId="8052"/>
-        </pc:sldMkLst>
-        <pc:spChg chg="mod">
-          <ac:chgData name="Eder Silva" userId="9b7f41b4-798d-40cf-8f87-8e33ae7a0417" providerId="ADAL" clId="{DFF9E84E-5922-4F26-9EAD-8AB4E668133E}" dt="2026-10-29T13:00:11.887" v="104" actId="27636"/>
-          <ac:spMkLst>
-            <pc:docMk/>
-            <pc:sldMk cId="2522586401" sldId="8052"/>
-            <ac:spMk id="2" creationId="{BD838F9D-24FF-9587-47EE-2142A78FFC2E}"/>
-          </ac:spMkLst>
-        </pc:spChg>
-        <pc:spChg chg="mod">
-          <ac:chgData name="Eder Silva" userId="9b7f41b4-798d-40cf-8f87-8e33ae7a0417" providerId="ADAL" clId="{DFF9E84E-5922-4F26-9EAD-8AB4E668133E}" dt="2026-10-29T13:00:07.479" v="101" actId="20577"/>
-          <ac:spMkLst>
-            <pc:docMk/>
-            <pc:sldMk cId="2522586401" sldId="8052"/>
-            <ac:spMk id="3" creationId="{0F913942-FC52-7ED6-2073-D315E213F662}"/>
-          </ac:spMkLst>
-        </pc:spChg>
-      </pc:sldChg>
-      <pc:sldChg chg="modSp add mod">
-        <pc:chgData name="Eder Silva" userId="9b7f41b4-798d-40cf-8f87-8e33ae7a0417" providerId="ADAL" clId="{DFF9E84E-5922-4F26-9EAD-8AB4E668133E}" dt="2026-10-29T13:00:18.985" v="115" actId="5793"/>
-        <pc:sldMkLst>
-          <pc:docMk/>
-          <pc:sldMk cId="1906589350" sldId="8053"/>
-        </pc:sldMkLst>
-        <pc:spChg chg="mod">
-          <ac:chgData name="Eder Silva" userId="9b7f41b4-798d-40cf-8f87-8e33ae7a0417" providerId="ADAL" clId="{DFF9E84E-5922-4F26-9EAD-8AB4E668133E}" dt="2026-10-29T13:00:11.875" v="103" actId="27636"/>
-          <ac:spMkLst>
-            <pc:docMk/>
-            <pc:sldMk cId="1906589350" sldId="8053"/>
-            <ac:spMk id="2" creationId="{283037DE-876A-A764-31C6-95D492E2C8EF}"/>
-          </ac:spMkLst>
-        </pc:spChg>
-        <pc:spChg chg="mod">
-          <ac:chgData name="Eder Silva" userId="9b7f41b4-798d-40cf-8f87-8e33ae7a0417" providerId="ADAL" clId="{DFF9E84E-5922-4F26-9EAD-8AB4E668133E}" dt="2026-10-29T13:00:18.985" v="115" actId="5793"/>
-          <ac:spMkLst>
-            <pc:docMk/>
-            <pc:sldMk cId="1906589350" sldId="8053"/>
-            <ac:spMk id="3" creationId="{6D21D0EA-E48B-9FA0-7770-0B68A3C94766}"/>
-          </ac:spMkLst>
-        </pc:spChg>
-      </pc:sldChg>
-      <pc:sldChg chg="modSp add mod">
-        <pc:chgData name="Eder Silva" userId="9b7f41b4-798d-40cf-8f87-8e33ae7a0417" providerId="ADAL" clId="{DFF9E84E-5922-4F26-9EAD-8AB4E668133E}" dt="2026-10-29T13:00:23.600" v="123" actId="5793"/>
-        <pc:sldMkLst>
-          <pc:docMk/>
-          <pc:sldMk cId="2714868916" sldId="8054"/>
-        </pc:sldMkLst>
-        <pc:spChg chg="mod">
-          <ac:chgData name="Eder Silva" userId="9b7f41b4-798d-40cf-8f87-8e33ae7a0417" providerId="ADAL" clId="{DFF9E84E-5922-4F26-9EAD-8AB4E668133E}" dt="2026-10-29T13:00:12.469" v="106" actId="27636"/>
-          <ac:spMkLst>
-            <pc:docMk/>
-            <pc:sldMk cId="2714868916" sldId="8054"/>
-            <ac:spMk id="2" creationId="{E314B73C-E252-E043-8B08-0B5B0E375308}"/>
-          </ac:spMkLst>
-        </pc:spChg>
-        <pc:spChg chg="mod">
-          <ac:chgData name="Eder Silva" userId="9b7f41b4-798d-40cf-8f87-8e33ae7a0417" providerId="ADAL" clId="{DFF9E84E-5922-4F26-9EAD-8AB4E668133E}" dt="2026-10-29T13:00:23.600" v="123" actId="5793"/>
-          <ac:spMkLst>
-            <pc:docMk/>
-            <pc:sldMk cId="2714868916" sldId="8054"/>
-            <ac:spMk id="3" creationId="{1BFA7F00-8044-555A-B817-9180D5BBE3C1}"/>
-          </ac:spMkLst>
-        </pc:spChg>
-      </pc:sldChg>
-      <pc:sldChg chg="modSp add mod">
-        <pc:chgData name="Eder Silva" userId="9b7f41b4-798d-40cf-8f87-8e33ae7a0417" providerId="ADAL" clId="{DFF9E84E-5922-4F26-9EAD-8AB4E668133E}" dt="2026-10-29T13:00:31.721" v="135" actId="27636"/>
-        <pc:sldMkLst>
-          <pc:docMk/>
-          <pc:sldMk cId="3844586632" sldId="8055"/>
-        </pc:sldMkLst>
-        <pc:spChg chg="mod">
-          <ac:chgData name="Eder Silva" userId="9b7f41b4-798d-40cf-8f87-8e33ae7a0417" providerId="ADAL" clId="{DFF9E84E-5922-4F26-9EAD-8AB4E668133E}" dt="2026-10-29T13:00:31.721" v="135" actId="27636"/>
-          <ac:spMkLst>
-            <pc:docMk/>
-            <pc:sldMk cId="3844586632" sldId="8055"/>
-            <ac:spMk id="3" creationId="{1E0AF1AF-290B-4E0A-C7C9-747229BB8763}"/>
-          </ac:spMkLst>
-        </pc:spChg>
-      </pc:sldChg>
-      <pc:sldChg chg="del">
-        <pc:chgData name="Eder Silva" userId="9b7f41b4-798d-40cf-8f87-8e33ae7a0417" providerId="ADAL" clId="{DFF9E84E-5922-4F26-9EAD-8AB4E668133E}" dt="2026-10-29T12:55:32.952" v="1" actId="47"/>
-        <pc:sldMkLst>
-          <pc:docMk/>
-          <pc:sldMk cId="2345178959" sldId="2069232995"/>
-        </pc:sldMkLst>
-      </pc:sldChg>
-      <pc:sldChg chg="del">
-        <pc:chgData name="Eder Silva" userId="9b7f41b4-798d-40cf-8f87-8e33ae7a0417" providerId="ADAL" clId="{DFF9E84E-5922-4F26-9EAD-8AB4E668133E}" dt="2026-10-29T12:55:26.321" v="0" actId="47"/>
-        <pc:sldMkLst>
-          <pc:docMk/>
-          <pc:sldMk cId="2336061776" sldId="2147376340"/>
-        </pc:sldMkLst>
-      </pc:sldChg>
-      <pc:sldChg chg="del">
-        <pc:chgData name="Eder Silva" userId="9b7f41b4-798d-40cf-8f87-8e33ae7a0417" providerId="ADAL" clId="{DFF9E84E-5922-4F26-9EAD-8AB4E668133E}" dt="2026-10-29T12:55:32.952" v="1" actId="47"/>
-        <pc:sldMkLst>
-          <pc:docMk/>
-          <pc:sldMk cId="1525061714" sldId="2147470644"/>
-        </pc:sldMkLst>
-      </pc:sldChg>
-      <pc:sldChg chg="del">
-        <pc:chgData name="Eder Silva" userId="9b7f41b4-798d-40cf-8f87-8e33ae7a0417" providerId="ADAL" clId="{DFF9E84E-5922-4F26-9EAD-8AB4E668133E}" dt="2026-10-29T12:55:26.321" v="0" actId="47"/>
-        <pc:sldMkLst>
-          <pc:docMk/>
-          <pc:sldMk cId="4073951537" sldId="2147478425"/>
-        </pc:sldMkLst>
-      </pc:sldChg>
-      <pc:sldChg chg="del">
-        <pc:chgData name="Eder Silva" userId="9b7f41b4-798d-40cf-8f87-8e33ae7a0417" providerId="ADAL" clId="{DFF9E84E-5922-4F26-9EAD-8AB4E668133E}" dt="2026-10-29T12:55:26.321" v="0" actId="47"/>
-        <pc:sldMkLst>
-          <pc:docMk/>
-          <pc:sldMk cId="2838426904" sldId="2147479461"/>
-        </pc:sldMkLst>
-      </pc:sldChg>
-      <pc:sldChg chg="del">
-        <pc:chgData name="Eder Silva" userId="9b7f41b4-798d-40cf-8f87-8e33ae7a0417" providerId="ADAL" clId="{DFF9E84E-5922-4F26-9EAD-8AB4E668133E}" dt="2026-10-29T12:55:32.952" v="1" actId="47"/>
-        <pc:sldMkLst>
-          <pc:docMk/>
-          <pc:sldMk cId="3501892397" sldId="2147479499"/>
-        </pc:sldMkLst>
-      </pc:sldChg>
-      <pc:sldChg chg="del">
-        <pc:chgData name="Eder Silva" userId="9b7f41b4-798d-40cf-8f87-8e33ae7a0417" providerId="ADAL" clId="{DFF9E84E-5922-4F26-9EAD-8AB4E668133E}" dt="2026-10-29T12:55:26.321" v="0" actId="47"/>
-        <pc:sldMkLst>
-          <pc:docMk/>
-          <pc:sldMk cId="3310555252" sldId="2147479502"/>
-        </pc:sldMkLst>
-      </pc:sldChg>
-      <pc:sldChg chg="del">
-        <pc:chgData name="Eder Silva" userId="9b7f41b4-798d-40cf-8f87-8e33ae7a0417" providerId="ADAL" clId="{DFF9E84E-5922-4F26-9EAD-8AB4E668133E}" dt="2026-10-29T12:55:32.952" v="1" actId="47"/>
-        <pc:sldMkLst>
-          <pc:docMk/>
-          <pc:sldMk cId="1647833090" sldId="2147479503"/>
-        </pc:sldMkLst>
-      </pc:sldChg>
-      <pc:sldChg chg="del">
-        <pc:chgData name="Eder Silva" userId="9b7f41b4-798d-40cf-8f87-8e33ae7a0417" providerId="ADAL" clId="{DFF9E84E-5922-4F26-9EAD-8AB4E668133E}" dt="2026-10-29T12:55:26.321" v="0" actId="47"/>
-        <pc:sldMkLst>
-          <pc:docMk/>
-          <pc:sldMk cId="1033170528" sldId="2147479505"/>
-        </pc:sldMkLst>
-      </pc:sldChg>
-      <pc:sldMasterChg chg="delSldLayout">
-        <pc:chgData name="Eder Silva" userId="9b7f41b4-798d-40cf-8f87-8e33ae7a0417" providerId="ADAL" clId="{DFF9E84E-5922-4F26-9EAD-8AB4E668133E}" dt="2026-10-29T12:55:32.952" v="1" actId="47"/>
-        <pc:sldMasterMkLst>
-          <pc:docMk/>
-          <pc:sldMasterMk cId="1386496529" sldId="2147483648"/>
-        </pc:sldMasterMkLst>
-        <pc:sldLayoutChg chg="del">
-          <pc:chgData name="Eder Silva" userId="9b7f41b4-798d-40cf-8f87-8e33ae7a0417" providerId="ADAL" clId="{DFF9E84E-5922-4F26-9EAD-8AB4E668133E}" dt="2026-10-29T12:55:32.952" v="1" actId="47"/>
-          <pc:sldLayoutMkLst>
-            <pc:docMk/>
-            <pc:sldMasterMk cId="1386496529" sldId="2147483648"/>
-            <pc:sldLayoutMk cId="2879701446" sldId="2147483687"/>
-          </pc:sldLayoutMkLst>
-        </pc:sldLayoutChg>
-        <pc:sldLayoutChg chg="del">
-          <pc:chgData name="Eder Silva" userId="9b7f41b4-798d-40cf-8f87-8e33ae7a0417" providerId="ADAL" clId="{DFF9E84E-5922-4F26-9EAD-8AB4E668133E}" dt="2026-10-29T12:55:26.321" v="0" actId="47"/>
-          <pc:sldLayoutMkLst>
-            <pc:docMk/>
-            <pc:sldMasterMk cId="1386496529" sldId="2147483648"/>
-            <pc:sldLayoutMk cId="510896008" sldId="2147483692"/>
-          </pc:sldLayoutMkLst>
-        </pc:sldLayoutChg>
-        <pc:sldLayoutChg chg="del">
-          <pc:chgData name="Eder Silva" userId="9b7f41b4-798d-40cf-8f87-8e33ae7a0417" providerId="ADAL" clId="{DFF9E84E-5922-4F26-9EAD-8AB4E668133E}" dt="2026-10-29T12:55:26.321" v="0" actId="47"/>
-          <pc:sldLayoutMkLst>
-            <pc:docMk/>
-            <pc:sldMasterMk cId="1386496529" sldId="2147483648"/>
-            <pc:sldLayoutMk cId="3172166586" sldId="2147483693"/>
-          </pc:sldLayoutMkLst>
-        </pc:sldLayoutChg>
-        <pc:sldLayoutChg chg="del">
-          <pc:chgData name="Eder Silva" userId="9b7f41b4-798d-40cf-8f87-8e33ae7a0417" providerId="ADAL" clId="{DFF9E84E-5922-4F26-9EAD-8AB4E668133E}" dt="2026-10-29T12:55:32.952" v="1" actId="47"/>
-          <pc:sldLayoutMkLst>
-            <pc:docMk/>
-            <pc:sldMasterMk cId="1386496529" sldId="2147483648"/>
-            <pc:sldLayoutMk cId="3572666370" sldId="2147483694"/>
-          </pc:sldLayoutMkLst>
-        </pc:sldLayoutChg>
-        <pc:sldLayoutChg chg="del">
-          <pc:chgData name="Eder Silva" userId="9b7f41b4-798d-40cf-8f87-8e33ae7a0417" providerId="ADAL" clId="{DFF9E84E-5922-4F26-9EAD-8AB4E668133E}" dt="2026-10-29T12:55:26.321" v="0" actId="47"/>
-          <pc:sldLayoutMkLst>
-            <pc:docMk/>
-            <pc:sldMasterMk cId="1386496529" sldId="2147483648"/>
-            <pc:sldLayoutMk cId="2317931528" sldId="2147483695"/>
-          </pc:sldLayoutMkLst>
-        </pc:sldLayoutChg>
-        <pc:sldLayoutChg chg="del">
-          <pc:chgData name="Eder Silva" userId="9b7f41b4-798d-40cf-8f87-8e33ae7a0417" providerId="ADAL" clId="{DFF9E84E-5922-4F26-9EAD-8AB4E668133E}" dt="2026-10-29T12:55:32.952" v="1" actId="47"/>
-          <pc:sldLayoutMkLst>
-            <pc:docMk/>
-            <pc:sldMasterMk cId="1386496529" sldId="2147483648"/>
-            <pc:sldLayoutMk cId="2360725724" sldId="2147483696"/>
-          </pc:sldLayoutMkLst>
-        </pc:sldLayoutChg>
-      </pc:sldMasterChg>
-      <pc:sldMasterChg chg="del delSldLayout">
-        <pc:chgData name="Eder Silva" userId="9b7f41b4-798d-40cf-8f87-8e33ae7a0417" providerId="ADAL" clId="{DFF9E84E-5922-4F26-9EAD-8AB4E668133E}" dt="2026-10-29T12:55:26.321" v="0" actId="47"/>
-        <pc:sldMasterMkLst>
-          <pc:docMk/>
-          <pc:sldMasterMk cId="1057281720" sldId="2147483697"/>
-        </pc:sldMasterMkLst>
-        <pc:sldLayoutChg chg="del">
-          <pc:chgData name="Eder Silva" userId="9b7f41b4-798d-40cf-8f87-8e33ae7a0417" providerId="ADAL" clId="{DFF9E84E-5922-4F26-9EAD-8AB4E668133E}" dt="2026-10-29T12:55:26.321" v="0" actId="47"/>
-          <pc:sldLayoutMkLst>
-            <pc:docMk/>
-            <pc:sldMasterMk cId="1057281720" sldId="2147483697"/>
-            <pc:sldLayoutMk cId="1691532616" sldId="2147483698"/>
-          </pc:sldLayoutMkLst>
-        </pc:sldLayoutChg>
-        <pc:sldLayoutChg chg="del">
-          <pc:chgData name="Eder Silva" userId="9b7f41b4-798d-40cf-8f87-8e33ae7a0417" providerId="ADAL" clId="{DFF9E84E-5922-4F26-9EAD-8AB4E668133E}" dt="2026-10-29T12:55:26.321" v="0" actId="47"/>
-          <pc:sldLayoutMkLst>
-            <pc:docMk/>
-            <pc:sldMasterMk cId="1057281720" sldId="2147483697"/>
-            <pc:sldLayoutMk cId="3258116074" sldId="2147483699"/>
-          </pc:sldLayoutMkLst>
-        </pc:sldLayoutChg>
-        <pc:sldLayoutChg chg="del">
-          <pc:chgData name="Eder Silva" userId="9b7f41b4-798d-40cf-8f87-8e33ae7a0417" providerId="ADAL" clId="{DFF9E84E-5922-4F26-9EAD-8AB4E668133E}" dt="2026-10-29T12:55:26.321" v="0" actId="47"/>
-          <pc:sldLayoutMkLst>
-            <pc:docMk/>
-            <pc:sldMasterMk cId="1057281720" sldId="2147483697"/>
-            <pc:sldLayoutMk cId="479033514" sldId="2147483700"/>
-          </pc:sldLayoutMkLst>
-        </pc:sldLayoutChg>
-        <pc:sldLayoutChg chg="del">
-          <pc:chgData name="Eder Silva" userId="9b7f41b4-798d-40cf-8f87-8e33ae7a0417" providerId="ADAL" clId="{DFF9E84E-5922-4F26-9EAD-8AB4E668133E}" dt="2026-10-29T12:55:26.321" v="0" actId="47"/>
-          <pc:sldLayoutMkLst>
-            <pc:docMk/>
-            <pc:sldMasterMk cId="1057281720" sldId="2147483697"/>
-            <pc:sldLayoutMk cId="3047717404" sldId="2147483701"/>
-          </pc:sldLayoutMkLst>
-        </pc:sldLayoutChg>
-        <pc:sldLayoutChg chg="del">
-          <pc:chgData name="Eder Silva" userId="9b7f41b4-798d-40cf-8f87-8e33ae7a0417" providerId="ADAL" clId="{DFF9E84E-5922-4F26-9EAD-8AB4E668133E}" dt="2026-10-29T12:55:26.321" v="0" actId="47"/>
-          <pc:sldLayoutMkLst>
-            <pc:docMk/>
-            <pc:sldMasterMk cId="1057281720" sldId="2147483697"/>
-            <pc:sldLayoutMk cId="2152459423" sldId="2147483702"/>
-          </pc:sldLayoutMkLst>
-        </pc:sldLayoutChg>
-        <pc:sldLayoutChg chg="del">
-          <pc:chgData name="Eder Silva" userId="9b7f41b4-798d-40cf-8f87-8e33ae7a0417" providerId="ADAL" clId="{DFF9E84E-5922-4F26-9EAD-8AB4E668133E}" dt="2026-10-29T12:55:26.321" v="0" actId="47"/>
-          <pc:sldLayoutMkLst>
-            <pc:docMk/>
-            <pc:sldMasterMk cId="1057281720" sldId="2147483697"/>
-            <pc:sldLayoutMk cId="2103563981" sldId="2147483703"/>
-          </pc:sldLayoutMkLst>
-        </pc:sldLayoutChg>
-        <pc:sldLayoutChg chg="del">
-          <pc:chgData name="Eder Silva" userId="9b7f41b4-798d-40cf-8f87-8e33ae7a0417" providerId="ADAL" clId="{DFF9E84E-5922-4F26-9EAD-8AB4E668133E}" dt="2026-10-29T12:55:26.321" v="0" actId="47"/>
-          <pc:sldLayoutMkLst>
-            <pc:docMk/>
-            <pc:sldMasterMk cId="1057281720" sldId="2147483697"/>
-            <pc:sldLayoutMk cId="1485553921" sldId="2147483704"/>
-          </pc:sldLayoutMkLst>
-        </pc:sldLayoutChg>
-        <pc:sldLayoutChg chg="del">
-          <pc:chgData name="Eder Silva" userId="9b7f41b4-798d-40cf-8f87-8e33ae7a0417" providerId="ADAL" clId="{DFF9E84E-5922-4F26-9EAD-8AB4E668133E}" dt="2026-10-29T12:55:26.321" v="0" actId="47"/>
-          <pc:sldLayoutMkLst>
-            <pc:docMk/>
-            <pc:sldMasterMk cId="1057281720" sldId="2147483697"/>
-            <pc:sldLayoutMk cId="222804649" sldId="2147483705"/>
-          </pc:sldLayoutMkLst>
-        </pc:sldLayoutChg>
-        <pc:sldLayoutChg chg="del">
-          <pc:chgData name="Eder Silva" userId="9b7f41b4-798d-40cf-8f87-8e33ae7a0417" providerId="ADAL" clId="{DFF9E84E-5922-4F26-9EAD-8AB4E668133E}" dt="2026-10-29T12:55:26.321" v="0" actId="47"/>
-          <pc:sldLayoutMkLst>
-            <pc:docMk/>
-            <pc:sldMasterMk cId="1057281720" sldId="2147483697"/>
-            <pc:sldLayoutMk cId="3157365019" sldId="2147483706"/>
-          </pc:sldLayoutMkLst>
-        </pc:sldLayoutChg>
-        <pc:sldLayoutChg chg="del">
-          <pc:chgData name="Eder Silva" userId="9b7f41b4-798d-40cf-8f87-8e33ae7a0417" providerId="ADAL" clId="{DFF9E84E-5922-4F26-9EAD-8AB4E668133E}" dt="2026-10-29T12:55:26.321" v="0" actId="47"/>
-          <pc:sldLayoutMkLst>
-            <pc:docMk/>
-            <pc:sldMasterMk cId="1057281720" sldId="2147483697"/>
-            <pc:sldLayoutMk cId="403996428" sldId="2147483707"/>
-          </pc:sldLayoutMkLst>
-        </pc:sldLayoutChg>
-        <pc:sldLayoutChg chg="del">
-          <pc:chgData name="Eder Silva" userId="9b7f41b4-798d-40cf-8f87-8e33ae7a0417" providerId="ADAL" clId="{DFF9E84E-5922-4F26-9EAD-8AB4E668133E}" dt="2026-10-29T12:55:26.321" v="0" actId="47"/>
-          <pc:sldLayoutMkLst>
-            <pc:docMk/>
-            <pc:sldMasterMk cId="1057281720" sldId="2147483697"/>
-            <pc:sldLayoutMk cId="3184381640" sldId="2147483708"/>
-          </pc:sldLayoutMkLst>
-        </pc:sldLayoutChg>
-      </pc:sldMasterChg>
-    </pc:docChg>
-  </pc:docChgLst>
-</pc:chgInfo>
 </file>
 
 <file path=ppt/diagrams/colors1.xml><?xml version="1.0" encoding="utf-8"?>
@@ -6495,7 +6068,7 @@
           <a:p>
             <a:fld id="{EF1AA1DD-759B-45B1-AFEB-78EB01D9D944}" type="datetimeFigureOut">
               <a:rPr lang="es-AR" smtClean="0"/>
-              <a:t>29/10/2026</a:t>
+              <a:t>30/10/2026</a:t>
             </a:fld>
             <a:endParaRPr lang="es-AR"/>
           </a:p>
@@ -6654,7 +6227,7 @@
           <a:p>
             <a:fld id="{9FD44675-D763-49AE-90C2-01474B77E645}" type="slidenum">
               <a:rPr lang="es-AR" smtClean="0"/>
-              <a:t>‹#›</a:t>
+              <a:t>‹nº›</a:t>
             </a:fld>
             <a:endParaRPr lang="es-AR"/>
           </a:p>
@@ -6996,7 +6569,7 @@
           <a:p>
             <a:fld id="{AC734F37-2617-DD46-AA94-6E6D6F7F1B32}" type="datetimeFigureOut">
               <a:rPr lang="es-CO" smtClean="0"/>
-              <a:t>29/10/2026</a:t>
+              <a:t>30/10/2026</a:t>
             </a:fld>
             <a:endParaRPr lang="es-CO"/>
           </a:p>
@@ -7050,7 +6623,7 @@
           <a:p>
             <a:fld id="{C1C60C78-3927-B643-B5DB-00526262D8FB}" type="slidenum">
               <a:rPr lang="es-CO" smtClean="0"/>
-              <a:t>‹#›</a:t>
+              <a:t>‹nº›</a:t>
             </a:fld>
             <a:endParaRPr lang="es-CO"/>
           </a:p>
@@ -7196,7 +6769,7 @@
           <a:p>
             <a:fld id="{AC734F37-2617-DD46-AA94-6E6D6F7F1B32}" type="datetimeFigureOut">
               <a:rPr lang="es-CO" smtClean="0"/>
-              <a:t>29/10/2026</a:t>
+              <a:t>30/10/2026</a:t>
             </a:fld>
             <a:endParaRPr lang="es-CO"/>
           </a:p>
@@ -7250,7 +6823,7 @@
           <a:p>
             <a:fld id="{C1C60C78-3927-B643-B5DB-00526262D8FB}" type="slidenum">
               <a:rPr lang="es-CO" smtClean="0"/>
-              <a:t>‹#›</a:t>
+              <a:t>‹nº›</a:t>
             </a:fld>
             <a:endParaRPr lang="es-CO"/>
           </a:p>
@@ -7406,7 +6979,7 @@
           <a:p>
             <a:fld id="{AC734F37-2617-DD46-AA94-6E6D6F7F1B32}" type="datetimeFigureOut">
               <a:rPr lang="es-CO" smtClean="0"/>
-              <a:t>29/10/2026</a:t>
+              <a:t>30/10/2026</a:t>
             </a:fld>
             <a:endParaRPr lang="es-CO"/>
           </a:p>
@@ -7460,7 +7033,7 @@
           <a:p>
             <a:fld id="{C1C60C78-3927-B643-B5DB-00526262D8FB}" type="slidenum">
               <a:rPr lang="es-CO" smtClean="0"/>
-              <a:t>‹#›</a:t>
+              <a:t>‹nº›</a:t>
             </a:fld>
             <a:endParaRPr lang="es-CO"/>
           </a:p>
@@ -7641,7 +7214,7 @@
           <a:p>
             <a:fld id="{652A3E76-57E0-4C14-B2D1-F81636436D73}" type="datetime1">
               <a:rPr lang="en-US" smtClean="0"/>
-              <a:t>10/29/2026</a:t>
+              <a:t>10/30/2026</a:t>
             </a:fld>
             <a:endParaRPr lang="en-US"/>
           </a:p>
@@ -7686,7 +7259,7 @@
           <a:p>
             <a:fld id="{A40963A9-C631-4C9D-836C-AA30C9A2093D}" type="slidenum">
               <a:rPr lang="en-US" smtClean="0"/>
-              <a:t>‹#›</a:t>
+              <a:t>‹nº›</a:t>
             </a:fld>
             <a:endParaRPr lang="en-US"/>
           </a:p>
@@ -7757,6 +7330,275 @@
 </p:sldLayout>
 </file>
 
+<file path=ppt/slideLayouts/slideLayout13.xml><?xml version="1.0" encoding="utf-8"?>
+<p:sldLayout xmlns:a="http://schemas.openxmlformats.org/drawingml/2006/main" xmlns:r="http://schemas.openxmlformats.org/officeDocument/2006/relationships" xmlns:p="http://schemas.openxmlformats.org/presentationml/2006/main" userDrawn="1">
+  <p:cSld name="Title Only">
+    <p:spTree>
+      <p:nvGrpSpPr>
+        <p:cNvPr id="1" name=""/>
+        <p:cNvGrpSpPr/>
+        <p:nvPr/>
+      </p:nvGrpSpPr>
+      <p:grpSpPr>
+        <a:xfrm>
+          <a:off x="0" y="0"/>
+          <a:ext cx="0" cy="0"/>
+          <a:chOff x="0" y="0"/>
+          <a:chExt cx="0" cy="0"/>
+        </a:xfrm>
+      </p:grpSpPr>
+      <p:sp>
+        <p:nvSpPr>
+          <p:cNvPr id="5" name="Footer Placeholder 4"/>
+          <p:cNvSpPr>
+            <a:spLocks noGrp="1"/>
+          </p:cNvSpPr>
+          <p:nvPr>
+            <p:ph type="ftr" sz="quarter" idx="11"/>
+          </p:nvPr>
+        </p:nvSpPr>
+        <p:spPr bwMode="gray"/>
+        <p:txBody>
+          <a:bodyPr/>
+          <a:lstStyle/>
+          <a:p>
+            <a:r>
+              <a:rPr lang="en-US"/>
+              <a:t>/// Bayer Template /// 2024</a:t>
+            </a:r>
+            <a:endParaRPr lang="en-US" dirty="0"/>
+          </a:p>
+        </p:txBody>
+      </p:sp>
+      <p:sp>
+        <p:nvSpPr>
+          <p:cNvPr id="6" name="Slide Number Placeholder 5"/>
+          <p:cNvSpPr>
+            <a:spLocks noGrp="1"/>
+          </p:cNvSpPr>
+          <p:nvPr>
+            <p:ph type="sldNum" sz="quarter" idx="12"/>
+          </p:nvPr>
+        </p:nvSpPr>
+        <p:spPr bwMode="gray"/>
+        <p:txBody>
+          <a:bodyPr/>
+          <a:lstStyle/>
+          <a:p>
+            <a:fld id="{EEAD9179-7A6B-4268-BEB2-F3B8EB06115B}" type="slidenum">
+              <a:rPr lang="en-US"/>
+              <a:t>‹nº›</a:t>
+            </a:fld>
+            <a:endParaRPr lang="en-US" dirty="0"/>
+          </a:p>
+        </p:txBody>
+      </p:sp>
+      <p:pic>
+        <p:nvPicPr>
+          <p:cNvPr id="9" name="Picture 2"/>
+          <p:cNvPicPr>
+            <a:picLocks noChangeAspect="1" noChangeArrowheads="1"/>
+          </p:cNvPicPr>
+          <p:nvPr/>
+        </p:nvPicPr>
+        <p:blipFill>
+          <a:blip r:embed="rId3">
+            <a:extLst>
+              <a:ext uri="{28A0092B-C50C-407E-A947-70E740481C1C}">
+                <a14:useLocalDpi xmlns:a14="http://schemas.microsoft.com/office/drawing/2010/main" val="0"/>
+              </a:ext>
+            </a:extLst>
+          </a:blip>
+          <a:stretch>
+            <a:fillRect/>
+          </a:stretch>
+        </p:blipFill>
+        <p:spPr bwMode="gray">
+          <a:xfrm>
+            <a:off x="196130" y="617155"/>
+            <a:ext cx="399652" cy="399600"/>
+          </a:xfrm>
+          <a:prstGeom prst="rect">
+            <a:avLst/>
+          </a:prstGeom>
+          <a:noFill/>
+          <a:extLst>
+            <a:ext uri="{909E8E84-426E-40DD-AFC4-6F175D3DCCD1}">
+              <a14:hiddenFill xmlns:a14="http://schemas.microsoft.com/office/drawing/2010/main">
+                <a:solidFill>
+                  <a:srgbClr val="FFFFFF"/>
+                </a:solidFill>
+              </a14:hiddenFill>
+            </a:ext>
+          </a:extLst>
+        </p:spPr>
+      </p:pic>
+      <p:sp>
+        <p:nvSpPr>
+          <p:cNvPr id="10" name="Logoschutz" hidden="1"/>
+          <p:cNvSpPr/>
+          <p:nvPr userDrawn="1">
+            <p:custDataLst>
+              <p:tags r:id="rId1"/>
+            </p:custDataLst>
+          </p:nvPr>
+        </p:nvSpPr>
+        <p:spPr bwMode="gray">
+          <a:xfrm>
+            <a:off x="86017" y="509323"/>
+            <a:ext cx="612080" cy="612000"/>
+          </a:xfrm>
+          <a:prstGeom prst="rect">
+            <a:avLst/>
+          </a:prstGeom>
+          <a:solidFill>
+            <a:srgbClr val="00BCFF">
+              <a:alpha val="38824"/>
+            </a:srgbClr>
+          </a:solidFill>
+          <a:ln>
+            <a:noFill/>
+          </a:ln>
+        </p:spPr>
+        <p:style>
+          <a:lnRef idx="2">
+            <a:schemeClr val="accent1">
+              <a:shade val="50000"/>
+            </a:schemeClr>
+          </a:lnRef>
+          <a:fillRef idx="1">
+            <a:schemeClr val="accent1"/>
+          </a:fillRef>
+          <a:effectRef idx="0">
+            <a:schemeClr val="accent1"/>
+          </a:effectRef>
+          <a:fontRef idx="minor">
+            <a:schemeClr val="lt1"/>
+          </a:fontRef>
+        </p:style>
+        <p:txBody>
+          <a:bodyPr rtlCol="0" anchor="ctr"/>
+          <a:lstStyle/>
+          <a:p>
+            <a:pPr algn="ctr"/>
+            <a:r>
+              <a:rPr lang="de-DE" sz="900" dirty="0">
+                <a:solidFill>
+                  <a:schemeClr val="tx1"/>
+                </a:solidFill>
+              </a:rPr>
+              <a:t>Logo</a:t>
+            </a:r>
+          </a:p>
+          <a:p>
+            <a:pPr algn="ctr"/>
+            <a:r>
+              <a:rPr lang="de-DE" sz="900" dirty="0">
+                <a:solidFill>
+                  <a:schemeClr val="tx1"/>
+                </a:solidFill>
+              </a:rPr>
+              <a:t>Schutz</a:t>
+            </a:r>
+          </a:p>
+        </p:txBody>
+      </p:sp>
+      <p:pic>
+        <p:nvPicPr>
+          <p:cNvPr id="14" name="Picture 13">
+            <a:extLst>
+              <a:ext uri="{FF2B5EF4-FFF2-40B4-BE49-F238E27FC236}">
+                <a16:creationId xmlns:a16="http://schemas.microsoft.com/office/drawing/2014/main" id="{E6983A67-7516-8C5A-66ED-F02D20C57168}"/>
+              </a:ext>
+            </a:extLst>
+          </p:cNvPr>
+          <p:cNvPicPr>
+            <a:picLocks noChangeAspect="1"/>
+          </p:cNvPicPr>
+          <p:nvPr userDrawn="1"/>
+        </p:nvPicPr>
+        <p:blipFill>
+          <a:blip r:embed="rId4"/>
+          <a:stretch>
+            <a:fillRect/>
+          </a:stretch>
+        </p:blipFill>
+        <p:spPr>
+          <a:xfrm>
+            <a:off x="9734816" y="163250"/>
+            <a:ext cx="2246693" cy="140400"/>
+          </a:xfrm>
+          <a:prstGeom prst="rect">
+            <a:avLst/>
+          </a:prstGeom>
+        </p:spPr>
+      </p:pic>
+      <p:sp>
+        <p:nvSpPr>
+          <p:cNvPr id="2" name="Title 1">
+            <a:extLst>
+              <a:ext uri="{FF2B5EF4-FFF2-40B4-BE49-F238E27FC236}">
+                <a16:creationId xmlns:a16="http://schemas.microsoft.com/office/drawing/2014/main" id="{3F640F38-817A-C59B-9537-98F103418C04}"/>
+              </a:ext>
+            </a:extLst>
+          </p:cNvPr>
+          <p:cNvSpPr>
+            <a:spLocks noGrp="1"/>
+          </p:cNvSpPr>
+          <p:nvPr>
+            <p:ph type="title"/>
+          </p:nvPr>
+        </p:nvSpPr>
+        <p:spPr/>
+        <p:txBody>
+          <a:bodyPr/>
+          <a:lstStyle/>
+          <a:p>
+            <a:r>
+              <a:rPr lang="en-GB"/>
+              <a:t>Click to edit Master title style</a:t>
+            </a:r>
+            <a:endParaRPr lang="en-US"/>
+          </a:p>
+        </p:txBody>
+      </p:sp>
+    </p:spTree>
+    <p:extLst>
+      <p:ext uri="{BB962C8B-B14F-4D97-AF65-F5344CB8AC3E}">
+        <p14:creationId xmlns:p14="http://schemas.microsoft.com/office/powerpoint/2010/main" val="3479153633"/>
+      </p:ext>
+    </p:extLst>
+  </p:cSld>
+  <p:clrMapOvr>
+    <a:masterClrMapping/>
+  </p:clrMapOvr>
+  <mc:AlternateContent xmlns:mc="http://schemas.openxmlformats.org/markup-compatibility/2006" xmlns:p14="http://schemas.microsoft.com/office/powerpoint/2010/main">
+    <mc:Choice Requires="p14">
+      <p:transition spd="med" p14:dur="700">
+        <p:fade/>
+      </p:transition>
+    </mc:Choice>
+    <mc:Fallback xmlns="">
+      <p:transition spd="med">
+        <p:fade/>
+      </p:transition>
+    </mc:Fallback>
+  </mc:AlternateContent>
+  <p:hf hdr="0" ftr="0" dt="0"/>
+  <p:extLst>
+    <p:ext uri="{DCECCB84-F9BA-43D5-87BE-67443E8EF086}">
+      <p15:sldGuideLst xmlns:p15="http://schemas.microsoft.com/office/powerpoint/2012/main">
+        <p15:guide id="4" orient="horz" pos="4085">
+          <p15:clr>
+            <a:srgbClr val="FBAE40"/>
+          </p15:clr>
+        </p15:guide>
+      </p15:sldGuideLst>
+    </p:ext>
+  </p:extLst>
+</p:sldLayout>
+</file>
+
 <file path=ppt/slideLayouts/slideLayout2.xml><?xml version="1.0" encoding="utf-8"?>
 <p:sldLayout xmlns:a="http://schemas.openxmlformats.org/drawingml/2006/main" xmlns:r="http://schemas.openxmlformats.org/officeDocument/2006/relationships" xmlns:p="http://schemas.openxmlformats.org/presentationml/2006/main" type="obj" preserve="1">
   <p:cSld name="Título y objetos">
@@ -7884,7 +7726,7 @@
           <a:p>
             <a:fld id="{AC734F37-2617-DD46-AA94-6E6D6F7F1B32}" type="datetimeFigureOut">
               <a:rPr lang="es-CO" smtClean="0"/>
-              <a:t>29/10/2026</a:t>
+              <a:t>30/10/2026</a:t>
             </a:fld>
             <a:endParaRPr lang="es-CO"/>
           </a:p>
@@ -7938,7 +7780,7 @@
           <a:p>
             <a:fld id="{C1C60C78-3927-B643-B5DB-00526262D8FB}" type="slidenum">
               <a:rPr lang="es-CO" smtClean="0"/>
-              <a:t>‹#›</a:t>
+              <a:t>‹nº›</a:t>
             </a:fld>
             <a:endParaRPr lang="es-CO"/>
           </a:p>
@@ -8160,7 +8002,7 @@
           <a:p>
             <a:fld id="{AC734F37-2617-DD46-AA94-6E6D6F7F1B32}" type="datetimeFigureOut">
               <a:rPr lang="es-CO" smtClean="0"/>
-              <a:t>29/10/2026</a:t>
+              <a:t>30/10/2026</a:t>
             </a:fld>
             <a:endParaRPr lang="es-CO"/>
           </a:p>
@@ -8214,7 +8056,7 @@
           <a:p>
             <a:fld id="{C1C60C78-3927-B643-B5DB-00526262D8FB}" type="slidenum">
               <a:rPr lang="es-CO" smtClean="0"/>
-              <a:t>‹#›</a:t>
+              <a:t>‹nº›</a:t>
             </a:fld>
             <a:endParaRPr lang="es-CO"/>
           </a:p>
@@ -8428,7 +8270,7 @@
           <a:p>
             <a:fld id="{AC734F37-2617-DD46-AA94-6E6D6F7F1B32}" type="datetimeFigureOut">
               <a:rPr lang="es-CO" smtClean="0"/>
-              <a:t>29/10/2026</a:t>
+              <a:t>30/10/2026</a:t>
             </a:fld>
             <a:endParaRPr lang="es-CO"/>
           </a:p>
@@ -8482,7 +8324,7 @@
           <a:p>
             <a:fld id="{C1C60C78-3927-B643-B5DB-00526262D8FB}" type="slidenum">
               <a:rPr lang="es-CO" smtClean="0"/>
-              <a:t>‹#›</a:t>
+              <a:t>‹nº›</a:t>
             </a:fld>
             <a:endParaRPr lang="es-CO"/>
           </a:p>
@@ -8843,7 +8685,7 @@
           <a:p>
             <a:fld id="{AC734F37-2617-DD46-AA94-6E6D6F7F1B32}" type="datetimeFigureOut">
               <a:rPr lang="es-CO" smtClean="0"/>
-              <a:t>29/10/2026</a:t>
+              <a:t>30/10/2026</a:t>
             </a:fld>
             <a:endParaRPr lang="es-CO"/>
           </a:p>
@@ -8897,7 +8739,7 @@
           <a:p>
             <a:fld id="{C1C60C78-3927-B643-B5DB-00526262D8FB}" type="slidenum">
               <a:rPr lang="es-CO" smtClean="0"/>
-              <a:t>‹#›</a:t>
+              <a:t>‹nº›</a:t>
             </a:fld>
             <a:endParaRPr lang="es-CO"/>
           </a:p>
@@ -8985,7 +8827,7 @@
           <a:p>
             <a:fld id="{AC734F37-2617-DD46-AA94-6E6D6F7F1B32}" type="datetimeFigureOut">
               <a:rPr lang="es-CO" smtClean="0"/>
-              <a:t>29/10/2026</a:t>
+              <a:t>30/10/2026</a:t>
             </a:fld>
             <a:endParaRPr lang="es-CO"/>
           </a:p>
@@ -9039,7 +8881,7 @@
           <a:p>
             <a:fld id="{C1C60C78-3927-B643-B5DB-00526262D8FB}" type="slidenum">
               <a:rPr lang="es-CO" smtClean="0"/>
-              <a:t>‹#›</a:t>
+              <a:t>‹nº›</a:t>
             </a:fld>
             <a:endParaRPr lang="es-CO"/>
           </a:p>
@@ -9098,7 +8940,7 @@
           <a:p>
             <a:fld id="{AC734F37-2617-DD46-AA94-6E6D6F7F1B32}" type="datetimeFigureOut">
               <a:rPr lang="es-CO" smtClean="0"/>
-              <a:t>29/10/2026</a:t>
+              <a:t>30/10/2026</a:t>
             </a:fld>
             <a:endParaRPr lang="es-CO"/>
           </a:p>
@@ -9152,7 +8994,7 @@
           <a:p>
             <a:fld id="{C1C60C78-3927-B643-B5DB-00526262D8FB}" type="slidenum">
               <a:rPr lang="es-CO" smtClean="0"/>
-              <a:t>‹#›</a:t>
+              <a:t>‹nº›</a:t>
             </a:fld>
             <a:endParaRPr lang="es-CO"/>
           </a:p>
@@ -9411,7 +9253,7 @@
           <a:p>
             <a:fld id="{AC734F37-2617-DD46-AA94-6E6D6F7F1B32}" type="datetimeFigureOut">
               <a:rPr lang="es-CO" smtClean="0"/>
-              <a:t>29/10/2026</a:t>
+              <a:t>30/10/2026</a:t>
             </a:fld>
             <a:endParaRPr lang="es-CO"/>
           </a:p>
@@ -9465,7 +9307,7 @@
           <a:p>
             <a:fld id="{C1C60C78-3927-B643-B5DB-00526262D8FB}" type="slidenum">
               <a:rPr lang="es-CO" smtClean="0"/>
-              <a:t>‹#›</a:t>
+              <a:t>‹nº›</a:t>
             </a:fld>
             <a:endParaRPr lang="es-CO"/>
           </a:p>
@@ -9700,7 +9542,7 @@
           <a:p>
             <a:fld id="{AC734F37-2617-DD46-AA94-6E6D6F7F1B32}" type="datetimeFigureOut">
               <a:rPr lang="es-CO" smtClean="0"/>
-              <a:t>29/10/2026</a:t>
+              <a:t>30/10/2026</a:t>
             </a:fld>
             <a:endParaRPr lang="es-CO"/>
           </a:p>
@@ -9754,7 +9596,7 @@
           <a:p>
             <a:fld id="{C1C60C78-3927-B643-B5DB-00526262D8FB}" type="slidenum">
               <a:rPr lang="es-CO" smtClean="0"/>
-              <a:t>‹#›</a:t>
+              <a:t>‹nº›</a:t>
             </a:fld>
             <a:endParaRPr lang="es-CO"/>
           </a:p>
@@ -9943,7 +9785,7 @@
           <a:p>
             <a:fld id="{AC734F37-2617-DD46-AA94-6E6D6F7F1B32}" type="datetimeFigureOut">
               <a:rPr lang="es-CO" smtClean="0"/>
-              <a:t>29/10/2026</a:t>
+              <a:t>30/10/2026</a:t>
             </a:fld>
             <a:endParaRPr lang="es-CO"/>
           </a:p>
@@ -10033,7 +9875,7 @@
           <a:p>
             <a:fld id="{C1C60C78-3927-B643-B5DB-00526262D8FB}" type="slidenum">
               <a:rPr lang="es-CO" smtClean="0"/>
-              <a:t>‹#›</a:t>
+              <a:t>‹nº›</a:t>
             </a:fld>
             <a:endParaRPr lang="es-CO"/>
           </a:p>
@@ -10107,6 +9949,7 @@
     <p:sldLayoutId id="2147483658" r:id="rId10"/>
     <p:sldLayoutId id="2147483659" r:id="rId11"/>
     <p:sldLayoutId id="2147483690" r:id="rId12"/>
+    <p:sldLayoutId id="2147483691" r:id="rId13"/>
   </p:sldLayoutIdLst>
   <p:txStyles>
     <p:titleStyle>
@@ -11671,12 +11514,2380 @@
 </p:sld>
 </file>
 
+<file path=ppt/slides/slide6.xml><?xml version="1.0" encoding="utf-8"?>
+<p:sld xmlns:a="http://schemas.openxmlformats.org/drawingml/2006/main" xmlns:r="http://schemas.openxmlformats.org/officeDocument/2006/relationships" xmlns:p="http://schemas.openxmlformats.org/presentationml/2006/main">
+  <p:cSld>
+    <p:spTree>
+      <p:nvGrpSpPr>
+        <p:cNvPr id="1" name=""/>
+        <p:cNvGrpSpPr/>
+        <p:nvPr/>
+      </p:nvGrpSpPr>
+      <p:grpSpPr>
+        <a:xfrm>
+          <a:off x="0" y="0"/>
+          <a:ext cx="0" cy="0"/>
+          <a:chOff x="0" y="0"/>
+          <a:chExt cx="0" cy="0"/>
+        </a:xfrm>
+      </p:grpSpPr>
+      <p:graphicFrame>
+        <p:nvGraphicFramePr>
+          <p:cNvPr id="16" name="Objekt 15" hidden="1"/>
+          <p:cNvGraphicFramePr>
+            <a:graphicFrameLocks noChangeAspect="1"/>
+          </p:cNvGraphicFramePr>
+          <p:nvPr>
+            <p:custDataLst>
+              <p:tags r:id="rId1"/>
+            </p:custDataLst>
+          </p:nvPr>
+        </p:nvGraphicFramePr>
+        <p:xfrm>
+          <a:off x="3854" y="2143"/>
+          <a:ext cx="2115" cy="1583"/>
+        </p:xfrm>
+        <a:graphic>
+          <a:graphicData uri="http://schemas.openxmlformats.org/presentationml/2006/ole">
+            <mc:AlternateContent xmlns:mc="http://schemas.openxmlformats.org/markup-compatibility/2006">
+              <mc:Choice xmlns:v="urn:schemas-microsoft-com:vml" Requires="v">
+                <p:oleObj name="think-cell Slide" r:id="rId3" imgW="270" imgH="270" progId="TCLayout.ActiveDocument.1">
+                  <p:embed/>
+                </p:oleObj>
+              </mc:Choice>
+              <mc:Fallback>
+                <p:oleObj name="think-cell Slide" r:id="rId3" imgW="270" imgH="270" progId="TCLayout.ActiveDocument.1">
+                  <p:embed/>
+                  <p:pic>
+                    <p:nvPicPr>
+                      <p:cNvPr id="16" name="Objekt 15" hidden="1"/>
+                      <p:cNvPicPr/>
+                      <p:nvPr/>
+                    </p:nvPicPr>
+                    <p:blipFill>
+                      <a:blip r:embed="rId4"/>
+                      <a:stretch>
+                        <a:fillRect/>
+                      </a:stretch>
+                    </p:blipFill>
+                    <p:spPr>
+                      <a:xfrm>
+                        <a:off x="3854" y="2143"/>
+                        <a:ext cx="2115" cy="1583"/>
+                      </a:xfrm>
+                      <a:prstGeom prst="rect">
+                        <a:avLst/>
+                      </a:prstGeom>
+                    </p:spPr>
+                  </p:pic>
+                </p:oleObj>
+              </mc:Fallback>
+            </mc:AlternateContent>
+          </a:graphicData>
+        </a:graphic>
+      </p:graphicFrame>
+      <p:grpSp>
+        <p:nvGrpSpPr>
+          <p:cNvPr id="6" name="Group 5"/>
+          <p:cNvGrpSpPr/>
+          <p:nvPr/>
+        </p:nvGrpSpPr>
+        <p:grpSpPr>
+          <a:xfrm>
+            <a:off x="4057664" y="1432331"/>
+            <a:ext cx="7722673" cy="2049195"/>
+            <a:chOff x="3528096" y="1772663"/>
+            <a:chExt cx="8278446" cy="2049462"/>
+          </a:xfrm>
+        </p:grpSpPr>
+        <p:sp>
+          <p:nvSpPr>
+            <p:cNvPr id="34" name="Rectangle 55"/>
+            <p:cNvSpPr>
+              <a:spLocks noChangeArrowheads="1"/>
+            </p:cNvSpPr>
+            <p:nvPr/>
+          </p:nvSpPr>
+          <p:spPr bwMode="gray">
+            <a:xfrm rot="21411424">
+              <a:off x="3528096" y="1805693"/>
+              <a:ext cx="8278446" cy="1902746"/>
+            </a:xfrm>
+            <a:prstGeom prst="rect">
+              <a:avLst/>
+            </a:prstGeom>
+            <a:solidFill>
+              <a:srgbClr val="10384F"/>
+            </a:solidFill>
+            <a:ln>
+              <a:noFill/>
+            </a:ln>
+            <a:extLst>
+              <a:ext uri="{91240B29-F687-4F45-9708-019B960494DF}">
+                <a14:hiddenLine xmlns:a14="http://schemas.microsoft.com/office/drawing/2010/main" w="19050">
+                  <a:solidFill>
+                    <a:srgbClr val="000000"/>
+                  </a:solidFill>
+                  <a:miter lim="800000"/>
+                  <a:headEnd/>
+                  <a:tailEnd/>
+                </a14:hiddenLine>
+              </a:ext>
+            </a:extLst>
+          </p:spPr>
+          <p:txBody>
+            <a:bodyPr wrap="none" lIns="92347" tIns="46192" rIns="92347" bIns="46192" anchor="ctr"/>
+            <a:lstStyle/>
+            <a:p>
+              <a:pPr defTabSz="905235"/>
+              <a:endParaRPr lang="en-US" sz="1300" dirty="0">
+                <a:solidFill>
+                  <a:srgbClr val="676767"/>
+                </a:solidFill>
+                <a:latin typeface="Arial"/>
+                <a:cs typeface="Arial" charset="0"/>
+              </a:endParaRPr>
+            </a:p>
+          </p:txBody>
+        </p:sp>
+        <p:sp>
+          <p:nvSpPr>
+            <p:cNvPr id="35" name="Rectangle 37"/>
+            <p:cNvSpPr>
+              <a:spLocks noChangeArrowheads="1"/>
+            </p:cNvSpPr>
+            <p:nvPr/>
+          </p:nvSpPr>
+          <p:spPr bwMode="gray">
+            <a:xfrm>
+              <a:off x="3618285" y="1772663"/>
+              <a:ext cx="8056644" cy="2049462"/>
+            </a:xfrm>
+            <a:prstGeom prst="rect">
+              <a:avLst/>
+            </a:prstGeom>
+            <a:solidFill>
+              <a:srgbClr val="FFFFFF"/>
+            </a:solidFill>
+            <a:ln w="3175" algn="ctr">
+              <a:solidFill>
+                <a:srgbClr val="624963"/>
+              </a:solidFill>
+              <a:miter lim="800000"/>
+              <a:headEnd/>
+              <a:tailEnd/>
+            </a:ln>
+          </p:spPr>
+          <p:txBody>
+            <a:bodyPr wrap="none" lIns="92347" tIns="46192" rIns="92347" bIns="46192" numCol="2" anchor="ctr"/>
+            <a:lstStyle/>
+            <a:p>
+              <a:pPr marL="175804" lvl="1" indent="-175804" defTabSz="326857" fontAlgn="base">
+                <a:spcBef>
+                  <a:spcPts val="300"/>
+                </a:spcBef>
+                <a:spcAft>
+                  <a:spcPct val="0"/>
+                </a:spcAft>
+                <a:buClr>
+                  <a:srgbClr val="005598"/>
+                </a:buClr>
+                <a:buSzPct val="85000"/>
+                <a:defRPr>
+                  <a:latin typeface="Arial"/>
+                </a:defRPr>
+              </a:pPr>
+              <a:endParaRPr lang="en-US" altLang="de-DE" sz="1100" kern="0" dirty="0">
+                <a:solidFill>
+                  <a:srgbClr val="676767"/>
+                </a:solidFill>
+                <a:latin typeface="Arial"/>
+              </a:endParaRPr>
+            </a:p>
+          </p:txBody>
+        </p:sp>
+      </p:grpSp>
+      <p:sp>
+        <p:nvSpPr>
+          <p:cNvPr id="4" name="AutoShape 10" descr="Bildergebnis für netflix"/>
+          <p:cNvSpPr>
+            <a:spLocks noChangeAspect="1" noChangeArrowheads="1"/>
+          </p:cNvSpPr>
+          <p:nvPr/>
+        </p:nvSpPr>
+        <p:spPr bwMode="auto">
+          <a:xfrm>
+            <a:off x="2125949" y="-455427"/>
+            <a:ext cx="1916867" cy="1434104"/>
+          </a:xfrm>
+          <a:prstGeom prst="rect">
+            <a:avLst/>
+          </a:prstGeom>
+          <a:noFill/>
+          <a:extLst>
+            <a:ext uri="{909E8E84-426E-40DD-AFC4-6F175D3DCCD1}">
+              <a14:hiddenFill xmlns:a14="http://schemas.microsoft.com/office/drawing/2010/main">
+                <a:solidFill>
+                  <a:srgbClr val="FFFFFF"/>
+                </a:solidFill>
+              </a14:hiddenFill>
+            </a:ext>
+          </a:extLst>
+        </p:spPr>
+        <p:txBody>
+          <a:bodyPr vert="horz" wrap="square" lIns="90405" tIns="45226" rIns="90405" bIns="45226" numCol="1" anchor="t" anchorCtr="0" compatLnSpc="1">
+            <a:prstTxWarp prst="textNoShape">
+              <a:avLst/>
+            </a:prstTxWarp>
+          </a:bodyPr>
+          <a:lstStyle/>
+          <a:p>
+            <a:endParaRPr lang="en-US">
+              <a:latin typeface="Arial"/>
+            </a:endParaRPr>
+          </a:p>
+        </p:txBody>
+      </p:sp>
+      <p:sp>
+        <p:nvSpPr>
+          <p:cNvPr id="5" name="AutoShape 5" descr="Bildergebnis für köln"/>
+          <p:cNvSpPr>
+            <a:spLocks noChangeAspect="1" noChangeArrowheads="1"/>
+          </p:cNvSpPr>
+          <p:nvPr/>
+        </p:nvSpPr>
+        <p:spPr bwMode="auto">
+          <a:xfrm>
+            <a:off x="208932" y="-143596"/>
+            <a:ext cx="406224" cy="303917"/>
+          </a:xfrm>
+          <a:prstGeom prst="rect">
+            <a:avLst/>
+          </a:prstGeom>
+          <a:noFill/>
+          <a:extLst>
+            <a:ext uri="{909E8E84-426E-40DD-AFC4-6F175D3DCCD1}">
+              <a14:hiddenFill xmlns:a14="http://schemas.microsoft.com/office/drawing/2010/main">
+                <a:solidFill>
+                  <a:srgbClr val="FFFFFF"/>
+                </a:solidFill>
+              </a14:hiddenFill>
+            </a:ext>
+          </a:extLst>
+        </p:spPr>
+        <p:txBody>
+          <a:bodyPr vert="horz" wrap="square" lIns="91428" tIns="45714" rIns="91428" bIns="45714" numCol="1" anchor="t" anchorCtr="0" compatLnSpc="1">
+            <a:prstTxWarp prst="textNoShape">
+              <a:avLst/>
+            </a:prstTxWarp>
+          </a:bodyPr>
+          <a:lstStyle/>
+          <a:p>
+            <a:endParaRPr lang="en-US">
+              <a:latin typeface="Arial"/>
+            </a:endParaRPr>
+          </a:p>
+        </p:txBody>
+      </p:sp>
+      <p:sp>
+        <p:nvSpPr>
+          <p:cNvPr id="9" name="AutoShape 7" descr="Bildergebnis für köln"/>
+          <p:cNvSpPr>
+            <a:spLocks noChangeAspect="1" noChangeArrowheads="1"/>
+          </p:cNvSpPr>
+          <p:nvPr/>
+        </p:nvSpPr>
+        <p:spPr bwMode="auto">
+          <a:xfrm>
+            <a:off x="412044" y="8363"/>
+            <a:ext cx="406224" cy="303917"/>
+          </a:xfrm>
+          <a:prstGeom prst="rect">
+            <a:avLst/>
+          </a:prstGeom>
+          <a:noFill/>
+          <a:extLst>
+            <a:ext uri="{909E8E84-426E-40DD-AFC4-6F175D3DCCD1}">
+              <a14:hiddenFill xmlns:a14="http://schemas.microsoft.com/office/drawing/2010/main">
+                <a:solidFill>
+                  <a:srgbClr val="FFFFFF"/>
+                </a:solidFill>
+              </a14:hiddenFill>
+            </a:ext>
+          </a:extLst>
+        </p:spPr>
+        <p:txBody>
+          <a:bodyPr vert="horz" wrap="square" lIns="91428" tIns="45714" rIns="91428" bIns="45714" numCol="1" anchor="t" anchorCtr="0" compatLnSpc="1">
+            <a:prstTxWarp prst="textNoShape">
+              <a:avLst/>
+            </a:prstTxWarp>
+          </a:bodyPr>
+          <a:lstStyle/>
+          <a:p>
+            <a:endParaRPr lang="en-US">
+              <a:latin typeface="Arial"/>
+            </a:endParaRPr>
+          </a:p>
+        </p:txBody>
+      </p:sp>
+      <p:sp>
+        <p:nvSpPr>
+          <p:cNvPr id="13" name="AutoShape 11" descr="Bildergebnis für Borussia Dortmund"/>
+          <p:cNvSpPr>
+            <a:spLocks noChangeAspect="1" noChangeArrowheads="1"/>
+          </p:cNvSpPr>
+          <p:nvPr/>
+        </p:nvSpPr>
+        <p:spPr bwMode="auto">
+          <a:xfrm>
+            <a:off x="615156" y="160321"/>
+            <a:ext cx="406224" cy="303917"/>
+          </a:xfrm>
+          <a:prstGeom prst="rect">
+            <a:avLst/>
+          </a:prstGeom>
+          <a:noFill/>
+          <a:extLst>
+            <a:ext uri="{909E8E84-426E-40DD-AFC4-6F175D3DCCD1}">
+              <a14:hiddenFill xmlns:a14="http://schemas.microsoft.com/office/drawing/2010/main">
+                <a:solidFill>
+                  <a:srgbClr val="FFFFFF"/>
+                </a:solidFill>
+              </a14:hiddenFill>
+            </a:ext>
+          </a:extLst>
+        </p:spPr>
+        <p:txBody>
+          <a:bodyPr vert="horz" wrap="square" lIns="91428" tIns="45714" rIns="91428" bIns="45714" numCol="1" anchor="t" anchorCtr="0" compatLnSpc="1">
+            <a:prstTxWarp prst="textNoShape">
+              <a:avLst/>
+            </a:prstTxWarp>
+          </a:bodyPr>
+          <a:lstStyle/>
+          <a:p>
+            <a:endParaRPr lang="en-US">
+              <a:latin typeface="Arial"/>
+            </a:endParaRPr>
+          </a:p>
+        </p:txBody>
+      </p:sp>
+      <p:sp>
+        <p:nvSpPr>
+          <p:cNvPr id="14" name="AutoShape 15" descr="Bildergebnis für Borussia Dortmund"/>
+          <p:cNvSpPr>
+            <a:spLocks noChangeAspect="1" noChangeArrowheads="1"/>
+          </p:cNvSpPr>
+          <p:nvPr/>
+        </p:nvSpPr>
+        <p:spPr bwMode="auto">
+          <a:xfrm>
+            <a:off x="818268" y="312280"/>
+            <a:ext cx="406224" cy="303917"/>
+          </a:xfrm>
+          <a:prstGeom prst="rect">
+            <a:avLst/>
+          </a:prstGeom>
+          <a:noFill/>
+          <a:extLst>
+            <a:ext uri="{909E8E84-426E-40DD-AFC4-6F175D3DCCD1}">
+              <a14:hiddenFill xmlns:a14="http://schemas.microsoft.com/office/drawing/2010/main">
+                <a:solidFill>
+                  <a:srgbClr val="FFFFFF"/>
+                </a:solidFill>
+              </a14:hiddenFill>
+            </a:ext>
+          </a:extLst>
+        </p:spPr>
+        <p:txBody>
+          <a:bodyPr vert="horz" wrap="square" lIns="91428" tIns="45714" rIns="91428" bIns="45714" numCol="1" anchor="t" anchorCtr="0" compatLnSpc="1">
+            <a:prstTxWarp prst="textNoShape">
+              <a:avLst/>
+            </a:prstTxWarp>
+          </a:bodyPr>
+          <a:lstStyle/>
+          <a:p>
+            <a:endParaRPr lang="en-US">
+              <a:latin typeface="Arial"/>
+            </a:endParaRPr>
+          </a:p>
+        </p:txBody>
+      </p:sp>
+      <p:sp>
+        <p:nvSpPr>
+          <p:cNvPr id="15" name="AutoShape 17" descr="Bildergebnis für Borussia Dortmund"/>
+          <p:cNvSpPr>
+            <a:spLocks noChangeAspect="1" noChangeArrowheads="1"/>
+          </p:cNvSpPr>
+          <p:nvPr/>
+        </p:nvSpPr>
+        <p:spPr bwMode="auto">
+          <a:xfrm>
+            <a:off x="1021379" y="464238"/>
+            <a:ext cx="406224" cy="303917"/>
+          </a:xfrm>
+          <a:prstGeom prst="rect">
+            <a:avLst/>
+          </a:prstGeom>
+          <a:noFill/>
+          <a:extLst>
+            <a:ext uri="{909E8E84-426E-40DD-AFC4-6F175D3DCCD1}">
+              <a14:hiddenFill xmlns:a14="http://schemas.microsoft.com/office/drawing/2010/main">
+                <a:solidFill>
+                  <a:srgbClr val="FFFFFF"/>
+                </a:solidFill>
+              </a14:hiddenFill>
+            </a:ext>
+          </a:extLst>
+        </p:spPr>
+        <p:txBody>
+          <a:bodyPr vert="horz" wrap="square" lIns="91428" tIns="45714" rIns="91428" bIns="45714" numCol="1" anchor="t" anchorCtr="0" compatLnSpc="1">
+            <a:prstTxWarp prst="textNoShape">
+              <a:avLst/>
+            </a:prstTxWarp>
+          </a:bodyPr>
+          <a:lstStyle/>
+          <a:p>
+            <a:endParaRPr lang="en-US">
+              <a:latin typeface="Arial"/>
+            </a:endParaRPr>
+          </a:p>
+        </p:txBody>
+      </p:sp>
+      <p:sp>
+        <p:nvSpPr>
+          <p:cNvPr id="36" name="Rectangle 55"/>
+          <p:cNvSpPr>
+            <a:spLocks noChangeArrowheads="1"/>
+          </p:cNvSpPr>
+          <p:nvPr/>
+        </p:nvSpPr>
+        <p:spPr bwMode="gray">
+          <a:xfrm rot="21241164">
+            <a:off x="931616" y="1555571"/>
+            <a:ext cx="2617871" cy="2033959"/>
+          </a:xfrm>
+          <a:prstGeom prst="rect">
+            <a:avLst/>
+          </a:prstGeom>
+          <a:solidFill>
+            <a:srgbClr val="10384F"/>
+          </a:solidFill>
+          <a:ln>
+            <a:noFill/>
+          </a:ln>
+          <a:extLst>
+            <a:ext uri="{91240B29-F687-4F45-9708-019B960494DF}">
+              <a14:hiddenLine xmlns:a14="http://schemas.microsoft.com/office/drawing/2010/main" w="19050">
+                <a:solidFill>
+                  <a:srgbClr val="000000"/>
+                </a:solidFill>
+                <a:miter lim="800000"/>
+                <a:headEnd/>
+                <a:tailEnd/>
+              </a14:hiddenLine>
+            </a:ext>
+          </a:extLst>
+        </p:spPr>
+        <p:txBody>
+          <a:bodyPr wrap="none" lIns="92347" tIns="46192" rIns="92347" bIns="46192" anchor="ctr"/>
+          <a:lstStyle/>
+          <a:p>
+            <a:pPr defTabSz="905235"/>
+            <a:endParaRPr lang="en-US" sz="1300" dirty="0">
+              <a:solidFill>
+                <a:srgbClr val="676767"/>
+              </a:solidFill>
+              <a:latin typeface="Arial"/>
+              <a:cs typeface="Arial" charset="0"/>
+            </a:endParaRPr>
+          </a:p>
+        </p:txBody>
+      </p:sp>
+      <p:sp>
+        <p:nvSpPr>
+          <p:cNvPr id="40" name="Rectangle 50"/>
+          <p:cNvSpPr>
+            <a:spLocks noChangeArrowheads="1"/>
+          </p:cNvSpPr>
+          <p:nvPr/>
+        </p:nvSpPr>
+        <p:spPr bwMode="gray">
+          <a:xfrm rot="21241164">
+            <a:off x="959889" y="3794569"/>
+            <a:ext cx="2656518" cy="2578752"/>
+          </a:xfrm>
+          <a:prstGeom prst="rect">
+            <a:avLst/>
+          </a:prstGeom>
+          <a:solidFill>
+            <a:srgbClr val="10384F"/>
+          </a:solidFill>
+          <a:ln>
+            <a:noFill/>
+          </a:ln>
+        </p:spPr>
+        <p:txBody>
+          <a:bodyPr wrap="none" lIns="92347" tIns="46192" rIns="92347" bIns="46192" anchor="ctr"/>
+          <a:lstStyle/>
+          <a:p>
+            <a:pPr defTabSz="905235"/>
+            <a:endParaRPr lang="en-US" sz="1300" dirty="0">
+              <a:latin typeface="Arial"/>
+              <a:cs typeface="Arial" charset="0"/>
+            </a:endParaRPr>
+          </a:p>
+        </p:txBody>
+      </p:sp>
+      <p:sp>
+        <p:nvSpPr>
+          <p:cNvPr id="69" name="Rectangle 50"/>
+          <p:cNvSpPr>
+            <a:spLocks noChangeArrowheads="1"/>
+          </p:cNvSpPr>
+          <p:nvPr/>
+        </p:nvSpPr>
+        <p:spPr bwMode="gray">
+          <a:xfrm rot="21241164">
+            <a:off x="9395522" y="4135153"/>
+            <a:ext cx="2241496" cy="2198707"/>
+          </a:xfrm>
+          <a:prstGeom prst="rect">
+            <a:avLst/>
+          </a:prstGeom>
+          <a:solidFill>
+            <a:srgbClr val="10384F"/>
+          </a:solidFill>
+          <a:ln>
+            <a:noFill/>
+          </a:ln>
+        </p:spPr>
+        <p:txBody>
+          <a:bodyPr wrap="none" lIns="92347" tIns="46192" rIns="92347" bIns="46192" anchor="ctr"/>
+          <a:lstStyle/>
+          <a:p>
+            <a:pPr defTabSz="905235"/>
+            <a:endParaRPr lang="en-US" sz="1300" dirty="0">
+              <a:latin typeface="Arial"/>
+              <a:cs typeface="Arial" charset="0"/>
+            </a:endParaRPr>
+          </a:p>
+        </p:txBody>
+      </p:sp>
+      <p:sp>
+        <p:nvSpPr>
+          <p:cNvPr id="632" name="Title 5"/>
+          <p:cNvSpPr txBox="1">
+            <a:spLocks/>
+          </p:cNvSpPr>
+          <p:nvPr/>
+        </p:nvSpPr>
+        <p:spPr bwMode="gray">
+          <a:xfrm>
+            <a:off x="983281" y="182361"/>
+            <a:ext cx="10797054" cy="863888"/>
+          </a:xfrm>
+          <a:prstGeom prst="rect">
+            <a:avLst/>
+          </a:prstGeom>
+        </p:spPr>
+        <p:txBody>
+          <a:bodyPr vert="horz" lIns="0" tIns="0" rIns="0" bIns="0" rtlCol="0" anchor="b">
+            <a:noAutofit/>
+          </a:bodyPr>
+          <a:lstStyle>
+            <a:lvl1pPr algn="l" defTabSz="914400" rtl="0" eaLnBrk="1" latinLnBrk="0" hangingPunct="1">
+              <a:spcBef>
+                <a:spcPct val="0"/>
+              </a:spcBef>
+              <a:buNone/>
+              <a:defRPr sz="2800" kern="1200">
+                <a:solidFill>
+                  <a:srgbClr val="10384F"/>
+                </a:solidFill>
+                <a:latin typeface="Arial"/>
+                <a:ea typeface="+mj-ea"/>
+                <a:cs typeface="+mj-cs"/>
+              </a:defRPr>
+            </a:lvl1pPr>
+          </a:lstStyle>
+          <a:p>
+            <a:r>
+              <a:rPr lang="en-US" b="1" dirty="0">
+                <a:latin typeface="Arial"/>
+              </a:rPr>
+              <a:t>Vitor Passos</a:t>
+            </a:r>
+          </a:p>
+        </p:txBody>
+      </p:sp>
+      <p:sp>
+        <p:nvSpPr>
+          <p:cNvPr id="633" name="BC-Subtitle"/>
+          <p:cNvSpPr txBox="1"/>
+          <p:nvPr/>
+        </p:nvSpPr>
+        <p:spPr bwMode="gray">
+          <a:xfrm>
+            <a:off x="984262" y="1138598"/>
+            <a:ext cx="10796074" cy="251968"/>
+          </a:xfrm>
+          <a:prstGeom prst="rect">
+            <a:avLst/>
+          </a:prstGeom>
+          <a:noFill/>
+          <a:ln w="6350" cap="flat" cmpd="sng" algn="ctr">
+            <a:noFill/>
+            <a:prstDash val="solid"/>
+            <a:round/>
+            <a:headEnd type="none" w="med" len="med"/>
+            <a:tailEnd type="none" w="med" len="med"/>
+          </a:ln>
+          <a:extLst>
+            <a:ext uri="{909E8E84-426E-40DD-AFC4-6F175D3DCCD1}">
+              <a14:hiddenFill xmlns:a14="http://schemas.microsoft.com/office/drawing/2010/main">
+                <a:solidFill>
+                  <a:srgbClr val="FFFFFF"/>
+                </a:solidFill>
+              </a14:hiddenFill>
+            </a:ext>
+            <a:ext uri="{91240B29-F687-4F45-9708-019B960494DF}">
+              <a14:hiddenLine xmlns:a14="http://schemas.microsoft.com/office/drawing/2010/main" w="6350" cap="flat" cmpd="sng" algn="ctr">
+                <a:solidFill>
+                  <a:srgbClr val="10384F"/>
+                </a:solidFill>
+                <a:prstDash val="solid"/>
+                <a:round/>
+                <a:headEnd type="none" w="med" len="med"/>
+                <a:tailEnd type="none" w="med" len="med"/>
+              </a14:hiddenLine>
+            </a:ext>
+          </a:extLst>
+        </p:spPr>
+        <p:txBody>
+          <a:bodyPr vert="horz" wrap="square" lIns="0" tIns="0" rIns="0" bIns="0" rtlCol="0" anchor="t" anchorCtr="0">
+            <a:noAutofit/>
+          </a:bodyPr>
+          <a:lstStyle/>
+          <a:p>
+            <a:r>
+              <a:rPr lang="en-US" dirty="0">
+                <a:latin typeface="Arial"/>
+              </a:rPr>
+              <a:t>Product Design Scientist</a:t>
+            </a:r>
+          </a:p>
+        </p:txBody>
+      </p:sp>
+      <p:sp>
+        <p:nvSpPr>
+          <p:cNvPr id="64" name="Rectangle 50"/>
+          <p:cNvSpPr>
+            <a:spLocks noChangeArrowheads="1"/>
+          </p:cNvSpPr>
+          <p:nvPr/>
+        </p:nvSpPr>
+        <p:spPr bwMode="gray">
+          <a:xfrm rot="21241164">
+            <a:off x="6693070" y="4135556"/>
+            <a:ext cx="2241496" cy="2050783"/>
+          </a:xfrm>
+          <a:prstGeom prst="rect">
+            <a:avLst/>
+          </a:prstGeom>
+          <a:solidFill>
+            <a:srgbClr val="10384F"/>
+          </a:solidFill>
+          <a:ln>
+            <a:noFill/>
+          </a:ln>
+        </p:spPr>
+        <p:txBody>
+          <a:bodyPr wrap="none" lIns="92347" tIns="46192" rIns="92347" bIns="46192" anchor="ctr"/>
+          <a:lstStyle/>
+          <a:p>
+            <a:pPr defTabSz="905235"/>
+            <a:endParaRPr lang="en-US" sz="1300" dirty="0">
+              <a:latin typeface="Arial"/>
+              <a:cs typeface="Arial" charset="0"/>
+            </a:endParaRPr>
+          </a:p>
+        </p:txBody>
+      </p:sp>
+      <p:sp>
+        <p:nvSpPr>
+          <p:cNvPr id="38" name="Rectangle 31">
+            <a:extLst>
+              <a:ext uri="{FF2B5EF4-FFF2-40B4-BE49-F238E27FC236}">
+                <a16:creationId xmlns:a16="http://schemas.microsoft.com/office/drawing/2014/main" id="{3D91908D-67F6-482B-8BEB-0DC2DB69892B}"/>
+              </a:ext>
+            </a:extLst>
+          </p:cNvPr>
+          <p:cNvSpPr>
+            <a:spLocks noChangeArrowheads="1"/>
+          </p:cNvSpPr>
+          <p:nvPr/>
+        </p:nvSpPr>
+        <p:spPr bwMode="gray">
+          <a:xfrm>
+            <a:off x="764174" y="6618171"/>
+            <a:ext cx="2247821" cy="180026"/>
+          </a:xfrm>
+          <a:prstGeom prst="rect">
+            <a:avLst/>
+          </a:prstGeom>
+          <a:noFill/>
+          <a:ln>
+            <a:noFill/>
+          </a:ln>
+          <a:extLst>
+            <a:ext uri="{909E8E84-426E-40DD-AFC4-6F175D3DCCD1}">
+              <a14:hiddenFill xmlns:a14="http://schemas.microsoft.com/office/drawing/2010/main">
+                <a:solidFill>
+                  <a:srgbClr val="FFFFFF"/>
+                </a:solidFill>
+              </a14:hiddenFill>
+            </a:ext>
+            <a:ext uri="{91240B29-F687-4F45-9708-019B960494DF}">
+              <a14:hiddenLine xmlns:a14="http://schemas.microsoft.com/office/drawing/2010/main" w="9525">
+                <a:solidFill>
+                  <a:srgbClr val="000000"/>
+                </a:solidFill>
+                <a:miter lim="800000"/>
+                <a:headEnd/>
+                <a:tailEnd/>
+              </a14:hiddenLine>
+            </a:ext>
+          </a:extLst>
+        </p:spPr>
+        <p:txBody>
+          <a:bodyPr wrap="square" lIns="0" tIns="0" rIns="0" bIns="0">
+            <a:spAutoFit/>
+          </a:bodyPr>
+          <a:lstStyle/>
+          <a:p>
+            <a:pPr algn="ctr" defTabSz="903479">
+              <a:lnSpc>
+                <a:spcPct val="90000"/>
+              </a:lnSpc>
+              <a:buClr>
+                <a:srgbClr val="000000"/>
+              </a:buClr>
+            </a:pPr>
+            <a:r>
+              <a:rPr lang="en-US" sz="1300" dirty="0">
+                <a:solidFill>
+                  <a:srgbClr val="10384F"/>
+                </a:solidFill>
+                <a:latin typeface="Arial"/>
+                <a:cs typeface="Arial" charset="0"/>
+              </a:rPr>
+              <a:t>My Family</a:t>
+            </a:r>
+          </a:p>
+        </p:txBody>
+      </p:sp>
+      <p:sp>
+        <p:nvSpPr>
+          <p:cNvPr id="46" name="Rectangle 31">
+            <a:extLst>
+              <a:ext uri="{FF2B5EF4-FFF2-40B4-BE49-F238E27FC236}">
+                <a16:creationId xmlns:a16="http://schemas.microsoft.com/office/drawing/2014/main" id="{0481E096-847D-4B3A-A3BF-4BA0BDA473F1}"/>
+              </a:ext>
+            </a:extLst>
+          </p:cNvPr>
+          <p:cNvSpPr>
+            <a:spLocks noChangeArrowheads="1"/>
+          </p:cNvSpPr>
+          <p:nvPr/>
+        </p:nvSpPr>
+        <p:spPr bwMode="gray">
+          <a:xfrm>
+            <a:off x="6721025" y="6618170"/>
+            <a:ext cx="2247820" cy="180026"/>
+          </a:xfrm>
+          <a:prstGeom prst="rect">
+            <a:avLst/>
+          </a:prstGeom>
+          <a:noFill/>
+          <a:ln>
+            <a:noFill/>
+          </a:ln>
+          <a:extLst>
+            <a:ext uri="{909E8E84-426E-40DD-AFC4-6F175D3DCCD1}">
+              <a14:hiddenFill xmlns:a14="http://schemas.microsoft.com/office/drawing/2010/main">
+                <a:solidFill>
+                  <a:srgbClr val="FFFFFF"/>
+                </a:solidFill>
+              </a14:hiddenFill>
+            </a:ext>
+            <a:ext uri="{91240B29-F687-4F45-9708-019B960494DF}">
+              <a14:hiddenLine xmlns:a14="http://schemas.microsoft.com/office/drawing/2010/main" w="9525">
+                <a:solidFill>
+                  <a:srgbClr val="000000"/>
+                </a:solidFill>
+                <a:miter lim="800000"/>
+                <a:headEnd/>
+                <a:tailEnd/>
+              </a14:hiddenLine>
+            </a:ext>
+          </a:extLst>
+        </p:spPr>
+        <p:txBody>
+          <a:bodyPr wrap="square" lIns="0" tIns="0" rIns="0" bIns="0">
+            <a:spAutoFit/>
+          </a:bodyPr>
+          <a:lstStyle/>
+          <a:p>
+            <a:pPr algn="ctr" defTabSz="903479">
+              <a:lnSpc>
+                <a:spcPct val="90000"/>
+              </a:lnSpc>
+              <a:buClr>
+                <a:srgbClr val="000000"/>
+              </a:buClr>
+            </a:pPr>
+            <a:r>
+              <a:rPr lang="en-US" sz="1300" dirty="0">
+                <a:solidFill>
+                  <a:srgbClr val="10384F"/>
+                </a:solidFill>
+                <a:latin typeface="Arial"/>
+                <a:cs typeface="Arial" charset="0"/>
+              </a:rPr>
+              <a:t>My Hobbies</a:t>
+            </a:r>
+          </a:p>
+        </p:txBody>
+      </p:sp>
+      <p:sp>
+        <p:nvSpPr>
+          <p:cNvPr id="32" name="Rectangle 31"/>
+          <p:cNvSpPr/>
+          <p:nvPr/>
+        </p:nvSpPr>
+        <p:spPr>
+          <a:xfrm>
+            <a:off x="1710883" y="5014771"/>
+            <a:ext cx="758541" cy="292388"/>
+          </a:xfrm>
+          <a:prstGeom prst="rect">
+            <a:avLst/>
+          </a:prstGeom>
+        </p:spPr>
+        <p:txBody>
+          <a:bodyPr wrap="none">
+            <a:spAutoFit/>
+          </a:bodyPr>
+          <a:lstStyle/>
+          <a:p>
+            <a:pPr marL="177782" lvl="1" indent="-177782" defTabSz="326857" fontAlgn="base">
+              <a:spcBef>
+                <a:spcPts val="300"/>
+              </a:spcBef>
+              <a:spcAft>
+                <a:spcPct val="0"/>
+              </a:spcAft>
+              <a:buClr>
+                <a:srgbClr val="005598"/>
+              </a:buClr>
+              <a:buSzPct val="85000"/>
+              <a:defRPr>
+                <a:latin typeface="Arial"/>
+              </a:defRPr>
+            </a:pPr>
+            <a:r>
+              <a:rPr lang="en-US" altLang="de-DE" sz="1300" i="1" kern="0" dirty="0">
+                <a:solidFill>
+                  <a:srgbClr val="10384F"/>
+                </a:solidFill>
+                <a:latin typeface="Arial"/>
+              </a:rPr>
+              <a:t>(picture)</a:t>
+            </a:r>
+          </a:p>
+        </p:txBody>
+      </p:sp>
+      <p:sp>
+        <p:nvSpPr>
+          <p:cNvPr id="50" name="Rectangle 31">
+            <a:extLst>
+              <a:ext uri="{FF2B5EF4-FFF2-40B4-BE49-F238E27FC236}">
+                <a16:creationId xmlns:a16="http://schemas.microsoft.com/office/drawing/2014/main" id="{3D91908D-67F6-482B-8BEB-0DC2DB69892B}"/>
+              </a:ext>
+            </a:extLst>
+          </p:cNvPr>
+          <p:cNvSpPr>
+            <a:spLocks noChangeArrowheads="1"/>
+          </p:cNvSpPr>
+          <p:nvPr/>
+        </p:nvSpPr>
+        <p:spPr bwMode="gray">
+          <a:xfrm>
+            <a:off x="3994035" y="6618488"/>
+            <a:ext cx="2247821" cy="180026"/>
+          </a:xfrm>
+          <a:prstGeom prst="rect">
+            <a:avLst/>
+          </a:prstGeom>
+          <a:noFill/>
+          <a:ln>
+            <a:noFill/>
+          </a:ln>
+          <a:extLst>
+            <a:ext uri="{909E8E84-426E-40DD-AFC4-6F175D3DCCD1}">
+              <a14:hiddenFill xmlns:a14="http://schemas.microsoft.com/office/drawing/2010/main">
+                <a:solidFill>
+                  <a:srgbClr val="FFFFFF"/>
+                </a:solidFill>
+              </a14:hiddenFill>
+            </a:ext>
+            <a:ext uri="{91240B29-F687-4F45-9708-019B960494DF}">
+              <a14:hiddenLine xmlns:a14="http://schemas.microsoft.com/office/drawing/2010/main" w="9525">
+                <a:solidFill>
+                  <a:srgbClr val="000000"/>
+                </a:solidFill>
+                <a:miter lim="800000"/>
+                <a:headEnd/>
+                <a:tailEnd/>
+              </a14:hiddenLine>
+            </a:ext>
+          </a:extLst>
+        </p:spPr>
+        <p:txBody>
+          <a:bodyPr wrap="square" lIns="0" tIns="0" rIns="0" bIns="0">
+            <a:spAutoFit/>
+          </a:bodyPr>
+          <a:lstStyle/>
+          <a:p>
+            <a:pPr algn="ctr" defTabSz="903479">
+              <a:lnSpc>
+                <a:spcPct val="90000"/>
+              </a:lnSpc>
+              <a:buClr>
+                <a:srgbClr val="000000"/>
+              </a:buClr>
+            </a:pPr>
+            <a:r>
+              <a:rPr lang="en-US" sz="1300" dirty="0">
+                <a:solidFill>
+                  <a:srgbClr val="10384F"/>
+                </a:solidFill>
+                <a:latin typeface="Arial"/>
+                <a:cs typeface="Arial" charset="0"/>
+              </a:rPr>
+              <a:t>My Travels</a:t>
+            </a:r>
+          </a:p>
+        </p:txBody>
+      </p:sp>
+      <p:sp>
+        <p:nvSpPr>
+          <p:cNvPr id="51" name="Rectangle 31">
+            <a:extLst>
+              <a:ext uri="{FF2B5EF4-FFF2-40B4-BE49-F238E27FC236}">
+                <a16:creationId xmlns:a16="http://schemas.microsoft.com/office/drawing/2014/main" id="{3D91908D-67F6-482B-8BEB-0DC2DB69892B}"/>
+              </a:ext>
+            </a:extLst>
+          </p:cNvPr>
+          <p:cNvSpPr>
+            <a:spLocks noChangeArrowheads="1"/>
+          </p:cNvSpPr>
+          <p:nvPr/>
+        </p:nvSpPr>
+        <p:spPr bwMode="gray">
+          <a:xfrm>
+            <a:off x="9400000" y="6614976"/>
+            <a:ext cx="1357935" cy="180026"/>
+          </a:xfrm>
+          <a:prstGeom prst="rect">
+            <a:avLst/>
+          </a:prstGeom>
+          <a:noFill/>
+          <a:ln>
+            <a:noFill/>
+          </a:ln>
+          <a:extLst>
+            <a:ext uri="{909E8E84-426E-40DD-AFC4-6F175D3DCCD1}">
+              <a14:hiddenFill xmlns:a14="http://schemas.microsoft.com/office/drawing/2010/main">
+                <a:solidFill>
+                  <a:srgbClr val="FFFFFF"/>
+                </a:solidFill>
+              </a14:hiddenFill>
+            </a:ext>
+            <a:ext uri="{91240B29-F687-4F45-9708-019B960494DF}">
+              <a14:hiddenLine xmlns:a14="http://schemas.microsoft.com/office/drawing/2010/main" w="9525">
+                <a:solidFill>
+                  <a:srgbClr val="000000"/>
+                </a:solidFill>
+                <a:miter lim="800000"/>
+                <a:headEnd/>
+                <a:tailEnd/>
+              </a14:hiddenLine>
+            </a:ext>
+          </a:extLst>
+        </p:spPr>
+        <p:txBody>
+          <a:bodyPr wrap="square" lIns="0" tIns="0" rIns="0" bIns="0">
+            <a:spAutoFit/>
+          </a:bodyPr>
+          <a:lstStyle/>
+          <a:p>
+            <a:pPr algn="ctr" defTabSz="903479">
+              <a:lnSpc>
+                <a:spcPct val="90000"/>
+              </a:lnSpc>
+              <a:buClr>
+                <a:srgbClr val="000000"/>
+              </a:buClr>
+            </a:pPr>
+            <a:r>
+              <a:rPr lang="en-US" sz="1300" dirty="0">
+                <a:solidFill>
+                  <a:srgbClr val="10384F"/>
+                </a:solidFill>
+                <a:latin typeface="Arial"/>
+                <a:cs typeface="Arial" charset="0"/>
+              </a:rPr>
+              <a:t>My Competencies</a:t>
+            </a:r>
+          </a:p>
+        </p:txBody>
+      </p:sp>
+      <p:sp>
+        <p:nvSpPr>
+          <p:cNvPr id="10" name="TextBox 9">
+            <a:extLst>
+              <a:ext uri="{FF2B5EF4-FFF2-40B4-BE49-F238E27FC236}">
+                <a16:creationId xmlns:a16="http://schemas.microsoft.com/office/drawing/2014/main" id="{40F50B73-D022-8144-9FF7-2ACA5E86E108}"/>
+              </a:ext>
+            </a:extLst>
+          </p:cNvPr>
+          <p:cNvSpPr txBox="1"/>
+          <p:nvPr/>
+        </p:nvSpPr>
+        <p:spPr bwMode="gray">
+          <a:xfrm>
+            <a:off x="8801989" y="1503270"/>
+            <a:ext cx="2970488" cy="268988"/>
+          </a:xfrm>
+          <a:prstGeom prst="rect">
+            <a:avLst/>
+          </a:prstGeom>
+          <a:noFill/>
+        </p:spPr>
+        <p:txBody>
+          <a:bodyPr wrap="square" lIns="71991" tIns="0" rIns="71991" bIns="0" rtlCol="0">
+            <a:noAutofit/>
+          </a:bodyPr>
+          <a:lstStyle/>
+          <a:p>
+            <a:pPr>
+              <a:spcAft>
+                <a:spcPts val="600"/>
+              </a:spcAft>
+              <a:buClr>
+                <a:srgbClr val="005598"/>
+              </a:buClr>
+              <a:buSzPct val="85000"/>
+            </a:pPr>
+            <a:r>
+              <a:rPr lang="en-US" sz="1600" b="1" dirty="0">
+                <a:solidFill>
+                  <a:srgbClr val="10384F"/>
+                </a:solidFill>
+                <a:latin typeface="Arial"/>
+              </a:rPr>
+              <a:t>Education:</a:t>
+            </a:r>
+          </a:p>
+        </p:txBody>
+      </p:sp>
+      <p:sp>
+        <p:nvSpPr>
+          <p:cNvPr id="48" name="TextBox 47">
+            <a:extLst>
+              <a:ext uri="{FF2B5EF4-FFF2-40B4-BE49-F238E27FC236}">
+                <a16:creationId xmlns:a16="http://schemas.microsoft.com/office/drawing/2014/main" id="{481A5722-B28E-6849-BE27-25B9A9F30EFB}"/>
+              </a:ext>
+            </a:extLst>
+          </p:cNvPr>
+          <p:cNvSpPr txBox="1"/>
+          <p:nvPr/>
+        </p:nvSpPr>
+        <p:spPr bwMode="gray">
+          <a:xfrm>
+            <a:off x="4125661" y="1503270"/>
+            <a:ext cx="3674208" cy="251560"/>
+          </a:xfrm>
+          <a:prstGeom prst="rect">
+            <a:avLst/>
+          </a:prstGeom>
+          <a:noFill/>
+        </p:spPr>
+        <p:txBody>
+          <a:bodyPr wrap="square" lIns="71991" tIns="0" rIns="71991" bIns="0" rtlCol="0">
+            <a:noAutofit/>
+          </a:bodyPr>
+          <a:lstStyle/>
+          <a:p>
+            <a:pPr>
+              <a:buClr>
+                <a:srgbClr val="005598"/>
+              </a:buClr>
+              <a:buSzPct val="85000"/>
+            </a:pPr>
+            <a:r>
+              <a:rPr lang="en-US" sz="1600" b="1" dirty="0">
+                <a:solidFill>
+                  <a:srgbClr val="10384F"/>
+                </a:solidFill>
+                <a:latin typeface="Arial"/>
+              </a:rPr>
+              <a:t>Professional Experience:</a:t>
+            </a:r>
+          </a:p>
+        </p:txBody>
+      </p:sp>
+      <p:sp>
+        <p:nvSpPr>
+          <p:cNvPr id="81" name="Rectangle 80">
+            <a:extLst>
+              <a:ext uri="{FF2B5EF4-FFF2-40B4-BE49-F238E27FC236}">
+                <a16:creationId xmlns:a16="http://schemas.microsoft.com/office/drawing/2014/main" id="{7E243E40-C569-2E42-83A9-B6A1C1BB410A}"/>
+              </a:ext>
+            </a:extLst>
+          </p:cNvPr>
+          <p:cNvSpPr/>
+          <p:nvPr/>
+        </p:nvSpPr>
+        <p:spPr>
+          <a:xfrm>
+            <a:off x="4099686" y="1775712"/>
+            <a:ext cx="4660611" cy="1600438"/>
+          </a:xfrm>
+          <a:prstGeom prst="rect">
+            <a:avLst/>
+          </a:prstGeom>
+        </p:spPr>
+        <p:txBody>
+          <a:bodyPr wrap="square">
+            <a:spAutoFit/>
+          </a:bodyPr>
+          <a:lstStyle/>
+          <a:p>
+            <a:pPr>
+              <a:spcAft>
+                <a:spcPts val="600"/>
+              </a:spcAft>
+              <a:buClr>
+                <a:srgbClr val="005598"/>
+              </a:buClr>
+              <a:buSzPct val="85000"/>
+            </a:pPr>
+            <a:r>
+              <a:rPr lang="en-US" sz="1600" dirty="0">
+                <a:solidFill>
+                  <a:srgbClr val="10384F"/>
+                </a:solidFill>
+                <a:latin typeface="Arial"/>
+                <a:cs typeface="Arial" charset="0"/>
+              </a:rPr>
+              <a:t>2018 – Visiting Scholar at University of Florida</a:t>
+            </a:r>
+          </a:p>
+          <a:p>
+            <a:pPr>
+              <a:spcAft>
+                <a:spcPts val="600"/>
+              </a:spcAft>
+              <a:buClr>
+                <a:srgbClr val="005598"/>
+              </a:buClr>
+              <a:buSzPct val="85000"/>
+            </a:pPr>
+            <a:r>
+              <a:rPr lang="en-US" sz="1600" dirty="0">
+                <a:solidFill>
+                  <a:srgbClr val="10384F"/>
+                </a:solidFill>
+                <a:latin typeface="Arial"/>
+                <a:cs typeface="Arial" charset="0"/>
+              </a:rPr>
+              <a:t>2019 – Senior Research in Eucalyptus Breeder;</a:t>
+            </a:r>
+          </a:p>
+          <a:p>
+            <a:pPr>
+              <a:spcAft>
+                <a:spcPts val="600"/>
+              </a:spcAft>
+              <a:buClr>
+                <a:srgbClr val="005598"/>
+              </a:buClr>
+              <a:buSzPct val="85000"/>
+            </a:pPr>
+            <a:r>
+              <a:rPr lang="en-US" sz="1600" dirty="0">
+                <a:solidFill>
+                  <a:srgbClr val="10384F"/>
+                </a:solidFill>
+                <a:latin typeface="Arial"/>
+                <a:cs typeface="Arial" charset="0"/>
+              </a:rPr>
+              <a:t>2023 – Expert in Eucalyptus and Acacia Breeder;</a:t>
+            </a:r>
+          </a:p>
+          <a:p>
+            <a:pPr>
+              <a:spcAft>
+                <a:spcPts val="600"/>
+              </a:spcAft>
+              <a:buClr>
+                <a:srgbClr val="005598"/>
+              </a:buClr>
+              <a:buSzPct val="85000"/>
+            </a:pPr>
+            <a:r>
+              <a:rPr lang="en-US" sz="1600" dirty="0">
+                <a:solidFill>
+                  <a:srgbClr val="10384F"/>
+                </a:solidFill>
+                <a:latin typeface="Arial"/>
+                <a:cs typeface="Arial" charset="0"/>
+              </a:rPr>
+              <a:t>2025 – Eucalyptus Breeding Coordinator</a:t>
+            </a:r>
+          </a:p>
+          <a:p>
+            <a:pPr>
+              <a:buClr>
+                <a:srgbClr val="005598"/>
+              </a:buClr>
+              <a:buSzPct val="85000"/>
+            </a:pPr>
+            <a:endParaRPr lang="en-US" sz="1400" dirty="0">
+              <a:solidFill>
+                <a:srgbClr val="10384F"/>
+              </a:solidFill>
+              <a:latin typeface="Arial"/>
+              <a:cs typeface="Arial" charset="0"/>
+            </a:endParaRPr>
+          </a:p>
+        </p:txBody>
+      </p:sp>
+      <p:sp>
+        <p:nvSpPr>
+          <p:cNvPr id="75" name="Rectangle 50">
+            <a:extLst>
+              <a:ext uri="{FF2B5EF4-FFF2-40B4-BE49-F238E27FC236}">
+                <a16:creationId xmlns:a16="http://schemas.microsoft.com/office/drawing/2014/main" id="{0EA80126-61E0-4C07-B581-D112CB32A489}"/>
+              </a:ext>
+            </a:extLst>
+          </p:cNvPr>
+          <p:cNvSpPr>
+            <a:spLocks noChangeArrowheads="1"/>
+          </p:cNvSpPr>
+          <p:nvPr/>
+        </p:nvSpPr>
+        <p:spPr bwMode="gray">
+          <a:xfrm rot="21241164">
+            <a:off x="3943538" y="3814364"/>
+            <a:ext cx="2348819" cy="2444120"/>
+          </a:xfrm>
+          <a:prstGeom prst="rect">
+            <a:avLst/>
+          </a:prstGeom>
+          <a:solidFill>
+            <a:srgbClr val="10384F"/>
+          </a:solidFill>
+          <a:ln>
+            <a:noFill/>
+          </a:ln>
+        </p:spPr>
+        <p:txBody>
+          <a:bodyPr wrap="none" lIns="92347" tIns="46192" rIns="92347" bIns="46192" anchor="ctr"/>
+          <a:lstStyle/>
+          <a:p>
+            <a:pPr defTabSz="905235"/>
+            <a:endParaRPr lang="en-US" sz="1300" dirty="0">
+              <a:latin typeface="Arial"/>
+              <a:cs typeface="Arial" charset="0"/>
+            </a:endParaRPr>
+          </a:p>
+        </p:txBody>
+      </p:sp>
+      <p:sp>
+        <p:nvSpPr>
+          <p:cNvPr id="31" name="Rectangle 30">
+            <a:extLst>
+              <a:ext uri="{FF2B5EF4-FFF2-40B4-BE49-F238E27FC236}">
+                <a16:creationId xmlns:a16="http://schemas.microsoft.com/office/drawing/2014/main" id="{0779C770-F96A-4585-9DA8-D1D63EB1B4E9}"/>
+              </a:ext>
+            </a:extLst>
+          </p:cNvPr>
+          <p:cNvSpPr/>
+          <p:nvPr/>
+        </p:nvSpPr>
+        <p:spPr>
+          <a:xfrm>
+            <a:off x="9346314" y="4463842"/>
+            <a:ext cx="2289781" cy="1754326"/>
+          </a:xfrm>
+          <a:prstGeom prst="rect">
+            <a:avLst/>
+          </a:prstGeom>
+        </p:spPr>
+        <p:txBody>
+          <a:bodyPr wrap="square">
+            <a:spAutoFit/>
+          </a:bodyPr>
+          <a:lstStyle/>
+          <a:p>
+            <a:pPr fontAlgn="base"/>
+            <a:r>
+              <a:rPr lang="en-US" sz="1200" b="1" dirty="0">
+                <a:solidFill>
+                  <a:srgbClr val="FFFFFF"/>
+                </a:solidFill>
+                <a:latin typeface="Calibri" panose="020F0502020204030204" pitchFamily="34" charset="0"/>
+              </a:rPr>
+              <a:t>Architect</a:t>
+            </a:r>
+          </a:p>
+          <a:p>
+            <a:pPr marL="171450" indent="-171450" fontAlgn="base">
+              <a:buFont typeface="Arial" panose="020B0604020202020204" pitchFamily="34" charset="0"/>
+              <a:buChar char="•"/>
+            </a:pPr>
+            <a:r>
+              <a:rPr lang="en-US" sz="1200" dirty="0">
+                <a:solidFill>
+                  <a:srgbClr val="FFFFFF"/>
+                </a:solidFill>
+                <a:latin typeface="Calibri" panose="020F0502020204030204" pitchFamily="34" charset="0"/>
+              </a:rPr>
+              <a:t>Efficient</a:t>
+            </a:r>
+          </a:p>
+          <a:p>
+            <a:pPr marL="171450" indent="-171450" fontAlgn="base">
+              <a:buFont typeface="Arial" panose="020B0604020202020204" pitchFamily="34" charset="0"/>
+              <a:buChar char="•"/>
+            </a:pPr>
+            <a:r>
+              <a:rPr lang="en-US" sz="1200" dirty="0">
+                <a:solidFill>
+                  <a:srgbClr val="FFFFFF"/>
+                </a:solidFill>
+                <a:latin typeface="Calibri" panose="020F0502020204030204" pitchFamily="34" charset="0"/>
+              </a:rPr>
+              <a:t>Clear Communication</a:t>
+            </a:r>
+          </a:p>
+          <a:p>
+            <a:pPr marL="171450" indent="-171450" fontAlgn="base">
+              <a:buFont typeface="Arial" panose="020B0604020202020204" pitchFamily="34" charset="0"/>
+              <a:buChar char="•"/>
+            </a:pPr>
+            <a:r>
+              <a:rPr lang="en-US" sz="1200" dirty="0">
+                <a:solidFill>
+                  <a:srgbClr val="FFFFFF"/>
+                </a:solidFill>
+                <a:latin typeface="Calibri" panose="020F0502020204030204" pitchFamily="34" charset="0"/>
+              </a:rPr>
+              <a:t>Maximizing efficiency everyday</a:t>
+            </a:r>
+          </a:p>
+          <a:p>
+            <a:pPr marL="171450" indent="-171450" fontAlgn="base">
+              <a:buFont typeface="Arial" panose="020B0604020202020204" pitchFamily="34" charset="0"/>
+              <a:buChar char="•"/>
+            </a:pPr>
+            <a:r>
+              <a:rPr lang="en-US" sz="1200" dirty="0">
+                <a:solidFill>
+                  <a:srgbClr val="FFFFFF"/>
+                </a:solidFill>
+                <a:latin typeface="Calibri" panose="020F0502020204030204" pitchFamily="34" charset="0"/>
+              </a:rPr>
+              <a:t>Autonomy</a:t>
+            </a:r>
+          </a:p>
+          <a:p>
+            <a:pPr algn="ctr" fontAlgn="base"/>
+            <a:endParaRPr lang="en-US" sz="1200" dirty="0">
+              <a:solidFill>
+                <a:srgbClr val="FFFFFF"/>
+              </a:solidFill>
+              <a:latin typeface="Calibri" panose="020F0502020204030204" pitchFamily="34" charset="0"/>
+            </a:endParaRPr>
+          </a:p>
+          <a:p>
+            <a:pPr algn="ctr" fontAlgn="base"/>
+            <a:r>
+              <a:rPr lang="en-US" sz="1200" dirty="0">
+                <a:solidFill>
+                  <a:srgbClr val="FFFFFF"/>
+                </a:solidFill>
+                <a:latin typeface="Calibri" panose="020F0502020204030204" pitchFamily="34" charset="0"/>
+              </a:rPr>
+              <a:t>I’ve combined scientific rigor with people development to drive impact in breeding programs.</a:t>
+            </a:r>
+            <a:endParaRPr lang="en-US" sz="1200" dirty="0">
+              <a:solidFill>
+                <a:srgbClr val="FFFFFF"/>
+              </a:solidFill>
+              <a:latin typeface="Arial" panose="020B0604020202020204" pitchFamily="34" charset="0"/>
+            </a:endParaRPr>
+          </a:p>
+        </p:txBody>
+      </p:sp>
+      <p:sp>
+        <p:nvSpPr>
+          <p:cNvPr id="7168" name="TextBox 7167">
+            <a:extLst>
+              <a:ext uri="{FF2B5EF4-FFF2-40B4-BE49-F238E27FC236}">
+                <a16:creationId xmlns:a16="http://schemas.microsoft.com/office/drawing/2014/main" id="{05F1A230-A59D-437B-B304-CA7A2D7AFC08}"/>
+              </a:ext>
+            </a:extLst>
+          </p:cNvPr>
+          <p:cNvSpPr txBox="1"/>
+          <p:nvPr/>
+        </p:nvSpPr>
+        <p:spPr bwMode="gray">
+          <a:xfrm>
+            <a:off x="9852730" y="4278728"/>
+            <a:ext cx="935073" cy="369299"/>
+          </a:xfrm>
+          <a:prstGeom prst="rect">
+            <a:avLst/>
+          </a:prstGeom>
+          <a:noFill/>
+        </p:spPr>
+        <p:txBody>
+          <a:bodyPr wrap="square" lIns="71991" tIns="0" rIns="71991" bIns="0" rtlCol="0">
+            <a:noAutofit/>
+          </a:bodyPr>
+          <a:lstStyle/>
+          <a:p>
+            <a:pPr>
+              <a:buClr>
+                <a:srgbClr val="005598"/>
+              </a:buClr>
+              <a:buSzPct val="85000"/>
+            </a:pPr>
+            <a:r>
+              <a:rPr lang="en-US" sz="1600" b="1" dirty="0">
+                <a:solidFill>
+                  <a:srgbClr val="FFFFFF"/>
+                </a:solidFill>
+                <a:latin typeface="Calibri" panose="020F0502020204030204" pitchFamily="34" charset="0"/>
+                <a:cs typeface="Calibri" panose="020F0502020204030204" pitchFamily="34" charset="0"/>
+              </a:rPr>
+              <a:t>DISC</a:t>
+            </a:r>
+            <a:r>
+              <a:rPr lang="en-US" sz="1600" dirty="0">
+                <a:solidFill>
+                  <a:srgbClr val="FFFFFF"/>
+                </a:solidFill>
+                <a:latin typeface="Calibri" panose="020F0502020204030204" pitchFamily="34" charset="0"/>
+                <a:cs typeface="Calibri" panose="020F0502020204030204" pitchFamily="34" charset="0"/>
+              </a:rPr>
+              <a:t>: Dc</a:t>
+            </a:r>
+          </a:p>
+        </p:txBody>
+      </p:sp>
+      <p:sp>
+        <p:nvSpPr>
+          <p:cNvPr id="8" name="TextBox 7">
+            <a:extLst>
+              <a:ext uri="{FF2B5EF4-FFF2-40B4-BE49-F238E27FC236}">
+                <a16:creationId xmlns:a16="http://schemas.microsoft.com/office/drawing/2014/main" id="{81C7983D-7C1D-107A-306C-C7D66F72432D}"/>
+              </a:ext>
+            </a:extLst>
+          </p:cNvPr>
+          <p:cNvSpPr txBox="1"/>
+          <p:nvPr/>
+        </p:nvSpPr>
+        <p:spPr bwMode="gray">
+          <a:xfrm>
+            <a:off x="8801990" y="1751676"/>
+            <a:ext cx="2846612" cy="1323439"/>
+          </a:xfrm>
+          <a:prstGeom prst="rect">
+            <a:avLst/>
+          </a:prstGeom>
+        </p:spPr>
+        <p:txBody>
+          <a:bodyPr wrap="square">
+            <a:spAutoFit/>
+          </a:bodyPr>
+          <a:lstStyle>
+            <a:defPPr>
+              <a:defRPr lang="de-DE">
+                <a:latin typeface="Arial"/>
+              </a:defRPr>
+            </a:defPPr>
+            <a:lvl1pPr>
+              <a:buClr>
+                <a:srgbClr val="005598"/>
+              </a:buClr>
+              <a:buSzPct val="85000"/>
+              <a:defRPr sz="1600">
+                <a:solidFill>
+                  <a:srgbClr val="10384F"/>
+                </a:solidFill>
+                <a:latin typeface="Arial"/>
+                <a:cs typeface="Arial" charset="0"/>
+              </a:defRPr>
+            </a:lvl1pPr>
+          </a:lstStyle>
+          <a:p>
+            <a:r>
+              <a:rPr lang="en-US" dirty="0">
+                <a:latin typeface="Arial"/>
+              </a:rPr>
+              <a:t>BS – Forest engineer</a:t>
+            </a:r>
+          </a:p>
+          <a:p>
+            <a:r>
+              <a:rPr lang="en-US" dirty="0">
+                <a:latin typeface="Arial"/>
+              </a:rPr>
+              <a:t>MSc &amp; PhD – Quantitative Genetics</a:t>
+            </a:r>
+          </a:p>
+          <a:p>
+            <a:r>
+              <a:rPr lang="en-US" dirty="0">
+                <a:latin typeface="Arial"/>
+              </a:rPr>
+              <a:t>MBA – Leadership and Innovation</a:t>
+            </a:r>
+          </a:p>
+        </p:txBody>
+      </p:sp>
+      <p:pic>
+        <p:nvPicPr>
+          <p:cNvPr id="12" name="Picture 11" descr="A person in a black shirt&#10;&#10;AI-generated content may be incorrect.">
+            <a:extLst>
+              <a:ext uri="{FF2B5EF4-FFF2-40B4-BE49-F238E27FC236}">
+                <a16:creationId xmlns:a16="http://schemas.microsoft.com/office/drawing/2014/main" id="{27042DB9-44A8-8CA3-2295-8E086D8D58CC}"/>
+              </a:ext>
+            </a:extLst>
+          </p:cNvPr>
+          <p:cNvPicPr>
+            <a:picLocks noChangeAspect="1"/>
+          </p:cNvPicPr>
+          <p:nvPr/>
+        </p:nvPicPr>
+        <p:blipFill>
+          <a:blip r:embed="rId5"/>
+          <a:stretch>
+            <a:fillRect/>
+          </a:stretch>
+        </p:blipFill>
+        <p:spPr>
+          <a:xfrm>
+            <a:off x="1333858" y="1497667"/>
+            <a:ext cx="1658742" cy="2193527"/>
+          </a:xfrm>
+          <a:prstGeom prst="rect">
+            <a:avLst/>
+          </a:prstGeom>
+          <a:ln>
+            <a:solidFill>
+              <a:srgbClr val="000000"/>
+            </a:solidFill>
+          </a:ln>
+        </p:spPr>
+      </p:pic>
+      <p:pic>
+        <p:nvPicPr>
+          <p:cNvPr id="25" name="Picture 24" descr="A person and person standing together in a desert&#10;&#10;AI-generated content may be incorrect.">
+            <a:extLst>
+              <a:ext uri="{FF2B5EF4-FFF2-40B4-BE49-F238E27FC236}">
+                <a16:creationId xmlns:a16="http://schemas.microsoft.com/office/drawing/2014/main" id="{EC1C7535-7AB5-5CCF-8388-C09E24EB09DC}"/>
+              </a:ext>
+            </a:extLst>
+          </p:cNvPr>
+          <p:cNvPicPr>
+            <a:picLocks noChangeAspect="1"/>
+          </p:cNvPicPr>
+          <p:nvPr/>
+        </p:nvPicPr>
+        <p:blipFill>
+          <a:blip r:embed="rId6"/>
+          <a:stretch>
+            <a:fillRect/>
+          </a:stretch>
+        </p:blipFill>
+        <p:spPr>
+          <a:xfrm>
+            <a:off x="2095772" y="3754533"/>
+            <a:ext cx="1550684" cy="2067578"/>
+          </a:xfrm>
+          <a:prstGeom prst="rect">
+            <a:avLst/>
+          </a:prstGeom>
+          <a:ln>
+            <a:solidFill>
+              <a:srgbClr val="000000"/>
+            </a:solidFill>
+          </a:ln>
+        </p:spPr>
+      </p:pic>
+      <p:pic>
+        <p:nvPicPr>
+          <p:cNvPr id="28" name="Picture 27" descr="A child standing on sand and giving thumbs up&#10;&#10;AI-generated content may be incorrect.">
+            <a:extLst>
+              <a:ext uri="{FF2B5EF4-FFF2-40B4-BE49-F238E27FC236}">
+                <a16:creationId xmlns:a16="http://schemas.microsoft.com/office/drawing/2014/main" id="{640C1E1A-A87E-C78E-0FE3-AA70FEA7CCDC}"/>
+              </a:ext>
+            </a:extLst>
+          </p:cNvPr>
+          <p:cNvPicPr>
+            <a:picLocks noChangeAspect="1"/>
+          </p:cNvPicPr>
+          <p:nvPr/>
+        </p:nvPicPr>
+        <p:blipFill>
+          <a:blip r:embed="rId7"/>
+          <a:srcRect r="44731"/>
+          <a:stretch/>
+        </p:blipFill>
+        <p:spPr>
+          <a:xfrm>
+            <a:off x="1281573" y="4884080"/>
+            <a:ext cx="639635" cy="1543096"/>
+          </a:xfrm>
+          <a:prstGeom prst="rect">
+            <a:avLst/>
+          </a:prstGeom>
+          <a:ln>
+            <a:solidFill>
+              <a:srgbClr val="000000"/>
+            </a:solidFill>
+          </a:ln>
+        </p:spPr>
+      </p:pic>
+      <p:pic>
+        <p:nvPicPr>
+          <p:cNvPr id="23" name="Picture 22" descr="A person taking a selfie with a group of people&#10;&#10;AI-generated content may be incorrect.">
+            <a:extLst>
+              <a:ext uri="{FF2B5EF4-FFF2-40B4-BE49-F238E27FC236}">
+                <a16:creationId xmlns:a16="http://schemas.microsoft.com/office/drawing/2014/main" id="{B180AFCB-91F1-7E5F-AA50-37BEE33EA607}"/>
+              </a:ext>
+            </a:extLst>
+          </p:cNvPr>
+          <p:cNvPicPr>
+            <a:picLocks noChangeAspect="1"/>
+          </p:cNvPicPr>
+          <p:nvPr/>
+        </p:nvPicPr>
+        <p:blipFill>
+          <a:blip r:embed="rId8"/>
+          <a:stretch>
+            <a:fillRect/>
+          </a:stretch>
+        </p:blipFill>
+        <p:spPr>
+          <a:xfrm>
+            <a:off x="574444" y="3829747"/>
+            <a:ext cx="1825460" cy="1370877"/>
+          </a:xfrm>
+          <a:prstGeom prst="rect">
+            <a:avLst/>
+          </a:prstGeom>
+          <a:ln>
+            <a:solidFill>
+              <a:srgbClr val="000000"/>
+            </a:solidFill>
+          </a:ln>
+        </p:spPr>
+      </p:pic>
+      <p:pic>
+        <p:nvPicPr>
+          <p:cNvPr id="33" name="Picture 32" descr="A person holding a skateboard in the desert&#10;&#10;AI-generated content may be incorrect.">
+            <a:extLst>
+              <a:ext uri="{FF2B5EF4-FFF2-40B4-BE49-F238E27FC236}">
+                <a16:creationId xmlns:a16="http://schemas.microsoft.com/office/drawing/2014/main" id="{1494F727-AA1F-B5D5-613C-4D471B295D29}"/>
+              </a:ext>
+            </a:extLst>
+          </p:cNvPr>
+          <p:cNvPicPr>
+            <a:picLocks noChangeAspect="1"/>
+          </p:cNvPicPr>
+          <p:nvPr/>
+        </p:nvPicPr>
+        <p:blipFill>
+          <a:blip r:embed="rId9"/>
+          <a:stretch>
+            <a:fillRect/>
+          </a:stretch>
+        </p:blipFill>
+        <p:spPr>
+          <a:xfrm>
+            <a:off x="3811920" y="5062240"/>
+            <a:ext cx="1019252" cy="1338919"/>
+          </a:xfrm>
+          <a:prstGeom prst="rect">
+            <a:avLst/>
+          </a:prstGeom>
+          <a:ln>
+            <a:solidFill>
+              <a:srgbClr val="000000"/>
+            </a:solidFill>
+          </a:ln>
+        </p:spPr>
+      </p:pic>
+      <p:pic>
+        <p:nvPicPr>
+          <p:cNvPr id="39" name="Picture 38" descr="A person holding a cup&#10;&#10;AI-generated content may be incorrect.">
+            <a:extLst>
+              <a:ext uri="{FF2B5EF4-FFF2-40B4-BE49-F238E27FC236}">
+                <a16:creationId xmlns:a16="http://schemas.microsoft.com/office/drawing/2014/main" id="{A28CB8A5-D5C9-6BB2-6E61-4F564BC1D0A7}"/>
+              </a:ext>
+            </a:extLst>
+          </p:cNvPr>
+          <p:cNvPicPr>
+            <a:picLocks noChangeAspect="1"/>
+          </p:cNvPicPr>
+          <p:nvPr/>
+        </p:nvPicPr>
+        <p:blipFill>
+          <a:blip r:embed="rId10"/>
+          <a:stretch>
+            <a:fillRect/>
+          </a:stretch>
+        </p:blipFill>
+        <p:spPr>
+          <a:xfrm>
+            <a:off x="5289428" y="3723841"/>
+            <a:ext cx="1020079" cy="1360105"/>
+          </a:xfrm>
+          <a:prstGeom prst="rect">
+            <a:avLst/>
+          </a:prstGeom>
+          <a:ln>
+            <a:solidFill>
+              <a:srgbClr val="000000"/>
+            </a:solidFill>
+          </a:ln>
+        </p:spPr>
+      </p:pic>
+      <p:pic>
+        <p:nvPicPr>
+          <p:cNvPr id="44" name="Picture 43" descr="A person swimming with a turtle&#10;&#10;AI-generated content may be incorrect.">
+            <a:extLst>
+              <a:ext uri="{FF2B5EF4-FFF2-40B4-BE49-F238E27FC236}">
+                <a16:creationId xmlns:a16="http://schemas.microsoft.com/office/drawing/2014/main" id="{4B1506D9-E017-B0AC-44C3-8EE2EE9A0816}"/>
+              </a:ext>
+            </a:extLst>
+          </p:cNvPr>
+          <p:cNvPicPr>
+            <a:picLocks noChangeAspect="1"/>
+          </p:cNvPicPr>
+          <p:nvPr/>
+        </p:nvPicPr>
+        <p:blipFill>
+          <a:blip r:embed="rId11"/>
+          <a:srcRect l="18773" t="34250" r="23458" b="21603"/>
+          <a:stretch/>
+        </p:blipFill>
+        <p:spPr>
+          <a:xfrm>
+            <a:off x="4918465" y="5132985"/>
+            <a:ext cx="1331807" cy="1357016"/>
+          </a:xfrm>
+          <a:prstGeom prst="rect">
+            <a:avLst/>
+          </a:prstGeom>
+          <a:ln>
+            <a:solidFill>
+              <a:srgbClr val="000000"/>
+            </a:solidFill>
+          </a:ln>
+        </p:spPr>
+      </p:pic>
+      <p:pic>
+        <p:nvPicPr>
+          <p:cNvPr id="47" name="Picture 46" descr="A person and person sitting next to a large reptile&#10;&#10;AI-generated content may be incorrect.">
+            <a:extLst>
+              <a:ext uri="{FF2B5EF4-FFF2-40B4-BE49-F238E27FC236}">
+                <a16:creationId xmlns:a16="http://schemas.microsoft.com/office/drawing/2014/main" id="{2D349FC8-907F-6C50-C1B5-EA98473F4C84}"/>
+              </a:ext>
+            </a:extLst>
+          </p:cNvPr>
+          <p:cNvPicPr>
+            <a:picLocks noChangeAspect="1"/>
+          </p:cNvPicPr>
+          <p:nvPr/>
+        </p:nvPicPr>
+        <p:blipFill>
+          <a:blip r:embed="rId12"/>
+          <a:srcRect l="11692" t="21838" r="10845" b="30586"/>
+          <a:stretch/>
+        </p:blipFill>
+        <p:spPr>
+          <a:xfrm>
+            <a:off x="3707894" y="3802165"/>
+            <a:ext cx="1524030" cy="1248034"/>
+          </a:xfrm>
+          <a:prstGeom prst="rect">
+            <a:avLst/>
+          </a:prstGeom>
+          <a:ln>
+            <a:solidFill>
+              <a:srgbClr val="000000"/>
+            </a:solidFill>
+          </a:ln>
+        </p:spPr>
+      </p:pic>
+      <p:pic>
+        <p:nvPicPr>
+          <p:cNvPr id="52" name="Picture 51" descr="A child flying a kite on a beach&#10;&#10;AI-generated content may be incorrect.">
+            <a:extLst>
+              <a:ext uri="{FF2B5EF4-FFF2-40B4-BE49-F238E27FC236}">
+                <a16:creationId xmlns:a16="http://schemas.microsoft.com/office/drawing/2014/main" id="{F86FB47A-4B04-298B-7CAB-8A7D1C427CB3}"/>
+              </a:ext>
+            </a:extLst>
+          </p:cNvPr>
+          <p:cNvPicPr>
+            <a:picLocks noChangeAspect="1"/>
+          </p:cNvPicPr>
+          <p:nvPr/>
+        </p:nvPicPr>
+        <p:blipFill>
+          <a:blip r:embed="rId13"/>
+          <a:stretch>
+            <a:fillRect/>
+          </a:stretch>
+        </p:blipFill>
+        <p:spPr>
+          <a:xfrm>
+            <a:off x="6436469" y="3522965"/>
+            <a:ext cx="1157999" cy="1549163"/>
+          </a:xfrm>
+          <a:prstGeom prst="rect">
+            <a:avLst/>
+          </a:prstGeom>
+          <a:ln>
+            <a:solidFill>
+              <a:srgbClr val="000000"/>
+            </a:solidFill>
+          </a:ln>
+        </p:spPr>
+      </p:pic>
+      <p:pic>
+        <p:nvPicPr>
+          <p:cNvPr id="54" name="Picture 53" descr="A person and person skydiving over a city&#10;&#10;AI-generated content may be incorrect.">
+            <a:extLst>
+              <a:ext uri="{FF2B5EF4-FFF2-40B4-BE49-F238E27FC236}">
+                <a16:creationId xmlns:a16="http://schemas.microsoft.com/office/drawing/2014/main" id="{CF691843-572A-D221-4FCF-11FCA2CA3368}"/>
+              </a:ext>
+            </a:extLst>
+          </p:cNvPr>
+          <p:cNvPicPr>
+            <a:picLocks noChangeAspect="1"/>
+          </p:cNvPicPr>
+          <p:nvPr/>
+        </p:nvPicPr>
+        <p:blipFill>
+          <a:blip r:embed="rId14"/>
+          <a:stretch>
+            <a:fillRect/>
+          </a:stretch>
+        </p:blipFill>
+        <p:spPr>
+          <a:xfrm>
+            <a:off x="6436469" y="4922901"/>
+            <a:ext cx="1550875" cy="1357016"/>
+          </a:xfrm>
+          <a:prstGeom prst="rect">
+            <a:avLst/>
+          </a:prstGeom>
+          <a:ln>
+            <a:solidFill>
+              <a:srgbClr val="000000"/>
+            </a:solidFill>
+          </a:ln>
+        </p:spPr>
+      </p:pic>
+      <p:pic>
+        <p:nvPicPr>
+          <p:cNvPr id="56" name="Picture 55" descr="A person and person sitting on a glass floor with a city in the background&#10;&#10;AI-generated content may be incorrect.">
+            <a:extLst>
+              <a:ext uri="{FF2B5EF4-FFF2-40B4-BE49-F238E27FC236}">
+                <a16:creationId xmlns:a16="http://schemas.microsoft.com/office/drawing/2014/main" id="{250270A0-2575-D7E5-8CDB-E29ED0EF0E08}"/>
+              </a:ext>
+            </a:extLst>
+          </p:cNvPr>
+          <p:cNvPicPr>
+            <a:picLocks noChangeAspect="1"/>
+          </p:cNvPicPr>
+          <p:nvPr/>
+        </p:nvPicPr>
+        <p:blipFill>
+          <a:blip r:embed="rId15"/>
+          <a:stretch>
+            <a:fillRect/>
+          </a:stretch>
+        </p:blipFill>
+        <p:spPr>
+          <a:xfrm>
+            <a:off x="7591875" y="3933887"/>
+            <a:ext cx="1565948" cy="1046249"/>
+          </a:xfrm>
+          <a:prstGeom prst="rect">
+            <a:avLst/>
+          </a:prstGeom>
+          <a:ln>
+            <a:solidFill>
+              <a:srgbClr val="000000"/>
+            </a:solidFill>
+          </a:ln>
+        </p:spPr>
+      </p:pic>
+      <p:pic>
+        <p:nvPicPr>
+          <p:cNvPr id="58" name="Picture 57" descr="A large rock formation with a sandy beach and blue water&#10;&#10;AI-generated content may be incorrect.">
+            <a:extLst>
+              <a:ext uri="{FF2B5EF4-FFF2-40B4-BE49-F238E27FC236}">
+                <a16:creationId xmlns:a16="http://schemas.microsoft.com/office/drawing/2014/main" id="{265B8B79-BB00-4150-712E-4CD1BD47F9C9}"/>
+              </a:ext>
+            </a:extLst>
+          </p:cNvPr>
+          <p:cNvPicPr>
+            <a:picLocks noChangeAspect="1"/>
+          </p:cNvPicPr>
+          <p:nvPr/>
+        </p:nvPicPr>
+        <p:blipFill>
+          <a:blip r:embed="rId16"/>
+          <a:stretch>
+            <a:fillRect/>
+          </a:stretch>
+        </p:blipFill>
+        <p:spPr>
+          <a:xfrm>
+            <a:off x="8047561" y="4965042"/>
+            <a:ext cx="1029562" cy="1372749"/>
+          </a:xfrm>
+          <a:prstGeom prst="rect">
+            <a:avLst/>
+          </a:prstGeom>
+          <a:ln>
+            <a:solidFill>
+              <a:srgbClr val="000000"/>
+            </a:solidFill>
+          </a:ln>
+        </p:spPr>
+      </p:pic>
+      <p:pic>
+        <p:nvPicPr>
+          <p:cNvPr id="60" name="Picture 59">
+            <a:extLst>
+              <a:ext uri="{FF2B5EF4-FFF2-40B4-BE49-F238E27FC236}">
+                <a16:creationId xmlns:a16="http://schemas.microsoft.com/office/drawing/2014/main" id="{6591E220-9262-B8B6-A396-6B3682A01A65}"/>
+              </a:ext>
+            </a:extLst>
+          </p:cNvPr>
+          <p:cNvPicPr>
+            <a:picLocks noChangeAspect="1"/>
+          </p:cNvPicPr>
+          <p:nvPr/>
+        </p:nvPicPr>
+        <p:blipFill>
+          <a:blip r:embed="rId17"/>
+          <a:stretch>
+            <a:fillRect/>
+          </a:stretch>
+        </p:blipFill>
+        <p:spPr>
+          <a:xfrm>
+            <a:off x="10932564" y="3803553"/>
+            <a:ext cx="1308299" cy="1280063"/>
+          </a:xfrm>
+          <a:prstGeom prst="ellipse">
+            <a:avLst/>
+          </a:prstGeom>
+        </p:spPr>
+      </p:pic>
+      <p:pic>
+        <p:nvPicPr>
+          <p:cNvPr id="61" name="Picture 3" descr="Identidade Visual - UFLA - Universidade Federal de Lavras">
+            <a:extLst>
+              <a:ext uri="{FF2B5EF4-FFF2-40B4-BE49-F238E27FC236}">
+                <a16:creationId xmlns:a16="http://schemas.microsoft.com/office/drawing/2014/main" id="{C76F35FD-D852-8093-D773-91E6646633D5}"/>
+              </a:ext>
+            </a:extLst>
+          </p:cNvPr>
+          <p:cNvPicPr>
+            <a:picLocks noChangeAspect="1" noChangeArrowheads="1"/>
+          </p:cNvPicPr>
+          <p:nvPr/>
+        </p:nvPicPr>
+        <p:blipFill>
+          <a:blip r:embed="rId18">
+            <a:extLst>
+              <a:ext uri="{28A0092B-C50C-407E-A947-70E740481C1C}">
+                <a14:useLocalDpi xmlns:a14="http://schemas.microsoft.com/office/drawing/2010/main" val="0"/>
+              </a:ext>
+            </a:extLst>
+          </a:blip>
+          <a:srcRect/>
+          <a:stretch>
+            <a:fillRect/>
+          </a:stretch>
+        </p:blipFill>
+        <p:spPr bwMode="auto">
+          <a:xfrm>
+            <a:off x="10914798" y="1719046"/>
+            <a:ext cx="669947" cy="248305"/>
+          </a:xfrm>
+          <a:prstGeom prst="rect">
+            <a:avLst/>
+          </a:prstGeom>
+          <a:noFill/>
+          <a:extLst>
+            <a:ext uri="{909E8E84-426E-40DD-AFC4-6F175D3DCCD1}">
+              <a14:hiddenFill xmlns:a14="http://schemas.microsoft.com/office/drawing/2010/main">
+                <a:solidFill>
+                  <a:srgbClr val="FFFFFF"/>
+                </a:solidFill>
+              </a14:hiddenFill>
+            </a:ext>
+          </a:extLst>
+        </p:spPr>
+      </p:pic>
+      <p:pic>
+        <p:nvPicPr>
+          <p:cNvPr id="62" name="Picture 13" descr="University of Florida Logo, symbol, meaning, history, PNG, brand">
+            <a:extLst>
+              <a:ext uri="{FF2B5EF4-FFF2-40B4-BE49-F238E27FC236}">
+                <a16:creationId xmlns:a16="http://schemas.microsoft.com/office/drawing/2014/main" id="{AF622CF6-F240-5009-46A7-9D11B29D63D4}"/>
+              </a:ext>
+            </a:extLst>
+          </p:cNvPr>
+          <p:cNvPicPr>
+            <a:picLocks noChangeAspect="1" noChangeArrowheads="1"/>
+          </p:cNvPicPr>
+          <p:nvPr/>
+        </p:nvPicPr>
+        <p:blipFill rotWithShape="1">
+          <a:blip r:embed="rId19">
+            <a:extLst>
+              <a:ext uri="{28A0092B-C50C-407E-A947-70E740481C1C}">
+                <a14:useLocalDpi xmlns:a14="http://schemas.microsoft.com/office/drawing/2010/main" val="0"/>
+              </a:ext>
+            </a:extLst>
+          </a:blip>
+          <a:srcRect b="21925"/>
+          <a:stretch/>
+        </p:blipFill>
+        <p:spPr bwMode="auto">
+          <a:xfrm>
+            <a:off x="4185633" y="2988854"/>
+            <a:ext cx="1098532" cy="440146"/>
+          </a:xfrm>
+          <a:prstGeom prst="rect">
+            <a:avLst/>
+          </a:prstGeom>
+          <a:noFill/>
+          <a:extLst>
+            <a:ext uri="{909E8E84-426E-40DD-AFC4-6F175D3DCCD1}">
+              <a14:hiddenFill xmlns:a14="http://schemas.microsoft.com/office/drawing/2010/main">
+                <a:solidFill>
+                  <a:srgbClr val="FFFFFF"/>
+                </a:solidFill>
+              </a14:hiddenFill>
+            </a:ext>
+          </a:extLst>
+        </p:spPr>
+      </p:pic>
+      <p:pic>
+        <p:nvPicPr>
+          <p:cNvPr id="63" name="Picture 15" descr="Bracell">
+            <a:extLst>
+              <a:ext uri="{FF2B5EF4-FFF2-40B4-BE49-F238E27FC236}">
+                <a16:creationId xmlns:a16="http://schemas.microsoft.com/office/drawing/2014/main" id="{5D083AF8-4800-B75F-A3AE-736DBEAA2B3C}"/>
+              </a:ext>
+            </a:extLst>
+          </p:cNvPr>
+          <p:cNvPicPr>
+            <a:picLocks noChangeAspect="1" noChangeArrowheads="1"/>
+          </p:cNvPicPr>
+          <p:nvPr/>
+        </p:nvPicPr>
+        <p:blipFill>
+          <a:blip r:embed="rId20">
+            <a:extLst>
+              <a:ext uri="{28A0092B-C50C-407E-A947-70E740481C1C}">
+                <a14:useLocalDpi xmlns:a14="http://schemas.microsoft.com/office/drawing/2010/main" val="0"/>
+              </a:ext>
+            </a:extLst>
+          </a:blip>
+          <a:srcRect/>
+          <a:stretch>
+            <a:fillRect/>
+          </a:stretch>
+        </p:blipFill>
+        <p:spPr bwMode="auto">
+          <a:xfrm>
+            <a:off x="5410242" y="3205445"/>
+            <a:ext cx="834832" cy="170685"/>
+          </a:xfrm>
+          <a:prstGeom prst="rect">
+            <a:avLst/>
+          </a:prstGeom>
+          <a:noFill/>
+          <a:extLst>
+            <a:ext uri="{909E8E84-426E-40DD-AFC4-6F175D3DCCD1}">
+              <a14:hiddenFill xmlns:a14="http://schemas.microsoft.com/office/drawing/2010/main">
+                <a:solidFill>
+                  <a:srgbClr val="FFFFFF"/>
+                </a:solidFill>
+              </a14:hiddenFill>
+            </a:ext>
+          </a:extLst>
+        </p:spPr>
+      </p:pic>
+      <p:pic>
+        <p:nvPicPr>
+          <p:cNvPr id="7169" name="Picture 6">
+            <a:extLst>
+              <a:ext uri="{FF2B5EF4-FFF2-40B4-BE49-F238E27FC236}">
+                <a16:creationId xmlns:a16="http://schemas.microsoft.com/office/drawing/2014/main" id="{5E1D1F66-FD51-F56B-64FB-79AA2B46EE92}"/>
+              </a:ext>
+            </a:extLst>
+          </p:cNvPr>
+          <p:cNvPicPr>
+            <a:picLocks noChangeAspect="1" noChangeArrowheads="1"/>
+          </p:cNvPicPr>
+          <p:nvPr/>
+        </p:nvPicPr>
+        <p:blipFill>
+          <a:blip r:embed="rId21">
+            <a:extLst>
+              <a:ext uri="{28A0092B-C50C-407E-A947-70E740481C1C}">
+                <a14:useLocalDpi xmlns:a14="http://schemas.microsoft.com/office/drawing/2010/main" val="0"/>
+              </a:ext>
+            </a:extLst>
+          </a:blip>
+          <a:srcRect/>
+          <a:stretch>
+            <a:fillRect/>
+          </a:stretch>
+        </p:blipFill>
+        <p:spPr bwMode="auto">
+          <a:xfrm>
+            <a:off x="6371152" y="3136754"/>
+            <a:ext cx="1303397" cy="292246"/>
+          </a:xfrm>
+          <a:prstGeom prst="rect">
+            <a:avLst/>
+          </a:prstGeom>
+          <a:noFill/>
+          <a:extLst>
+            <a:ext uri="{909E8E84-426E-40DD-AFC4-6F175D3DCCD1}">
+              <a14:hiddenFill xmlns:a14="http://schemas.microsoft.com/office/drawing/2010/main">
+                <a:solidFill>
+                  <a:srgbClr val="FFFFFF"/>
+                </a:solidFill>
+              </a14:hiddenFill>
+            </a:ext>
+          </a:extLst>
+        </p:spPr>
+      </p:pic>
+      <p:pic>
+        <p:nvPicPr>
+          <p:cNvPr id="7170" name="Picture 6">
+            <a:extLst>
+              <a:ext uri="{FF2B5EF4-FFF2-40B4-BE49-F238E27FC236}">
+                <a16:creationId xmlns:a16="http://schemas.microsoft.com/office/drawing/2014/main" id="{EC70C797-6C65-B9E2-99A0-5E7C1A196FF6}"/>
+              </a:ext>
+            </a:extLst>
+          </p:cNvPr>
+          <p:cNvPicPr>
+            <a:picLocks noChangeAspect="1" noChangeArrowheads="1"/>
+          </p:cNvPicPr>
+          <p:nvPr/>
+        </p:nvPicPr>
+        <p:blipFill>
+          <a:blip r:embed="rId22">
+            <a:extLst>
+              <a:ext uri="{28A0092B-C50C-407E-A947-70E740481C1C}">
+                <a14:useLocalDpi xmlns:a14="http://schemas.microsoft.com/office/drawing/2010/main" val="0"/>
+              </a:ext>
+            </a:extLst>
+          </a:blip>
+          <a:srcRect/>
+          <a:stretch>
+            <a:fillRect/>
+          </a:stretch>
+        </p:blipFill>
+        <p:spPr bwMode="auto">
+          <a:xfrm>
+            <a:off x="10503713" y="2889093"/>
+            <a:ext cx="1033345" cy="185141"/>
+          </a:xfrm>
+          <a:prstGeom prst="rect">
+            <a:avLst/>
+          </a:prstGeom>
+          <a:noFill/>
+          <a:extLst>
+            <a:ext uri="{909E8E84-426E-40DD-AFC4-6F175D3DCCD1}">
+              <a14:hiddenFill xmlns:a14="http://schemas.microsoft.com/office/drawing/2010/main">
+                <a:solidFill>
+                  <a:srgbClr val="FFFFFF"/>
+                </a:solidFill>
+              </a14:hiddenFill>
+            </a:ext>
+          </a:extLst>
+        </p:spPr>
+      </p:pic>
+      <p:pic>
+        <p:nvPicPr>
+          <p:cNvPr id="7171" name="Picture 8" descr="Sylvamo Logo – PNG e Vetor – Download de Logo">
+            <a:extLst>
+              <a:ext uri="{FF2B5EF4-FFF2-40B4-BE49-F238E27FC236}">
+                <a16:creationId xmlns:a16="http://schemas.microsoft.com/office/drawing/2014/main" id="{DD43EA07-EBB4-7558-8792-1B3812A51046}"/>
+              </a:ext>
+            </a:extLst>
+          </p:cNvPr>
+          <p:cNvPicPr>
+            <a:picLocks noChangeAspect="1" noChangeArrowheads="1"/>
+          </p:cNvPicPr>
+          <p:nvPr/>
+        </p:nvPicPr>
+        <p:blipFill>
+          <a:blip r:embed="rId23">
+            <a:extLst>
+              <a:ext uri="{28A0092B-C50C-407E-A947-70E740481C1C}">
+                <a14:useLocalDpi xmlns:a14="http://schemas.microsoft.com/office/drawing/2010/main" val="0"/>
+              </a:ext>
+            </a:extLst>
+          </a:blip>
+          <a:srcRect/>
+          <a:stretch>
+            <a:fillRect/>
+          </a:stretch>
+        </p:blipFill>
+        <p:spPr bwMode="auto">
+          <a:xfrm>
+            <a:off x="7800626" y="2941428"/>
+            <a:ext cx="832240" cy="455564"/>
+          </a:xfrm>
+          <a:prstGeom prst="rect">
+            <a:avLst/>
+          </a:prstGeom>
+          <a:noFill/>
+          <a:extLst>
+            <a:ext uri="{909E8E84-426E-40DD-AFC4-6F175D3DCCD1}">
+              <a14:hiddenFill xmlns:a14="http://schemas.microsoft.com/office/drawing/2010/main">
+                <a:solidFill>
+                  <a:srgbClr val="FFFFFF"/>
+                </a:solidFill>
+              </a14:hiddenFill>
+            </a:ext>
+          </a:extLst>
+        </p:spPr>
+      </p:pic>
+      <p:pic>
+        <p:nvPicPr>
+          <p:cNvPr id="7173" name="Picture 4">
+            <a:extLst>
+              <a:ext uri="{FF2B5EF4-FFF2-40B4-BE49-F238E27FC236}">
+                <a16:creationId xmlns:a16="http://schemas.microsoft.com/office/drawing/2014/main" id="{0B0C3567-1ABD-D0B7-7496-BC8F39375EA9}"/>
+              </a:ext>
+            </a:extLst>
+          </p:cNvPr>
+          <p:cNvPicPr>
+            <a:picLocks noChangeAspect="1" noChangeArrowheads="1"/>
+          </p:cNvPicPr>
+          <p:nvPr/>
+        </p:nvPicPr>
+        <p:blipFill>
+          <a:blip r:embed="rId24">
+            <a:extLst>
+              <a:ext uri="{28A0092B-C50C-407E-A947-70E740481C1C}">
+                <a14:useLocalDpi xmlns:a14="http://schemas.microsoft.com/office/drawing/2010/main" val="0"/>
+              </a:ext>
+            </a:extLst>
+          </a:blip>
+          <a:srcRect/>
+          <a:stretch>
+            <a:fillRect/>
+          </a:stretch>
+        </p:blipFill>
+        <p:spPr bwMode="auto">
+          <a:xfrm>
+            <a:off x="10995573" y="349316"/>
+            <a:ext cx="831111" cy="831111"/>
+          </a:xfrm>
+          <a:prstGeom prst="rect">
+            <a:avLst/>
+          </a:prstGeom>
+          <a:noFill/>
+          <a:extLst>
+            <a:ext uri="{909E8E84-426E-40DD-AFC4-6F175D3DCCD1}">
+              <a14:hiddenFill xmlns:a14="http://schemas.microsoft.com/office/drawing/2010/main">
+                <a:solidFill>
+                  <a:srgbClr val="FFFFFF"/>
+                </a:solidFill>
+              </a14:hiddenFill>
+            </a:ext>
+          </a:extLst>
+        </p:spPr>
+      </p:pic>
+    </p:spTree>
+    <p:extLst>
+      <p:ext uri="{BB962C8B-B14F-4D97-AF65-F5344CB8AC3E}">
+        <p14:creationId xmlns:p14="http://schemas.microsoft.com/office/powerpoint/2010/main" val="5505706"/>
+      </p:ext>
+    </p:extLst>
+  </p:cSld>
+  <p:clrMapOvr>
+    <a:masterClrMapping/>
+  </p:clrMapOvr>
+  <mc:AlternateContent xmlns:mc="http://schemas.openxmlformats.org/markup-compatibility/2006" xmlns:p14="http://schemas.microsoft.com/office/powerpoint/2010/main">
+    <mc:Choice Requires="p14">
+      <p:transition spd="med" p14:dur="700">
+        <p:fade/>
+      </p:transition>
+    </mc:Choice>
+    <mc:Fallback xmlns="">
+      <p:transition spd="med">
+        <p:fade/>
+      </p:transition>
+    </mc:Fallback>
+  </mc:AlternateContent>
+</p:sld>
+</file>
+
 <file path=ppt/tags/tag1.xml><?xml version="1.0" encoding="utf-8"?>
 <p:tagLst xmlns:a="http://schemas.openxmlformats.org/drawingml/2006/main" xmlns:r="http://schemas.openxmlformats.org/officeDocument/2006/relationships" xmlns:p="http://schemas.openxmlformats.org/presentationml/2006/main">
   <p:tag name="EMPOWERCHARTSPROPERTIES_A_0" val="AAAAAAH//////////wEAAAAAAAAAAAAAACoqIFRoaXMgaXMgYSBMaXRlREIgZmlsZSAqKgcEAP////8FAAAAAQAAAAAAAAAAAAAAAAAAAAAAAAAAAAAAAAAAAAAAAAAAAAAAAAABEQAAAFByb3BlcnR5RG9jdW1lbnRzAgAAAAAAAAAAAAAAAAAAAAAAAAAAAAAAAAAAAAAAAAAAAAAAAAAAAAAAAAAAAAAAAAAAAAAAAAAAAAAAAAAAAAAAAAAAAAAAAAAAAAAAAAAAAAAAAAAAAAAAAAAAAAAAAAAAAAAAAAAAAAAAAAAAAAAAAAAAAAAAAAAAAAAAAAAAAAAAAAAAAAAAAAAAAAAAAAAAAAAAAAAAAAAAAAAAAAAAAAAAAAAAAAAAAAAAAAAAAAAAAAAAAAAAAAAAAAAAAAAAAAAAAAAAAAAAAAAAAAAAAAAAAAAAAAAAAAAAAAAAAAAAAAAAAAAAAAAAAAAAAAAAAAAAAAAAAAAAAAAAAAAAAAAAAAAAAAAAAAAAAAAAAAAAAAAAAAAAAAAAAAAAAAAAAAAAAAAAAAAAAAAAAAAAAAAAAAAAAAAAAAAAAAAAAAAAAAAAAAAAAAAAAAAAAAAAAAAAAAAAAAAAAAAAAAAAAAAAAAAAAAAAAAAAAAAAAAAAAAAAAAAAAAAAAAAAAAAAAAAAAAAAAAAAAAAAAAAAAAAAAAAAAAAAAAAAAAAAAAAAAAAAAAAAAAAAAAAAAAAAAAAAAAAAAAAAAAAAAAAAAAAAAAAAAAAAAAAAAAAAAAAAAAAAAAAAAAAAAAAAAAAAAAAAAAAAAAAAAAAAAAAAAAAAAAAAAAAAAAAAAAAAAAAAAAAAAAAAAAAAAAAAAAAAAAAAAAAAAAAAAAAAAAAAAAAAAAAAAAAAAAAAAAAAAAAAAAAAAAAAAAAAAAAAAAAAAAAAAAAAAAAAAAAAAAAAAAAAAAAAAAAAAAAAAAAAAAAAAAAAAAAAAAAAAAAAAAAAAAAAAAAAAAAAAAAAAAAAAAAAAAAAAAAAAAAAAAAAAAAAAAAAAAAAAAAAAAAAAAAAAAAAAAAAAAAAAAAAAAAAAAAAAAAAAAAAAAAAAAAAAAAAAAAAAAAAAAAAAAAAAAAAAAAAAAAAAAAAAAAAAAAAAAAAAAAAAAAAAAAAAAAAAAAAAAAAAAAAAAAAAAAAAAAAAAAAAAAAAAAAAAAAAAAAAAAAAAAAAAAAAAAAAAAAAAAAAAAAAAAAAAAAAAAAAAAAAAAAAAAAAAAAAAAAAAAAAAAAAAAAAAAAAAAAAAAAAAAAAAAAAAAAAAAAAAAAAAAAAAAAAAAAAAAAAAAAAAAAAAAAAAAAAAAAAAAAAAAAAAAAAAAAAAAAAAAAAAAAAAAAAAAAAAAAAAAAAAAAAAAAAAAAAAAAAAAAAAAAAAAAAAAAAAAAAAAAAAAAAAAAAAAAAAAAAAAAAAAAAAAAAAAAAAAAAAAAAAAAAAAAAAAAAAAAAAAAAAAAAAAAAAAAAAAAAAAAAAAAAAAAAAAAAAAAAAAAAAAAAAAAAAAAAAAAAAAAAAAAAAAAAAAAAAAAAAAAAAAAAAAAAAAAAAAAAAAAAAAAAAAAAAAAAAAAAAAAAAAAAAAAAAAAAAAAAAAAAAAAAAAAAAAAAAAAAAAAAAAAAAAAAAAAAAAAAAAAAAAAAAAAAAAAAAAAAAAAAAAAAAAAAAAAAAAAAAAAAAAAAAAAAAAAAAAAAAAAAAAAAAAAAAAAAAAAAAAAAAAAAAAAAAAAAAAAAAAAAAAAAAAAAAAAAAAAAAAAAAAAAAAAAAAAAAAAAAAAAAAAAAAAAAAAAAAAAAAAAAAAAAAAAAAAAAAAAAAAAAAAAAAAAAAAAAAAAAAAAAAAAAAAAAAAAAAAAAAAAAAAAAAAAAAAAAAAAAAAAAAAAAAAAAAAAAAAAAAAAAAAAAAAAAAAAAAAAAAAAAAAAAAAAAAAAAAAAAAAAAAAAAAAAAAAAAAAAAAAAAAAAAAAAAAAAAAAAAAAAAAAAAAAAAAAAAAAAAAAAAAAAAAAAAAAAAAAAAAAAAAAAAAAAAAAAAAAAAAAAAAAAAAAAAAAAAAAAAAAAAAAAAAAAAAAAAAAAAAAAAAAAAAAAAAAAAAAAAAAAAAAAAAAAAAAAAAAAAAAAAAAAAAAAAAAAAAAAAAAAAAAAAAAAAAAAAAAAAAAAAAAAAAAAAAAAAAAAAAAAAAAAAAAAAAAAAAAAAAAAAAAAAAAAAAAAAAAAAAAAAAAAAAAAAAAAAAAAAAAAAAAAAAAAAAAAAAAAAAAAAAAAAAAAAAAAAAAAAAAAAAAAAAAAAAAAAAAAAAAAAAAAAAAAAAAAAAAAAAAAAAAAAAAAAAAAAAAAAAAAAAAAAAAAAAAAAAAAAAAAAAAAAAAAAAAAAAAAAAAAAAAAAAAAAAAAAAAAAAAAAAAAAAAAAAAAAAAAAAAAAAAAAAAAAAAAAAAAAAAAAAAAAAAAAAAAAAAAAAAAAAAAAAAAAAAAAAAAAAAAAAAAAAAAAAAAAAAAAAAAAAAAAAAAAAAAAAAAAAAAAAAAAAAAAAAAAAAAAAAAAAAAAAAAAAAAAAAAAAAAAAAAAAAAAAAAAAAAAAAAAAAAAAAAAAAAAAAAAAAAAAAAAAAAAAAAAAAAAAAAAAAAAAAAAAAAAAAAAAAAAAAAAAAAAAAAAAAAAAAAAAAAAAAAAAAAAAAAAAAAAAAAAAAAAAAAAAAAAAAAAAAAAAAAAAAAAAAAAAAAAAAAAAAAAAAAAAAAAAAAAAAAAAAAAAAAAAAAAAAAAAAAAAAAAAAAAAAAAAAAAAAAAAAAAAAAAAAAAAAAAAAAAAAAAAAAAAAAAAAAAAAAAAAAAAAAAAAAAAAAAAAAAAAAAAAAAAAAAAAAAAAAAAAAAAAAAAAAAAAAAAAAAAAAAAAAAAAAAAAAAAAAAAAAAAAAAAAAAAAAAAAAAAAAAAAAAAAAAAAAAAAAAAAAAAAAAAAAAAAAAAAAAAAAAAAAAAAAAAAAAAAAAAAAAAAAAAAAAAAAAAAAAAAAAAAAAAAAAAAAAAAAAAAAAAAAAAAAAAAAAAAAAAAAAAAAAAAAAAAAAAAAAAAAAAAAAAAAAAAAAAAAAAAAAAAAAAAAAAAAAAAAAAAAAAAAAAAAAAAAAAAAAAAAAAAAAAAAAAAAAAAAAAAAAAAAAAAAAAAAAAAAAAAAAAAAAAAAAAAAAAAAAAAAAAAAAAAAAAAAAAAAAAAAAAAAAAAAAAAAAAAAAAAAAAAAAAAAAAAAAAAAAAAAAAAAAAAAAAAAAAAAAAAAAAAAAAAAAAAAAAAAAAAAAAAAAAAAAAAAAAAAAAAAAAAAAAAAAAAAAAAAAAAAAAAAAAAAAAAAAAAAAAAAAAAAAAAAAAAAAAAAAAAAAAAAAAAAAAAAAAAAAAAAAAAAAAAAAAAAAAAAAAAAAAAAAAAAAAAAAAAAAAAAAAAAAAAAAAAAAAAAAAAAAAAAAAAAAAAAAAAAAAAAAAAAAAAAAAAAAAAAAAAAAAAAAAAAAAAAAAAAAAAAAAAAAAAAAAAAAAAAAAAAAAAAAAAAAAAAAAAAAAAAAAAAAAAAAAAAAAAAAAAAAAAAAAAAAAAAAAAAAAAAAAAAAAAAAAAAAAAAAAAAAAAAAAAAAAAAAAAAAAAAAAAAAAAAAAAAAAAAAAAAAAAAAAAAAAAAAAAAAAAAAAAAAAAAAAAAAAAAAAAAAAAAAAAAAAAAAAAAAAAAAAAAAAAAAAAAAAAAAAAAAAAAAAAAAAAAAAAAAAAAAAAAAAAAAAAAAAAAAAAAAAAAAAAAAAAAAAAAAAAAAAAAAAAAAAAAAAAAAAAAAAAAAAAAAAAAAAAAAAAAAAAAAAAAAAAAAAAAAAAAAAAAAAAAAAAAAAAAAAAAAAAAAAAAAAAAAAAAAAAAAAAAAAAAAAAAAAAAAAAAAAAAAAAAAAAAAAAAAAAAAAAAAAAAAAAAAAAAAAAAAAAAAAAAAAAAAAAAAAAAAAAAAAAAAAAAAAAAAAAAAAAAAAAAAAAAAAAAAAAAAAAAAAAAAAAAAAAAAAAAAAAAAAAAAAAAAAAAAAAAAAAAAAAAAAAAAAAAAAAAAAAAAAAAAAAAAAAAAAAAAAAAAAAAAAAAAAAAAAAAAAAAAAAAAAAAAAAAAAAAAAAAAAAAAAAAAAAAAAAAAAAAAAAAAAAAAAAAAAAAAAAAAAAAAAAAAAAAAAAAAAAAAAAAAAAAAAAAAAAAAAAAAAAAAAAAAAAAAAAAAAAAAAAAAAAAAAAAAAAAAAAAAAAAAAAAAAAAAAAAAAAAAAAAAAAAAAAAAAAAAAAAAAAAAAAAAAAAAAAAAAAAAAAAAAAAAAAAAAAAAAAAAAAAAAAAAAAAAAAAAAAAAAAAAAAAAAAAAAAAAAAAAAAAAAAAAAAAAAAAAAAAAAAAAAAAAAAAAAAAAAAAAAAAAAAAAAAAAAAAAAAAAAAAAAAAAAAAAAAAAAAAAAAAAAAAAAAAAAAAAAAAAAAAAAAAAAAAAAAAAAAAAAAAAAAAAAAAAAAAAAAAAAAAAAAAAAAAAAAAAAAAAAAAAAAAAAAAAAAAAAAAAAAAAAAAAAAAAAAAAAAAAAAAAAAAAAAAAAAAAAAAAAAAAAAAAAAAAAAAAAAAAAAAAAAAAAAAAAAAAAAAAAAAAAAAAAAAAAAAAAAAAAAAAAAAAAAAAAAAAAAAAAAAAAAAAAAAAAAAAAAAAAAAAAAAAAAAAAAAAAAAAAAAAAAAAAAAAAAAAAAAAAAAAAAAAAAAAAAAAAAAAAAAAAAAAAAAAAAAAAAAAAAAAAAAAAAAAAAAAAAAAAAAAAAAAAAAAAAAAAAAAAAAAAAAAAAAAAAAAAAAAAAAAAAAAAAAAAAAAAAAAAAAAAAAAAAAAAAAAAAAAAAAAAAAAAAAAAAAAAAAAAAAAAAAAAAAAAAAAAAAAAAAAAAAAAAAAAAAAAAAAAAAAAAAAAAAAAAAAAAAAAAAAAAAAAAAAAAAAAAAAAAAAAAAAAAAAAAAAAAAAAAAAAAAAAAAAAAAAAAAAAAAAAAAAAAAAAAAAAAAAAAAAAAAAAAAAAAAAAAAAAAAAAAAAAAAAAAAAAAAAAAAAAAAAAAAAAAAAAAAAAAAAAAAAAAAAAAAAAAAAAAAAAAAAAAAAAAAAAAAAAAAAAAAAAAAAAAAAAAAAAAAAAAAAAAAAAAAAAAAAAAAAAAAAAAAAAAAAAAAAAAAAAAAAAAAAAAAAAAAAAAAAAAAAAAAAAAAAAAAAAAAAAAAAAAAAAAAAAAAAAAAAAAAAAAAAAAAAAAAAAAAAAAAAAAAAAAAAAAAAAAAAAAAAAAAAAAAAAAAAAAAAAAAAAAAAAAAAAAAAAAAAAAAAAAAAAAAAAAAAAAAAAAAAAAAAAAAAAAAAAAAAAAAAAAAAAAAAAAAAAAAAAAAAAAAAAAAAAAAAAAAAAAAAAAAAAAAAAAAAAAAAAAAAAAAAAAAAAAAAAAAAAAAAAAAAAAAAAAAAAAAAAAAAAAAAAAAAAAAAAAAAAAAAAAAAAAAAAAAAAAAAAAAAAAAAAAAAAAAAAAAAAAAAAAAAAAAAAAAAAAAAAAAAAAAAAAAAAAAAAAAAAAAAAAAAAAAAAAAAAAAAAAAAAAAAAAAAAAAAAAAAAAAAAAAAAAAAAAAAAAAAAAAAAAAAAAAAAAAAAAAAAAAAAAAAAAAAAAAAAAAAAAAAAAAAAAAAAAAAAAAAAAAAAAAAAAAAAAAAAAAAAAAAAAAAAAAAAAAAAAAAAAAAAAAAAAAAAAAAAAAAAAAAAAAAAAAAAAAAAAAAAAAAAAAAAAAAAAAAAAAAAAAAAAAAAAAAAAAAAAAAAAAAAAAAAAAAAAAAAAAAAAAAAAAAAAAAAAAAAAAAAAAAAAAAAAAAAAAAAAAAAAAAAAAAAAAAAAAAAAAAAAAAAAAAAAAAAAAAAAAAAAAAAAAAAAAAAAAAAAAAAAAAAAAAAAAAAAAAAAAAAAAAAAAAAAAAAAAAAAAAAAAAAAAAAAAAAAAAAAAAAAAAAAAAAAAAAAAAAAAAAAAAAAAAAAAAAAAAAAAAAAAAAAAAAAAAAAAAAAAAAAAAAAAAAAAAAAAAAAAAAAAAAAAAAAAAAAAAAAAAAAAAAAAAAAAAAAAAAAAAAAAAAAAAAAAAAAAAAAAAAAAAAAAAAAAAAAAAAAAAAAAAAAAAAAAAAAAAAAAAAAAAAAAAAAAAAAAAAAAAAAAAAAAAAAAAAAAAAAAAAAAAAAAAAAAAAAAAAAAAAAAAAAAAAAAAAAAAAAAAAAAAAAAAAAAAAAAAAAAAAAAAAAAAAAAAAAAAAAAAAAAAAAAAAAAAAAAAAAAAAAAAAAAAAAAAAAAAAAAAAAAAAAAAAAAAAAAAAAAAAAAAAAAAAAAAAAAAAAAAAAAAAAAAAAAAAAAAAAAAAAAAAAAAAAAAAAAAAAAAAAAAAAAAAAAAAAAAAAAAAAAAAAAAAAAAAAAAAAAAAAAAAAAAAAAAAAAAAAAAAAAAAAAAAAAAAAAAAAAAAAAAAAAAAAAAAAAAAAAAAAAAAAAAAAAAAAAAAAAAAAAAAAAAAAAAAAAAAAAAAAAAAAAAAAAAAAAAAAAAAAAAAAAAAAAAAAAAAAAAAAAAAAAAAAAAAAAAAAAAAAAAAAAAAAAAAAAAAAAAAAAAAAAAAAAAAAAAAAAAAAAAAAAAAAAAAAAAAAAAAAAAAAAAAAAAAAAAAAAAAAAAAAAAAAAAAAAAAAAAAAAAAAAAAAAAAAAAAAAAAAAAAAAAAAAAAAAAAAAAAAAAAAAAAAAAAAAAAAAAAAAAAAAAAAAAAAAAAAAAAAAAAAAAAAAAAAAAAAAAAAAAAAAAAAAAAAAAAAAAAAAAAAAAAAAAAAAAAAAAAAAAAAAAAAAAAAAAAAAAAAAAAAAAAAAAAAAAAAAAAAAAAAAAAAAAAAAAAAAAAAAAAAAAAAAAAAAAAAAAAAAAAAAAAAAAAAAAAAAAAAAAAAAAAAAAAAAAAAAAAAAAAAAAAAAAAAAAAAAAAAAAAAAAAAAAAAAAAAAAAAAAAAAAAAAAAAAAAAAAAAAAAAAAAAAAAAAAAAAAAAAAAAAAAAAAAAAAAAAAAAAAAAAAAAAAAAAAAAAAAAAAAAAAAAAAAAAAAAAAAAAAAAAAAAAAAAAAAAAAAAAAAAAAAAAAAAAAAAAAAAAAAAAAAAAAAAAAAAAAAAAAAAAAAAAAAAAAAAAAAAAAAAAAAAAAAAAAAAAAAAAAAAAAAAAAAAAAAAAAAAAAAAAAAAAAAAAAAAAAAAAAAAAAAAAAAAAAAAAAAAAAAAAAAAAAAAAAAAAAAAAAAAAAAAAAAAAAAAAAAAAAAAAAAAAAAAAAAAAAAAAAAAAAAAAAAAAAAAAAAAAAAAAAAAAAAAAAAAAAAAAAAAAAAAAAAAAAAAAAAAAAAAAAAAAAAAAAAAAAAAAAAAAAAAAAAAAAAAAAAAAAAAAAAAAAAAAAAAAAAAAAAAAAAAAAAAAAAAAAAAAAAAAAAAAAAAAAAAAAAAAAAAAAAAAAAAAAAAAAAAAAAAAAAAAAAAAAAAAAAAAAAAAAAAAAAAAAAAAAAAAAAAAAAAAAAAAAAAAAAAAAAAAAAAAAAAAAAAAAAAAAAAAAAAAAAAAAAAAAAAAAAAAAAAAAAAAAAAAAAAAAAAAAAAAAAAAAAAAAAAAAAAAAAAAAAAAAAAAAAAAAAAAAAAAAAAAAAAAAAAAAAAAAAAAAAAAAAAAAAAAAAAAAAAAAAAAAAAAAAAAAAAAAAAAAAAAAAAAAAAAAAAAAAAAAAAAAAAAAAAAAAAAAAAAAAAAAAAAAAAAAAAAAAAAAAAAAAAAAAAAAAAAAAAAAAAAAAAAAAAAAAAAAAAAAAAAAAAAAAAAAAAAAAAAAAAAAAAAAAAAAAAAAAAAAAAAAAAAAAAAAAAAAAAAAAAAAAAAAAAAAAAAAAAAAAAAAAAAAAAAAAAAAAAAAAAAAAAAAAAAAAAAAAAAAAAAAAAAAAAAAAAAAAAAAAAAAAAAAAAAAAAAAAAAAAAAAAAAAAAAAAAAAAAAAAAAAAAAAAAAAAAAAAAAAAAAAAAAAAAAAAAAAAAAAAAAAAAAAAAAAAAAAAAAAAAAAAAAAAAAAAAAAAAAAAAAAAAAAAAAAAAAAAAAAAAAAAAAAAAAAAAAAAAAAAAAAAAAAAAAAAAAAAAAAAAAAAAAAAAAAAAAAAAAAAAAAAAAAAAAAAAAAAAAAAAAAAAAAAAAAAAAAAAAAAAAAAAAAAAAAAAAAAAAAAAAAAAAAAAAAAAAAAAAAAAAAAAAAAAAAAAAAAAAAAAAAAAAAAAAAAAAAAAAAAAAAAAAAAAAAAAAAAAAAAAAAAAAAAAAAAAAAAAAAAAAAAAAAAAAAAAAAAAAAAAAAAAAAAAAAAAAAAAAAAAAAAAAAAAAAAAAAAAAAAAAAAAAAAAAAAAAAAAAAAAAAAAAAAAAAAAAAAAAAAAAAAAAAAAAAAAAAAAAAAAAAAAAAAAAAAAAAAAAAAAAAAAAAAAAAAAAAAAAAAAAAAAAAAAAAAAAAAAAAAAAAAAAAAAAAAAAAAAAAAAAAAAAAAAAAAAAAAAAAAAAAAAAAAAAAAAAAAAAAAAAAAAAAAAAAAAAAAAAAAAAAAAAAAAAAAAAAAAAAAAAAAAAAAAAAAAAAAAAAAAAAAAAAAAAAAAAAAAAAAAAAAAAAAAAAAAAAAAAAAAAAAAAAAAAAAAAAAAAAAAAAAAAAAAAAAAAAAAAAAAAAAAAAAAAAAAAAAAAAAAAAAAAAAAAAAAAAAAAAAAAAAAAAAAAAAAAAAAAAAAAAAAAAAAAAAAAAAAAAAAAAAAAAAAAAAAAAAAAAAAAAAAAAAAAAAAAAAAAAAAAAAAAAAAAAAAAAAAAAAAAAAAAAAAAAAAAAAAAAAAAAAAAAAAAAAAAAAAAAAAAAAAAAAAAAAAAAAAAAAAAAAAAAAAAAAAAAAAAAAAAAAAAAAAAAAAAAAAAAAAAAAAAAAAAAAAAAAAAAAAAAAAAAAAAAAAAAAAAAAAAAAAAAAAAAAAAAAAAAAAAAAAAAAAAAAAAAAAAAAAAAAAAAAAAAAAAAAAAAAAAAAAAAAAAAAAAAAAAAAAAAAAAAAAAAAAAAAAAAAAAAAAAAAAAAAAAAAAAAAAAAAAAAAAAAAAAAAAAAAAAAAAAAAAAAAAAAAAAAAAAAAAAAAAAAAAAAAAAAAAAAAAAAAAAAAAAAAAAAAAAAAAAAAAAAAAAAAAAAAAAAAAAAAAAAAAAAAAAAAAAAAAAAAAAAAAAAAAAAAAAAAAAAAAAAAAAAAAAAAAAAAAAAAAAAAAAAAAAAAAAAAAAAAAAAAAAAAAAAAAAAAAAAAAAAAAAAAAAAAAAAAAAAAAAAAAAAAAAAAAAAAAAAAAAAAAAAAAAAAAAAAAAAAAAAAAAAAAAAAAAAAAAAAAAAAAAAAAAAAAAAAAAAAAAAAAAAAAAAAAAAAAAAAAAAAAAAAAAAAAAAAAAAAAAAAAAAAAAAAAAAAAAAAAAAAAAAAAAAAAAAAAAAAAAAAAAAAAAAAAAAAAAAAAAAAAAAAAAAAAAAAAAAAAAAAAAAAAAAAAAAAAAAAAAAAAAAAAAAAAAAAAAAAAAAAAAAAAAAAAAAAAAAAAAAAAAAAAAAAAAAAAAAAAAAAAAAAAAAAAAAAAAAAAAAAAAAAAAAAAAAAAAAAAAAAAAAAAAAAAAAAAAAAAAAAAAAAAAAAAAAAAAAAAAAAAAAAAAAAAAAAAAAAAAAAAAAAAAAAAAAAAAAAAAAAAAAAAAAAAAAAAAAAAAAAAAAAAAAAAAAAAAAAAAAAAAAAAAAAAAAAAAAAAAAAAAAAAAAAAAAAAAAAAAAAAAAAAAAAAAAAAAAAAAAAAAAAAAAAAAAAAAAAAAAAAAAAAAAAAAAAAAAAAAAAAAAAAAAAAAAAAAAAAAAAAAAAAAAAAAAAAAAAAAAAAAAAAAAAAAAAAAAAAAAAAAAAAAAAAAAAAAAAAAAAAAAAAAAAAAAAAAAAAAAAAAAAAAAAAAAAAAAAAAAAAAAAAAAAAAAAAAAAAAAAAAAAAAAAAAAAAAAAAAAAAAAAAAAAAAAAAAAAAAAAAAAAAAAAAAAAAAAAAAAAAAAAAAAAAAAAAAAAAAAAAAAAAAAAAAAAAAAAAAAAAAAAAAAAAAAAAAAAAAAAAAAAAAAAAAAAAAAAAAAAAAAAAAAAAAAAAAAAAAAAAAAAAAAAAAAAAAAAAAAAAAAAAAAAAAAAAAAAAAAAAAAAAAAAAAAAAAAAAAAAAAAAAAAAAAAAAAAAAAAAAAAAAAAAAAAAAAAAAAAAAAAAAAAAAAAAAAAAAAAAAAAAAAAAAAAAAAAAAAAAAAAAAAAAAAAAAAAAAAAAAAAAAAAAAAAAAAAAAAAAAAAAAAAAAAAAAAAAAAAAAAAAAAAAAAAAAAAAAAAAAAAAAAAAAAAAAAAAAAAAAAAAAAAAAAAAAAAAAAAAAAAAAAAAAAAAAAAAAAAAAAAAAAAAAAAAAAAAAAAAAAAAAAAAAAAAAAAAAAAAAAAAAAAAAAAAAAAAAAAAAAAAAAAAAAAAAAAAAAAAAAAAAAAAAAAAAAAAAAAAAAAAAAAAAAAAAAAAAAAAAAAAAAAAAAAAAAAAAAAAAAAAAAAAAAAAAAAAAAAAAAAAAAAAAAAAAAAAAAAAAAAAAAAAAAAAAAAAAAAAAAAAAAAAAAAAAAAAAAAAAAAAAAAAAAAAAAAAAAAAAAAAAAAAAAAAAAAAAAAAAAAAAAAAAAAAAAAAAAAAAAAAAAAAAAAAAAAAAAAAAAAAAAAAAAAAAAAAAAAAAAAAAAAAAAAAAAAAAAAAAAAAAAAAAAAAAAAAAAAAAAAAAAAAAAAAAAAAAAAAAAAAAAAAAAAAAAAAAAAAAAAACAAAAAv//////////AQAAAAAAAAAAAAAAEQAAAFByb3BlcnR5RG9jdW1lbnRzAwAAAAAAAAAEAAAACQAAAF9pZD0kLl9pZAEDAAAAAAADAAAAAQADAAAAIwAAAENvbWJpSW5kZXg9JC5OYW1lICsgJ18nICsgJC5WZXJzaW9uAQUAAAAAAAUAAAABAAUAAAAAAAAAAP///////wAAAAAAAP////8AAAAAAP///////wAAAAAAAP////8AAAAAAP///////wAAAAAAAP////8AAAAAAP///////wAAAAAAAP////8AAAAAAP///////wAAAAAAAP////8AAAAAAP///////wAAAAAAAP////8AAAAAAP///////wAAAAAAAP////8AAAAAAP///////wAAAAAAAP////8AAAAAAP///////wAAAAAAAP////8AAAAAAP///////wAAAAAAAP////8AAAAAAP///////wAAAAAAAP////8AAAAAAP///////wAAAAAAAP////8AAAAAAP///////wAAAAAAAP////8AAAAAAP///////wAAAAAAAP////8AAAAAAAAAAAAAAAAAAAAAAAAAAAAAAAAAAAAAAAAAAAAAAAAAAAAAAAAAAAAAAAAAAAAAAAAAAAAAAAAAAAAAAAAAAAAAAAAAAAAAAAAAAAAAAAAAAAAAAAAAAAAAAAAAAAAAAAAAAAAAAAAAAAAAAAAAAAAAAAAAAAAAAAAAAAAAAAAAAAAAAAAAAAAAAAAAAAAAAAAAAAAAAAAAAAAAAAAAAAAAAAAAAAAAAAAAAAAAAAAAAAAAAAAAAAAAAAAAAAAAAAAAAAAAAAAAAAAAAAAAAAAAAAAAAAAAAAAAAAAAAAAAAAAAAAAAAAAAAAAAAAAAAAAAAAAAAAAAAAAAAAAAAAAAAAAAAAAAAAAAAAAAAAAAAAAAAAAAAAAAAAAAAAAAAAAAAAAAAAAAAAAAAAAAAAAAAAAAAAAAAAAAAAAAAAAAAAAAAAAAAAAAAAAAAAAAAAAAAAAAAAAAAAAAAAAAAAAAAAAAAAAAAAAAAAAAAAAAAAAAAAAAAAAAAAAAAAAAAAAAAAAAAAAAAAAAAAAAAAAAAAAAAAAAAAAAAAAAAAAAAAAAAAAAAAAAAAAAAAAAAAAAAAAAAAAAAAAAAAAAAAAAAAAAAAAAAAAAAAAAAAAAAAAAAAAAAAAAAAAAAAAAAAAAAAAAAAAAAAAAAAAAAAAAAAAAAAAAAAAAAAAAAAAAAAAAAAAAAAAAAAAAAAAAAAAAAAAAAAAAAAAAAAAAAAAAAAAAAAAAAAAAAAAAAAAAAAAAAAAAAAAAAAAAAAAAAAAAAAAAAAAAAAAAAAAAAAAAAAAAAAAAAAAAAAAAAAAAAAAAAAAAAAAAAAAAAAAAAAAAAAAAAAAAAAAAAAAAAAAAAAAAAAAAAAAAAAAAAAAAAAAAAAAAAAAAAAAAAAAAAAAAAAAAAAAAAAAAAAAAAAAAAAAAAAAAAAAAAAAAAAAAAAAAAAAAAAAAAAAAAAAAAAAAAAAAAAAAAAAAAAAAAAAAAAAAAAAAAAAAAAAAAAAAAAAAAAAAAAAAAAAAAAAAAAAAAAAAAAAAAAAAAAAAAAAAAAAAAAAAAAAAAAAAAAAAAAAAAAAAAAAAAAAAAAAAAAAAAAAAAAAAAAAAAAAAAAAAAAAAAAAAAAAAAAAAAAAAAAAAAAAAAAAAAAAAAAAAAAAAAAAAAAAAAAAAAAAAAAAAAAAAAAAAAAAAAAAAAAAAAAAAAAAAAAAAAAAAAAAAAAAAAAAAAAAAAAAAAAAAAAAAAAAAAAAAAAAAAAAAAAAAAAAAAAAAAAAAAAAAAAAAAAAAAAAAAAAAAAAAAAAAAAAAAAAAAAAAAAAAAAAAAAAAAAAAAAAAAAAAAAAAAAAAAAAAAAAAAAAAAAAAAAAAAAAAAAAAAAAAAAAAAAAAAAAAAAAAAAAAAAAAAAAAAAAAAAAAAAAAAAAAAAAAAAAAAAAAAAAAAAAAAAAAAAAAAAAAAAAAAAAAAAAAAAAAAAAAAAAAAAAAAAAAAAAAAAAAAAAAAAAAAAAAAAAAAAAAAAAAAAAAAAAAAAAAAAAAAAAAAAAAAAAAAAAAAAAAAAAAAAAAAAAAAAAAAAAAAAAAAAAAAAAAAAAAAAAAAAAAAAAAAAAAAAAAAAAAAAAAAAAAAAAAAAAAAAAAAAAAAAAAAAAAAAAAAAAAAAAAAAAAAAAAAAAAAAAAAAAAAAAAAAAAAAAAAAAAAAAAAAAAAAAAAAAAAAAAAAAAAAAAAAAAAAAAAAAAAAAAAAAAAAAAAAAAAAAAAAAAAAAAAAAAAAAAAAAAAAAAAAAAAAAAAAAAAAAAAAAAAAAAAAAAAAAAAAAAAAAAAAAAAAAAAAAAAAAAAAAAAAAAAAAAAAAAAAAAAAAAAAAAAAAAAAAAAAAAAAAAAAAAAAAAAAAAAAAAAAAAAAAAAAAAAAAAAAAAAAAAAAAAAAAAAAAAAAAAAAAAAAAAAAAAAAAAAAAAAAAAAAAAAAAAAAAAAAAAAAAAAAAAAAAAAAAAAAAAAAAAAAAAAAAAAAAAAAAAAAAAAAAAAAAAAAAAAAAAAAAAAAAAAAAAAAAAAAAAAAAAAAAAAAAAAAAAAAAAAAAAAAAAAAAAAAAAAAAAAAAAAAAAAAAAAAAAAAAAAAAAAAAAAAAAAAAAAAAAAAAAAAAAAAAAAAAAAAAAAAAAAAAAAAAAAAAAAAAAAAAAAAAAAAAAAAAAAAAAAAAAAAAAAAAAAAAAAAAAAAAAAAAAAAAAAAAAAAAAAAAAAAAAAAAAAAAAAAAAAAAAAAAAAAAAAAAAAAAAAAAAAAAAAAAAAAAAAAAAAAAAAAAAAAAAAAAAAAAAAAAAAAAAAAAAAAAAAAAAAAAAAAAAAAAAAAAAAAAAAAAAAAAAAAAAAAAAAAAAAAAAAAAAAAAAAAAAAAAAAAAAAAAAAAAAAAAAAAAAAAAAAAAAAAAAAAAAAAAAAAAAAAAAAAAAAAAAAAAAAAAAAAAAAAAAAAAAAAAAAAAAAAAAAAAAAAAAAAAAAAAAAAAAAAAAAAAAAAAAAAAAAAAAAAAAAAAAAAAAAAAAAAAAAAAAAAAAAAAAAAAAAAAAAAAAAAAAAAAAAAAAAAAAAAAAAAAAAAAAAAAAAAAAAAAAAAAAAAAAAAAAAAAAAAAAAAAAAAAAAAAAAAAAAAAAAAAAAAAAAAAAAAAAAAAAAAAAAAAAAAAAAAAAAAAAAAAAAAAAAAAAAAAAAAAAAAAAAAAAAAAAAAAAAAAAAAAAAAAAAAAAAAAAAAAAAAAAAAAAAAAAAAAAAAAAAAAAAAAAAAAAAAAAAAAAAAAAAAAAAAAAAAAAAAAAAAAAAAAAAAAAAAAAAAAAAAAAAAAAAAAAAAAAAAAAAAAAAAAAAAAAAAAAAAAAAAAAAAAAAAAAAAAAAAAAAAAAAAAAAAAAAAAAAAAAAAAAAAAAAAAAAAAAAAAAAAAAAAAAAAAAAAAAAAAAAAAAAAAAAAAAAAAAAAAAAAAAAAAAAAAAAAAAAAAAAAAAAAAAAAAAAAAAAAAAAAAAAAAAAAAAAAAAAAAAAAAAAAAAAAAAAAAAAAAAAAAAAAAAAAAAAAAAAAAAAAAAAAAAAAAAAAAAAAAAAAAAAAAAAAAAAAAAAAAAAAAAAAAAAAAAAAAAAAAAAAAAAAAAAAAAAAAAAAAAAAAAAAAAAAAAAAAAAAAAAAAAAAAAAAAAAAAAAAAAAAAAAAAAAAAAAAAAAAAAAAAAAAAAAAAAAAAAAAAAAAAAAAAAAAAAAAAAAAAAAAAAAAAAAAAAAAAAAAAAAAAAAAAAAAAAAAAAAAAAAAAAAAAAAAAAAAAAAAAAAAAAAAAAAAAAAAAAAAAAAAAAAAAAAAAAAAAAAAAAAAAAAAAAAAAAAAAAAAAAAAAAAAAAAAAAAAAAAAAAAAAAAAAAAAAAAAAAAAAAAAAAAAAAAAAAAAAAAAAAAAAAAAAAAAAAAAAAAAAAAAAAAAAAAAAAAAAAAAAAAAAAAAAAAAAAAAAAAAAAAAAAAAAAAAAAAAAAAAAAAAAAAAAAAAAAAAAAAAAAAAAAAAAAAAAAAAAAAAAAAAAAAAAAAAAAAAAAAAAAAAAAAAAAAAAAAAAAAAAAAAAAAAAAAAAAAAAAAAAAAAAAAAAAAAAAAAAAAAAAAAAAAAAAAAAAAAAAAAAAAAAAAAAAAAAAAAAAAAAAAAAAAAAAAAAAAAAAAAAAAAAAAAAAAAAAAAAAAAAAAAAAAAAAAAAAAAAAAAAAAAAAAAAAAAAAAAAAAAAAAAAAAAAAAAAAAAAAAAAAAAAAAAAAAAAAAAAAAAAAAAAAAAAAAAAAAAAAAAAAAAAAAAAAAAAAAAAAAAAAAAAAAAAAAAAAAAAAAAAAAAAAAAAAAAAAAAAAAAAAAAAAAAAAAAAAAAAAAAAAAAAAAAAAAAAAAAAAAAAAAAAAAAAAAAAAAAAAAAAAAAAAAAAAAAAAAAAAAAAAAAAAAAAAAAAAAAAAAAAAAAAAAAAAAAAAAAAAAAAAAAAAAAAAAAAAAAAAAAAAAAAAAAAAAAAAAAAAAAAAAAAAAAAAAAAAAAAAAAAAAAAAAAAAAAAAAAAAAAAAAAAAAAAAAAAAAAAAAAAAAAAAAAAAAAAAAAAAAAAAAAAAAAAAAAAAAAAAAAAAAAAAAAAAAAAAAAAAAAAAAAAAAAAAAAAAAAAAAAAAAAAAAAAAAAAAAAAAAAAAAAAAAAAAAAAAAAAAAAAAAAAAAAAAAAAAAAAAAAAAAAAAAAAAAAAAAAAAAAAAAAAAAAAAAAAAAAAAAAAAAAAAAAAAAAAAAAAAAAAAAAAAAAAAAAAAAAAAAAAAAAAAAAAAAAAAAAAAAAAAAAAAAAAAAAAAAAAAAAAAAAAAAAAAAAAAAAAAAAAAAAAAAAAAAAAAAAAAAAAAAAAAAAAAAAAAAAAAAAAAAAAAAAAAAAAAAAAAAAAAAAAAAAAAAAAAAAAAAAAAAAAAAAAAAAAAAAAAAAAAAAAAAAAAAAAAAAAAAAAAAAAAAAAAAAAAAAAAAAAAAAAAAAAAAAAAAAAAAAAAAAAAAAAAAAAAAAAAAAAAAAAAAAAAAAAAAAAAAAAAAAAAAAAAAAAAAAAAAAAAAAAAAAAAAAAAAAAAAAAAAAAAAAAAAAAAAAAAAAAAAAAAAAAAAAAAAAAAAAAAAAAAAAAAAAAAAAAAAAAAAAAAAAAAAAAAAAAAAAAAAAAAAAAAAAAAAAAAAAAAAAAAAAAAAAAAAAAAAAAAAAAAAAAAAAAAAAAAAAAAAAAAAAAAAAAAAAAAAAAAAAAAAAAAAAAAAAAAAAAAAAAAAAAAAAAAAAAAAAAAAAAAAAAAAAAAAAAAAAAAAAAAAAAAAAAAAAAACAMBAQEBAQEBAQEBAQEBAQMAAAAAAAAAAwAAAAMAAAAA/////wUAqgsAAAAAAAAAAAAAIAD///////////////8AAAD///////////////8DAAAAAgD///////8DAAAAAgD///////8DAAAAAwD///////8DAAAAAwD///////8DAAAAAwD///////8DAAAAAwD///////8DAAAAAwD///////8DAAAAAwD///////////////////////////////////////////////////////////////////////////////////////////////////////////////////////////////////////////////////////////////////////////////////////////////////////////////////////////////////////////////////////////////////////////////////////////////////////////////////////////////////////////////////////////////////////////////////////////////8BACAA////////////////AAAO////////AwAAAAQA////////////////////////////////////////////////////////////////////////////////////////////////////////////////////////////////////////////////////////////////////////////////////////////////////////////////////////////////////////////////////////////////////////////////////////////////////////////////////////////////////////////////////////////////////////////////////////////////////////////////////////////////////////////////////////////////////////////////////////////////////////////////////////AgACAP///////wUAAAACABAAC1mughhiz4lAiJICcyQCQ1cEAAAAAAADAAAAAAADAAAAAwADAAAAAAADAAAAAwADAAgA////////BQAAAAMAEAALYtgDXrjXu0m71Zb3wITk6QQAAAABAAMAAAACAAMAAAAEAAMAAAACAAMAAAAEAAMAAAAAAP///////wMAAAAAAP///////wMAAAAAAP///////wMAAAAAAP///////wMAAAAAAP///////wMAAAAAAP///////wQAAgD///////8FAAAABAAQAAuC/tz/M39cSryCmsDXLyS3BAAAAAIAAwAAAAMAAwAAAAEAAwAAAAMA////////AAAAAAAAAAAAAAAAAAAAAAAAAAAAAAAAAAAAAAAAAAAAAAAAAAAAAAAAAAAAAAAAAAAAAAAAAAAAAAAAAAAAAAAAAAAAAAAAAAAAAAAAAAAAAAAAAAAAAAAAAAAAAAAAAAAAAAAAAAAAAAAAAAAAAAAAAAAAAAAAAAAAAAAAAAAAAAAAAAAAAAAAAAAAAAAAAAAAAAAAAAAAAAAAAAAAAAAAAAAAAAAAAAAAAAAAAAAAAAAAAAAAAAAAAAAAAAAAAAAAAAAAAAAAAAAAAAAAAAAAAAAAAAAAAAAAAAAAAAAAAAAAAAAAAAAAAAAAAAAAAAAAAAAAAAAAAAAAAAAAAAAAAAAAAAAAAAAAAAAAAAAAAAAAAAAAAAAAAAAAAAAAAAAAAAAAAAAAAAAAAAAAAAAAAAAAAAAAAAAAAAAAAAAAAAAAAAAAAAAAAAAAAAAAAAAAAAAAAAAAAAAAAAAAAAAAAAAAAAAAAAAAAAAAAAAAAAAAAAAAAAAAAAAAAAAAAAAAAAAAAAAAAAAAAAAAAAAAAAAAAAAAAAAAAAAAAAAAAAAAAAAAAAAAAAAAAAAAAAAAAAAAAAAAAAAAAAAAAAAAAAAAAAAAAAAAAAAAAAAAAAAAAAAAAAAAAAAAAAAAAAAAAAAAAAAAAAAAAAAAAAAAAAAAAAAAAAAAAAAAAAAAAAAAAAAAAAAAAAAAAAAAAAAAAAAAAAAAAAAAAAAAAAAAAAAAAAAAAAAAAAAAAAAAAAAAAAAAAAAAAAAAAAAAAAAAAAAAAAAAAAAAAAAAAAAAAAAAAAAAAAAAAAAAAAAAAAAAAAAAAAAAAAAAAAAAAAAAAAAAAAAAAAAAAAAAAAAAAAAAAAAAAAAAAAAAAAAAAAAAAAAAAAAAAAAAAAAAAAAAAAAAAAAAAAAAAAAAAAAAAAAAAAAAAAAAAAAAAAAAAAAAAAAAAAAAAAAAAAAAAAAAAAAAAAAAAAAAAAAAAAAAAAAAAAAAAAAAAAAAAAAAAAAAAAAAAAAAAAAAAAAAAAAAAAAAAAAAAAAAAAAAAAAAAAAAAAAAAAAAAAAAAAAAAAAAAAAAAAAAAAAAAAAAAAAAAAAAAAAAAAAAAAAAAAAAAAAAAAAAAAAAAAAAAAAAAAAAAAAAAAAAAAAAAAAAAAAAAAAAAAAAAAAAAAAAAAAAAAAAAAAAAAAAAAAAAAAAAAAAAAAAAAAAAAAAAAAAAAAAAAAAAAAAAAAAAAAAAAAAAAAAAAAAAAAAAAAAAAAAAAAAAAAAAAAAAAAAAAAAAAAAAAAAAAAAAAAAAAAAAAAAAAAAAAAAAAAAAAAAAAAAAAAAAAAAAAAAAAAAAAAAAAAAAAAAAAAAAAAAAAAAAAAAAAAAAAAAAAAAAAAAAAAAAAAAAAAAAAAAAAAAAAAAAAAAAAAAAAAAAAAAAAAAAAAAAAAAAAAAAAAAAAAAAAAAAAAAAAAAAAAAAAAAAAAAAAAAAAAAAAAAAAAAAAAAAAAAAAAAAAAAAAAAAAAAAAAAAAAAAAAAAAAAAAAAAAAAAAAAAAAAAAAAAAAAAAAAAAAAAAAAAAAAAAAAAAAAAAAAAAAAAAAAAAAAAAAAAAAAAAAAAAAAAAAAAAAAAAAAAAAAAAAAAAAAAAAAAAAAAAAAAAAAAAAAAAAAAAAAAAAAAAAAAAAAAAAAAAAAAAAAAAAAAAAAAAAAAAAAAAAAAAAAAAAAAAAAAAAAAAAAAAAAAAAAAAAAAAAAAAAAAAAAAAAAAAAAAAAAAAAAAAAAAAAAAAAAAAAAAAAAAAAAAAAAAAAAAAAAAAAAAAAAAAAAAAAAAAAAAAAAAAAAAAAAAAAAAAAAAAAAAAAAAAAAAAAAAAAAAAAAAAAAAAAAAAAAAAAAAAAAAAAAAAAAAAAAAAAAAAAAAAAAAAAAAAAAAAAAAAAAAAAAAAAAAAAAAAAAAAAAAAAAAAAAAAAAAAAAAAAAAAAAAAAAAAAAAAAAAAAAAAAAAAAAAAAAAAAAAAAAAAAAAAAAAAAAAAAAAAAAAAAAAAAAAAAAAAAAAAAAAAAAAAAAAAAAAAAAAAAAAAAAAAAAAAAAAAAAAAAAAAAAAAAAAAAAAAAAAAAAAAAAAAAAAAAAAAAAAAAAAAAAAAAAAAAAAAAAAAAAAAAAAAAAAAAAAAAAAAAAAAAAAAAAAAAAAAAAAAAAAAAAAAAAAAAAAAAAAAAAAAAAAAAAAAAAAAAAAAAAAAAAAAAAAAAAAAAAAAAAAAAAAAAAAAAAAAAAAAAAAAAAAAAAAAAAAAAAAAAAAAAAAAAAAAAAAAAAAAAAAAAAAAAAAAAAAAAAAAAAAAAAAAAAAAAAAAAAAAAAAAAAAAAAAAAAAAAAAAAAAAAAAAAAAAAAAAAAAAAAAAAAAAAAAAAAAAAAAAAAAAAAAAAAAAAAAAAAAAAAAAAAAAAAAAAAAAAAAAAAAAAAAAAAAAAAAAAAAAAAAAAAAAAAAAAAAAAAAAAAAAAAAAAAAAAAAAAAAAAAAAAAAAAAAAAAAAAAAAAAAAAAAAAAAAAAAAAAAAAAAAAAAAAAAAAAAAAAAAAAAAAAAAAAAAAAAAAAAAAAAAAAAAAAAAAAAAAAAAAAAAAAAAAAAAAAAAAAAAAAAAAAAAAAAAAAAAAAAAAAAAAAAAAAAAAAAAAAAAAAAAAAAAAAAAAAAAAAAAAAAAAAAAAAAAAAAAAAAAAAAAAAAAAAAAAAAAAAAAAAAAAAAAAAAAAAAAAAAAAAAAAAAAAAAAAAAAAAAAAAAAAAAAAAAAAAAAAAAAAAAAAAAAAAAAAAAAAAAAAAAAAAAAAAAAAAAAAAAAAAAAAAAAAAAAAAAAAAAAAAAAAAAAAAAAAAAAAAAAAAAAAAAAAAAAAAAAAAAAAAAAAAAAAAAAAAAAAAAAAAAAAAAAAAAAAAAAAAAAAAAAAAAAAAAAAAAAAAAAAAAAAAAAAAAAAAAAAAAAAAAAAAAAAAAAAAAAAAAAAAAAAAAAAAAAAAAAAAAAAAAAAAAAAAAAAAAAAAAAAAAAAAAAAAAAAAAAAAAAAAAAAAAAAAAAAAAAAAAAAAAAAAAAAAAAAAAAAAAAAAAAAAAAAAAAAAAAAAAAAAAAAAAAAAAAAAAAAAAAAAAAAAAAAAAAAAAAAAAAAAAAAAAAAAAAAAAAAAAAAAAAAAAAAAAAAAAAAAAAAAAAAAAAAAAAAAAAAAAAAAAAAAAAAAAAAAAAAAAAAAAAAAAAAAAAAAAAAAAAAAAAAAAAAAAAAAAAAAAAAAAAAAAAAAAAAAAAAAAAAAAAAAAAAAAAAAAAAAAAAAAAAAAAAAAAAAAAAAAAAAAAAAAAAAAAAAAAAAAAAAAAAAAAAAAAAAAAAAAAAAAAAAAAAAAAAAAAAAAAAAAAAAAAAAAAAAAAAAAAAAAAAAAAAAAAAAAAAAAAAAAAAAAAAAAAAAAAAAAAAAAAAAAAAAAAAAAAAAAAAAAAAAAAAAAAAAAAAAAAAAAAAAAAAAAAAAAAAAAAAAAAAAAAAAAAAAAAAAAAAAAAAAAAAAAAAAAAAAAAAAAAAAAAAAAAAAAAAAAAAAAAAAAAAAAAAAAAAAAAAAAAAAAAAAAAAAAAAAAAAAAAAAAAAAAAAAAAAAAAAAAAAAAAAAAAAAAAAAAAAAAAAAAAAAAAAAAAAAAAAAAAAAAAAAAAAAAAAAAAAAAAAAAAAAAAAAAAAAAAAAAAAAAAAAAAAAAAAAAAAAAAAAAAAAAAAAAAAAAAAAAAAAAAAAAAAAAAAAAAAAAAAAAAAAAAAAAAAAAAAAAAAAAAAAAAAAAAAAAAAAAAAAAAAAAAAAAAAAAAAAAAAAAAAAAAAAAAAAAAAAAAAAAAAAAAAAAAAAAAAAAAAAAAAAAAAAAAAAAAAAAAAAAAAAAAAAAAAAAAAAAAAAAAAAAAAAAAAAAAAAAAAAAAAAAAAAAAAAAAAAAAAAAAAAAAAAAAAAAAAAAAAAAAAAAAAAAAAAAAQAAAAEAAAAAP////8DAAMOAAAAAAAAAAAAAP/////GAMYAAAAFX2lkABAAAAAEWa6CGGLPiUCIkgJzJAJDVwNEYXRhAFMAAAAIUHJlc2VudGF0aW9uU2Nhbm5lZEZvckxpbmtlZFNoYXBlcwAAAk51bWJlckZvcm1hdFNlcGFyYXRvck1vZGUACgAAAEF1dG9tYXRpYwAAAk5hbWUAJAAAAExpbmtlZFNoYXBlUHJlc2VudGF0aW9uU2V0dGluZ3NEYXRhABBWZXJzaW9uAAAAAAAJTGFzdFdyaXRlAMTUOuqNAQAAAAEA/////4MAgwAAAAVfaWQAEAAAAARi2ANeuNe7SbvVlvfAhOTpA0RhdGEAGwAAAARMaW5rZWRTaGFwZURhdGEABQAAAAAAAk5hbWUAGQAAAExpbmtlZFNoYXBlc0RhdGFQcm9wZXJ0eQAQVmVyc2lvbgABAAAACUxhc3RXcml0ZQC01DrqjQEAAAACAP////+DAIMAAAAFX2lkABAAAAAEgv7c/zN/XEq8gprA1y8ktwNEYXRhABsAAAAETGlua2VkU2hhcGVEYXRhAAUAAAAAAAJOYW1lABkAAABMaW5rZWRTaGFwZXNEYXRhUHJvcGVydHkAEFZlcnNpb24AAAAAAAlMYXN0V3JpdGUActQ66o0BAAAAAAAAAAAAAAAAAAAAAAAAAAAAAAAAAAAAAAAAAAAAAAAAAAAAAAAAAAAAAAAAAAAAAAAAAAAAAAAAAAAAAAAAAAAAAAAAAAAAAAAAAAAAAAAAAAAAAAAAAAAAAAAAAAAAAAAAAAAAAAAAAAAAAAAAAAAAAAAAAAAAAAAAAAAAAAAAAAAAAAAAAAAAAAAAAAAAAAAAAAAAAAAAAAAAAAAAAAAAAAAAAAAAAAAAAAAAAAAAAAAAAAAAAAAAAAAAAAAAAAAAAAAAAAAAAAAAAAAAAAAAAAAAAAAAAAAAAAAAAAAAAAAAAAAAAAAAAAAAAAAAAAAAAAAAAAAAAAAAAAAAAAAAAAAAAAAAAAAAAAAAAAAAAAAAAAAAAAAAAAAAAAAAAAAAAAAAAAAAAAAAAAAAAAAAAAAAAAAAAAAAAAAAAAAAAAAAAAAAAAAAAAAAAAAAAAAAAAAAAAAAAAAAAAAAAAAAAAAAAAAAAAAAAAAAAAAAAAAAAAAAAAAAAAAAAAAAAAAAAAAAAAAAAAAAAAAAAAAAAAAAAAAAAAAAAAAAAAAAAAAAAAAAAAAAAAAAAAAAAAAAAAAAAAAAAAAAAAAAAAAAAAAAAAAAAAAAAAAAAAAAAAAAAAAAAAAAAAAAAAAAAAAAAAAAAAAAAAAAAAAAAAAAAAAAAAAAAAAAAAAAAAAAAAAAAAAAAAAAAAAAAAAAAAAAAAAAAAAAAAAAAAAAAAAAAAAAAAAAAAAAAAAAAAAAAAAAAAAAAAAAAAAAAAAAAAAAAAAAAAAAAAAAAAAAAAAAAAAAAAAAAAAAAAAAAAAAAAAAAAAAAAAAAAAAAAAAAAAAAAAAAAAAAAAAAAAAAAAAAAAAAAAAAAAAAAAAAAAAAAAAAAAAAAAAAAAAAAAAAAAAAAAAAAAAAAAAAAAAAAAAAAAAAAAAAAAAAAAAAAAAAAAAAAAAAAAAAAAAAAAAAAAAAAAAAAAAAAAAAAAAAAAAAAAAAAAAAAAAAAAAAAAAAAAAAAAAAAAAAAAAAAAAAAAAAAAAAAAAAAAAAAAAAAAAAAAAAAAAAAAAAAAAAAAAAAAAAAAAAAAAAAAAAAAAAAAAAAAAAAAAAAAAAAAAAAAAAAAAAAAAAAAAAAAAAAAAAAAAAAAAAAAAAAAAAAAAAAAAAAAAAAAAAAAAAAAAAAAAAAAAAAAAAAAAAAAAAAAAAAAAAAAAAAAAAAAAAAAAAAAAAAAAAAAAAAAAAAAAAAAAAAAAAAAAAAAAAAAAAAAAAAAAAAAAAAAAAAAAAAAAAAAAAAAAAAAAAAAAAAAAAAAAAAAAAAAAAAAAAAAAAAAAAAAAAAAAAAAAAAAAAAAAAAAAAAAAAAAAAAAAAAAAAAAAAAAAAAAAAAAAAAAAAAAAAAAAAAAAAAAAAAAAAAAAAAAAAAAAAAAAAAAAAAAAAAAAAAAAAAAAAAAAAAAAAAAAAAAAAAAAAAAAAAAAAAAAAAAAAAAAAAAAAAAAAAAAAAAAAAAAAAAAAAAAAAAAAAAAAAAAAAAAAAAAAAAAAAAAAAAAAAAAAAAAAAAAAAAAAAAAAAAAAAAAAAAAAAAAAAAAAAAAAAAAAAAAAAAAAAAAAAAAAAAAAAAAAAAAAAAAAAAAAAAAAAAAAAAAAAAAAAAAAAAAAAAAAAAAAAAAAAAAAAAAAAAAAAAAAAAAAAAAAAAAAAAAAAAAAAAAAAAAAAAAAAAAAAAAAAAAAAAAAAAAAAAAAAAAAAAAAAAAAAAAAAAAAAAAAAAAAAAAAAAAAAAAAAAAAAAAAAAAAAAAAAAAAAAAAAAAAAAAAAAAAAAAAAAAAAAAAAAAAAAAAAAAAAAAAAAAAAAAAAAAAAAAAAAAAAAAAAAAAAAAAAAAAAAAAAAAAAAAAAAAAAAAAAAAAAAAAAAAAAAAAAAAAAAAAAAAAAAAAAAAAAAAAAAAAAAAAAAAAAAAAAAAAAAAAAAAAAAAAAAAAAAAAAAAAAAAAAAAAAAAAAAAAAAAAAAAAAAAAAAAAAAAAAAAAAAAAAAAAAAAAAAAAAAAAAAAAAAAAAAAAAAAAAAAAAAAAAAAAAAAAAAAAAAAAAAAAAAAAAAAAAAAAAAAAAAAAAAAAAAAAAAAAAAAAAAAAAAAAAAAAAAAAAAAAAAAAAAAAAAAAAAAAAAAAAAAAAAAAAAAAAAAAAAAAAAAAAAAAAAAAAAAAAAAAAAAAAAAAAAAAAAAAAAAAAAAAAAAAAAAAAAAAAAAAAAAAAAAAAAAAAAAAAAAAAAAAAAAAAAAAAAAAAAAAAAAAAAAAAAAAAAAAAAAAAAAAAAAAAAAAAAAAAAAAAAAAAAAAAAAAAAAAAAAAAAAAAAAAAAAAAAAAAAAAAAAAAAAAAAAAAAAAAAAAAAAAAAAAAAAAAAAAAAAAAAAAAAAAAAAAAAAAAAAAAAAAAAAAAAAAAAAAAAAAAAAAAAAAAAAAAAAAAAAAAAAAAAAAAAAAAAAAAAAAAAAAAAAAAAAAAAAAAAAAAAAAAAAAAAAAAAAAAAAAAAAAAAAAAAAAAAAAAAAAAAAAAAAAAAAAAAAAAAAAAAAAAAAAAAAAAAAAAAAAAAAAAAAAAAAAAAAAAAAAAAAAAAAAAAAAAAAAAAAAAAAAAAAAAAAAAAAAAAAAAAAAAAAAAAAAAAAAAAAAAAAAAAAAAAAAAAAAAAAAAAAAAAAAAAAAAAAAAAAAAAAAAAAAAAAAAAAAAAAAAAAAAAAAAAAAAAAAAAAAAAAAAAAAAAAAAAAAAAAAAAAAAAAAAAAAAAAAAAAAAAAAAAAAAAAAAAAAAAAAAAAAAAAAAAAAAAAAAAAAAAAAAAAAAAAAAAAAAAAAAAAAAAAAAAAAAAAAAAAAAAAAAAAAAAAAAAAAAAAAAAAAAAAAAAAAAAAAAAAAAAAAAAAAAAAAAAAAAAAAAAAAAAAAAAAAAAAAAAAAAAAAAAAAAAAAAAAAAAAAAAAAAAAAAAAAAAAAAAAAAAAAAAAAAAAAAAAAAAAAAAAAAAAAAAAAAAAAAAAAAAAAAAAAAAAAAAAAAAAAAAAAAAAAAAAAAAAAAAAAAAAAAAAAAAAAAAAAAAAAAAAAAAAAAAAAAAAAAAAAAAAAAAAAAAAAAAAAAAAAAAAAAAAAAAAAAAAAAAAAAAAAAAAAAAAAAAAAAAAAAAAAAAAAAAAAAAAAAAAAAAAAAAAAAAAAAAAAAAAAAAAAAAAAAAAAAAAAAAAAAAAAAAAAAAAAAAAAAAAAAAAAAAAAAAAAAAAAAAAAAAAAAAAAAAAAAAAAAAAAAAAAAAAAAAAAAAAAAAAAAAAAAAAAAAAAAAAAAAAAAAAAAAAAAAAAAAAAAAAAAAAAAAAAAAAAAAAAAAAAAAAAAAAAAAAAAAAAAAAAAAAAAAAAAAAAAAAAAAAAAAAAAAAAAAAAAAAAAAAAAAAAAAAAAAAAAAAAAAAAAAAAAAAAAAAAAAAAAAAAAAAAAAAAAAAAAAAAAAAAAAAAAAAAAAAAAAAAAAAAAAAAAAAAAAAAAAAAAAAAAAAAAAAAAAAAAAAAAAAAAAAAAAAAAAAAAAAAAAAAAAAAAAAAAAAAAAAAAAAAAAAAAAAAAAAAAAAAAAAAAAAAAAAAAAAAAAAAAAAAAAAAAAAAAAAAAAAAAAAAAAAAAAAAAAAAAAAAAAAAAAAAAAAAAAAAAAAAAAAAAAAAAAAAAAAAAAAAAAAAAAAAAAAAAAAAAAAAAAAAAAAAAAAAAAAAAAAAAAAAAAAAAAAAAAAAAAAAAAAAAAAAAAAAAAAAAAAAAAAAAAAAAAAAAAAAAAAAAAAAAAAAAAAAAAAAAAAAAAAAAAAAAAAAAAAAAAAAAAAAAAAAAAAAAAAAAAAAAAAAAAAAAAAAAAAAAAAAAAAAAAAAAAAAAAAAAAAAAAAAAAAAAAAAAAAAAAAAAAAAAAAAAAAAAAAAAAAAAAAAAAAAAAAAAAAAAAAAAAAAAAAAAAAAAAAAAAAAAAAAAAAAAAAAAAAAAAAAAAAAAAAAAAAAAAAAAAAAAAAAAAAAAAAAAAAAAAAAAAAAAAAAAAAAAAAAAAAAAAAAAAAAAAAAAAAAAAAAAAAAAAAAAAAAAAAAAAAAAAAAAAAAAAAAAAAAAAAAAAAAAAAAAAAAAAAAAAAAAAAAAAAAAAAAAAAAAAAAAAAAAAAAAAAAAAAAAAAAAAAAAAAAAAAAAAAAAAAAAAAAAAAAAAAAAAAAAAAAAAAAAAAAAAAAAAAAAAAAAAAAAAAAAAAAAAAAAAAAAAAAAAAAAAAAAAAAAAAAAAAAAAAAAAAAAAAAAAAAAAAAAAAAAAAAAAAAAAAAAAAAAAAAAAAAAAAAAAAAAAAAAAAAAAAAAAAAAAAAAAAAAAAAAAAAAAAAAAAAAAAAAAAAAAAAAAAAAAAAAAAAAAAAAAAAAAAAAAAAAAAAAAAAAAAAAAAAAAAAAAAAAAAAAAAAAAAAAAAAAAAAAAAAAAAAAAAAAAAAAAAAAAAAAAAAAAAAAAAAAAAAAAAAAAAAAAAAAAAAAAAAAAAAAAAAAAAAAAAAAAAAAAAAAAAAAAAAAAAAAAAAAAAAAAAAAAAAAAAAAAAAAAAAAAAAAAAAAAAAAAAAAAAAAAAAAAAAAAAAAAAAAAAAAAAAAAAAAAAAAAAAAAAAAAAAAAAAAAAAAAAAAAAAAAAAAAAAAAAAAAAAAAAAAAAAAAAAAAAAAAAAAAAAAAAAAAAAAAAAAAAAAAAAAAAAAAAAAAAAAAAAAAAAAAAAAAAAAAAAAAAAAAAAAAAAAAAAAAAAAAAAAAAAAAFAAAAAwAAAAD/////BQDJCwAAAAAAAAAAAAAgAf///////////////wAAAP///////////////wUAAAACAP///////wUAAAACAP///////wUAAAADAP///////////////////////////////////////////////////////////////////////////////////////////////////////////////////////////////////////////////////////////////////////////////////////////////////////////////////////////////////////////////////////////////////////////////////////////////////////////////////////////////////////////////////////////////////////////////////////////////////////////////////////////////////////////////////////////////////////////////wEAIAH///////////////8AAA7///////8FAAAAAwD///////////////////////////////////////////////////////////////////////////////////////////////////////////////////////////////////////////////////////////////////////////////////////////////////////////////////////////////////////////////////////////////////////////////////////////////////////////////////////////////////////////////////////////////////////////////////////////////////////////////////////////////////////////////////////////////////////////////////////////////////////////////////////8CAAIBAwAAAAIA////////JQAGTGlua2VkU2hhcGVQcmVzZW50YXRpb25TZXR0aW5nc0RhdGFfMAQAAAAAAAUAAAAAAAUAAAAEAAUAAAAAAAUAAAADAAMAAwEDAAAAAwD///////8aAAZMaW5rZWRTaGFwZXNEYXRhUHJvcGVydHlfMQQAAAABAAUAAAAEAAUAAAABAAUAAAACAP///////wUAAAAAAP///////wQAAQEDAAAABAD///////8aAAZMaW5rZWRTaGFwZXNEYXRhUHJvcGVydHlfMAQAAAACAAUAAAACAAUAAAADAAAAAAAAAAAAAAAAAAAAAAAAAAAAAAAAAAAAAAAAAAAAAAAAAAAAAAAAAAAAAAAAAAAAAAAAAAAAAAAAAAAAAAAAAAAAAAAAAAAAAAAAAAAAAAAAAAAAAAAAAAAAAAAAAAAAAAAAAAAAAAAAAAAAAAAAAAAAAAAAAAAAAAAAAAAAAAAAAAAAAAAAAAAAAAAAAAAAAAAAAAAAAAAAAAAAAAAAAAAAAAAAAAAAAAAAAAAAAAAAAAAAAAAAAAAAAAAAAAAAAAAAAAAAAAAAAAAAAAAAAAAAAAAAAAAAAAAAAAAAAAAAAAAAAAAAAAAAAAAAAAAAAAAAAAAAAAAAAAAAAAAAAAAAAAAAAAAAAAAAAAAAAAAAAAAAAAAAAAAAAAAAAAAAAAAAAAAAAAAAAAAAAAAAAAAAAAAAAAAAAAAAAAAAAAAAAAAAAAAAAAAAAAAAAAAAAAAAAAAAAAAAAAAAAAAAAAAAAAAAAAAAAAAAAAAAAAAAAAAAAAAAAAAAAAAAAAAAAAAAAAAAAAAAAAAAAAAAAAAAAAAAAAAAAAAAAAAAAAAAAAAAAAAAAAAAAAAAAAAAAAAAAAAAAAAAAAAAAAAAAAAAAAAAAAAAAAAAAAAAAAAAAAAAAAAAAAAAAAAAAAAAAAAAAAAAAAAAAAAAAAAAAAAAAAAAAAAAAAAAAAAAAAAAAAAAAAAAAAAAAAAAAAAAAAAAAAAAAAAAAAAAAAAAAAAAAAAAAAAAAAAAAAAAAAAAAAAAAAAAAAAAAAAAAAAAAAAAAAAAAAAAAAAAAAAAAAAAAAAAAAAAAAAAAAAAAAAAAAAAAAAAAAAAAAAAAAAAAAAAAAAAAAAAAAAAAAAAAAAAAAAAAAAAAAAAAAAAAAAAAAAAAAAAAAAAAAAAAAAAAAAAAAAAAAAAAAAAAAAAAAAAAAAAAAAAAAAAAAAAAAAAAAAAAAAAAAAAAAAAAAAAAAAAAAAAAAAAAAAAAAAAAAAAAAAAAAAAAAAAAAAAAAAAAAAAAAAAAAAAAAAAAAAAAAAAAAAAAAAAAAAAAAAAAAAAAAAAAAAAAAAAAAAAAAAAAAAAAAAAAAAAAAAAAAAAAAAAAAAAAAAAAAAAAAAAAAAAAAAAAAAAAAAAAAAAAAAAAAAAAAAAAAAAAAAAAAAAAAAAAAAAAAAAAAAAAAAAAAAAAAAAAAAAAAAAAAAAAAAAAAAAAAAAAAAAAAAAAAAAAAAAAAAAAAAAAAAAAAAAAAAAAAAAAAAAAAAAAAAAAAAAAAAAAAAAAAAAAAAAAAAAAAAAAAAAAAAAAAAAAAAAAAAAAAAAAAAAAAAAAAAAAAAAAAAAAAAAAAAAAAAAAAAAAAAAAAAAAAAAAAAAAAAAAAAAAAAAAAAAAAAAAAAAAAAAAAAAAAAAAAAAAAAAAAAAAAAAAAAAAAAAAAAAAAAAAAAAAAAAAAAAAAAAAAAAAAAAAAAAAAAAAAAAAAAAAAAAAAAAAAAAAAAAAAAAAAAAAAAAAAAAAAAAAAAAAAAAAAAAAAAAAAAAAAAAAAAAAAAAAAAAAAAAAAAAAAAAAAAAAAAAAAAAAAAAAAAAAAAAAAAAAAAAAAAAAAAAAAAAAAAAAAAAAAAAAAAAAAAAAAAAAAAAAAAAAAAAAAAAAAAAAAAAAAAAAAAAAAAAAAAAAAAAAAAAAAAAAAAAAAAAAAAAAAAAAAAAAAAAAAAAAAAAAAAAAAAAAAAAAAAAAAAAAAAAAAAAAAAAAAAAAAAAAAAAAAAAAAAAAAAAAAAAAAAAAAAAAAAAAAAAAAAAAAAAAAAAAAAAAAAAAAAAAAAAAAAAAAAAAAAAAAAAAAAAAAAAAAAAAAAAAAAAAAAAAAAAAAAAAAAAAAAAAAAAAAAAAAAAAAAAAAAAAAAAAAAAAAAAAAAAAAAAAAAAAAAAAAAAAAAAAAAAAAAAAAAAAAAAAAAAAAAAAAAAAAAAAAAAAAAAAAAAAAAAAAAAAAAAAAAAAAAAAAAAAAAAAAAAAAAAAAAAAAAAAAAAAAAAAAAAAAAAAAAAAAAAAAAAAAAAAAAAAAAAAAAAAAAAAAAAAAAAAAAAAAAAAAAAAAAAAAAAAAAAAAAAAAAAAAAAAAAAAAAAAAAAAAAAAAAAAAAAAAAAAAAAAAAAAAAAAAAAAAAAAAAAAAAAAAAAAAAAAAAAAAAAAAAAAAAAAAAAAAAAAAAAAAAAAAAAAAAAAAAAAAAAAAAAAAAAAAAAAAAAAAAAAAAAAAAAAAAAAAAAAAAAAAAAAAAAAAAAAAAAAAAAAAAAAAAAAAAAAAAAAAAAAAAAAAAAAAAAAAAAAAAAAAAAAAAAAAAAAAAAAAAAAAAAAAAAAAAAAAAAAAAAAAAAAAAAAAAAAAAAAAAAAAAAAAAAAAAAAAAAAAAAAAAAAAAAAAAAAAAAAAAAAAAAAAAAAAAAAAAAAAAAAAAAAAAAAAAAAAAAAAAAAAAAAAAAAAAAAAAAAAAAAAAAAAAAAAAAAAAAAAAAAAAAAAAAAAAAAAAAAAAAAAAAAAAAAAAAAAAAAAAAAAAAAAAAAAAAAAAAAAAAAAAAAAAAAAAAAAAAAAAAAAAAAAAAAAAAAAAAAAAAAAAAAAAAAAAAAAAAAAAAAAAAAAAAAAAAAAAAAAAAAAAAAAAAAAAAAAAAAAAAAAAAAAAAAAAAAAAAAAAAAAAAAAAAAAAAAAAAAAAAAAAAAAAAAAAAAAAAAAAAAAAAAAAAAAAAAAAAAAAAAAAAAAAAAAAAAAAAAAAAAAAAAAAAAAAAAAAAAAAAAAAAAAAAAAAAAAAAAAAAAAAAAAAAAAAAAAAAAAAAAAAAAAAAAAAAAAAAAAAAAAAAAAAAAAAAAAAAAAAAAAAAAAAAAAAAAAAAAAAAAAAAAAAAAAAAAAAAAAAAAAAAAAAAAAAAAAAAAAAAAAAAAAAAAAAAAAAAAAAAAAAAAAAAAAAAAAAAAAAAAAAAAAAAAAAAAAAAAAAAAAAAAAAAAAAAAAAAAAAAAAAAAAAAAAAAAAAAAAAAAAAAAAAAAAAAAAAAAAAAAAAAAAAAAAAAAAAAAAAAAAAAAAAAAAAAAAAAAAAAAAAAAAAAAAAAAAAAAAAAAAAAAAAAAAAAAAAAAAAAAAAAAAAAAAAAAAAAAAAAAAAAAAAAAAAAAAAAAAAAAAAAAAAAAAAAAAAAAAAAAAAAAAAAAAAAAAAAAAAAAAAAAAAAAAAAAAAAAAAAAAAAAAAAAAAAAAAAAAAAAAAAAAAAAAAAAAAAAAAAAAAAAAAAAAAAAAAAAAAAAAAAAAAAAAAAAAAAAAAAAAAAAAAAAAAAAAAAAAAAAAAAAAAAAAAAAAAAAAAAAAAAAAAAAAAAAAAAAAAAAAAAAAAAAAAAAAAAAAAAAAAAAAAAAAAAAAAAAAAAAAAAAAAAAAAAAAAAAAAAAAAAAAAAAAAAAAAAAAAAAAAAAAAAAAAAAAAAAAAAAAAAAAAAAAAAAAAAAAAAAAAAAAAAAAAAAAAAAAAAAAAAAAAAAAAAAAAAAAAAAAAAAAAAAAAAAAAAAAAAAAAAAAAAAAAAAAAAAAAAAAAAAAAAAAAAAAAAAAAAAAAAAAAAAAAAAAAAAAAAAAAAAAAAAAAAAAAAAAAAAAAAAAAAAAAAAAAAAAAAAAAAAAAAAAAAAAAAAAAAAAAAAAAAAAAAAAAAAAAAAAAAAAAAAAAAAAAAAAAAAAAAAAAAAAAAAAAAAAAAAAAAAAAAAAAAAAAAAAAAAAAAAAAAAAAAAAAAAAAAAAAAAAAAAAAAAAAAAAAAAAAAAAAAAAAAAAAAAAAAAAAAAAAAAAAAAAAAAAAAAAAAAAAAAAAAAAAAAAAAAAAAAAAAAAAAAAAAAAAAAAAAAAAAAAAAAAAAAAAAAAAAAAAAAAAAAAAAAAAAAAAAAAAAAAAAAAAAAAAAAAAAAAAAAAAAAAAAAAAAAAAAAAAAAAAAAAAAAAAAAAAAAAAAAAAAAAAAAAAAAAAAAAAAAAAAAAAAAAAAAAAAAAAAAAAAAAAAAAAAAAAAAAAA"/>
   <p:tag name="EMPOWERCHARTSPROPERTIES_SLOT" val="A"/>
   <p:tag name="EMPOWERCHARTSPROPERTIES_LASTWRITEDATE" val="638446285407391725"/>
   <p:tag name="EMPOWERCHARTSPROPERTIES_A_LENGTH" val="24576"/>
+</p:tagLst>
+</file>
+
+<file path=ppt/tags/tag2.xml><?xml version="1.0" encoding="utf-8"?>
+<p:tagLst xmlns:a="http://schemas.openxmlformats.org/drawingml/2006/main" xmlns:r="http://schemas.openxmlformats.org/officeDocument/2006/relationships" xmlns:p="http://schemas.openxmlformats.org/presentationml/2006/main">
+  <p:tag name="MIO_CD_LOGO_PROTECTION" val="true"/>
+</p:tagLst>
+</file>
+
+<file path=ppt/tags/tag3.xml><?xml version="1.0" encoding="utf-8"?>
+<p:tagLst xmlns:a="http://schemas.openxmlformats.org/drawingml/2006/main" xmlns:r="http://schemas.openxmlformats.org/officeDocument/2006/relationships" xmlns:p="http://schemas.openxmlformats.org/presentationml/2006/main">
+  <p:tag name="THINKCELLSHAPEDONOTDELETE" val="thinkcellActiveDocDoNotDelete"/>
 </p:tagLst>
 </file>
 
@@ -12272,35 +14483,10 @@
 
 <file path=customXml/item1.xml><?xml version="1.0" encoding="utf-8"?>
 <?mso-contentType ?>
-<FormTemplates xmlns="http://schemas.microsoft.com/sharepoint/v3/contenttype/forms">
-  <Display>DocumentLibraryForm</Display>
-  <Edit>DocumentLibraryForm</Edit>
-  <New>DocumentLibraryForm</New>
-</FormTemplates>
+<SharedContentType xmlns="Microsoft.SharePoint.Taxonomy.ContentTypeSync" SourceId="7bc43322-b630-4bac-8b27-31def233d1d0" ContentTypeId="0x0101" PreviousValue="false"/>
 </file>
 
 <file path=customXml/item2.xml><?xml version="1.0" encoding="utf-8"?>
-<p:properties xmlns:p="http://schemas.microsoft.com/office/2006/metadata/properties" xmlns:xsi="http://www.w3.org/2001/XMLSchema-instance" xmlns:pc="http://schemas.microsoft.com/office/infopath/2007/PartnerControls">
-  <documentManagement>
-    <TaxCatchAll xmlns="1a4d292e-883c-434b-96e3-060cfff16c86" xsi:nil="true"/>
-    <_dlc_ExpireDateSaved xmlns="http://schemas.microsoft.com/sharepoint/v3" xsi:nil="true"/>
-    <_dlc_ExpireDate xmlns="http://schemas.microsoft.com/sharepoint/v3" xsi:nil="true"/>
-    <_dlc_Exempt xmlns="http://schemas.microsoft.com/sharepoint/v3">false</_dlc_Exempt>
-    <lcf76f155ced4ddcb4097134ff3c332f xmlns="9e8c98dc-1cc2-4e2b-8f63-7b59b1b0454b">
-      <Terms xmlns="http://schemas.microsoft.com/office/infopath/2007/PartnerControls"/>
-    </lcf76f155ced4ddcb4097134ff3c332f>
-    <SharedWithUsers xmlns="a5e35b8f-00fd-4376-9624-e7ec14d1a312">
-      <UserInfo>
-        <DisplayName>Eder Silva</DisplayName>
-        <AccountId>64</AccountId>
-        <AccountType/>
-      </UserInfo>
-    </SharedWithUsers>
-  </documentManagement>
-</p:properties>
-</file>
-
-<file path=customXml/item3.xml><?xml version="1.0" encoding="utf-8"?>
 <ct:contentTypeSchema xmlns:ct="http://schemas.microsoft.com/office/2006/metadata/contentType" xmlns:ma="http://schemas.microsoft.com/office/2006/metadata/properties/metaAttributes" ct:_="" ma:_="" ma:contentTypeName="Document" ma:contentTypeID="0x01010073B35D40139D0D4AAAC34CF6040DF05D" ma:contentTypeVersion="16" ma:contentTypeDescription="Create a new document." ma:contentTypeScope="" ma:versionID="5cea01adce4ee2953623ebdb797bc0f2">
   <xsd:schema xmlns:xsd="http://www.w3.org/2001/XMLSchema" xmlns:xs="http://www.w3.org/2001/XMLSchema" xmlns:p="http://schemas.microsoft.com/office/2006/metadata/properties" xmlns:ns1="http://schemas.microsoft.com/sharepoint/v3" xmlns:ns2="1a4d292e-883c-434b-96e3-060cfff16c86" xmlns:ns3="9e8c98dc-1cc2-4e2b-8f63-7b59b1b0454b" xmlns:ns4="a5e35b8f-00fd-4376-9624-e7ec14d1a312" targetNamespace="http://schemas.microsoft.com/office/2006/metadata/properties" ma:root="true" ma:fieldsID="f2d2dfdd41677bb1404cc274f6f9b71b" ns1:_="" ns2:_="" ns3:_="" ns4:_="">
     <xsd:import namespace="http://schemas.microsoft.com/sharepoint/v3"/>
@@ -12563,39 +14749,45 @@
 </ct:contentTypeSchema>
 </file>
 
+<file path=customXml/item3.xml><?xml version="1.0" encoding="utf-8"?>
+<p:properties xmlns:p="http://schemas.microsoft.com/office/2006/metadata/properties" xmlns:xsi="http://www.w3.org/2001/XMLSchema-instance" xmlns:pc="http://schemas.microsoft.com/office/infopath/2007/PartnerControls">
+  <documentManagement>
+    <TaxCatchAll xmlns="1a4d292e-883c-434b-96e3-060cfff16c86" xsi:nil="true"/>
+    <_dlc_ExpireDateSaved xmlns="http://schemas.microsoft.com/sharepoint/v3" xsi:nil="true"/>
+    <_dlc_ExpireDate xmlns="http://schemas.microsoft.com/sharepoint/v3" xsi:nil="true"/>
+    <_dlc_Exempt xmlns="http://schemas.microsoft.com/sharepoint/v3">false</_dlc_Exempt>
+    <lcf76f155ced4ddcb4097134ff3c332f xmlns="9e8c98dc-1cc2-4e2b-8f63-7b59b1b0454b">
+      <Terms xmlns="http://schemas.microsoft.com/office/infopath/2007/PartnerControls"/>
+    </lcf76f155ced4ddcb4097134ff3c332f>
+    <SharedWithUsers xmlns="a5e35b8f-00fd-4376-9624-e7ec14d1a312">
+      <UserInfo>
+        <DisplayName>Eder Silva</DisplayName>
+        <AccountId>64</AccountId>
+        <AccountType/>
+      </UserInfo>
+    </SharedWithUsers>
+  </documentManagement>
+</p:properties>
+</file>
+
 <file path=customXml/item4.xml><?xml version="1.0" encoding="utf-8"?>
 <?mso-contentType ?>
-<SharedContentType xmlns="Microsoft.SharePoint.Taxonomy.ContentTypeSync" SourceId="7bc43322-b630-4bac-8b27-31def233d1d0" ContentTypeId="0x0101" PreviousValue="false"/>
+<FormTemplates xmlns="http://schemas.microsoft.com/sharepoint/v3/contenttype/forms">
+  <Display>DocumentLibraryForm</Display>
+  <Edit>DocumentLibraryForm</Edit>
+  <New>DocumentLibraryForm</New>
+</FormTemplates>
 </file>
 
 <file path=customXml/itemProps1.xml><?xml version="1.0" encoding="utf-8"?>
-<ds:datastoreItem xmlns:ds="http://schemas.openxmlformats.org/officeDocument/2006/customXml" ds:itemID="{E92E76FD-DDEE-46BB-B3B6-1BA841480DE6}">
+<ds:datastoreItem xmlns:ds="http://schemas.openxmlformats.org/officeDocument/2006/customXml" ds:itemID="{DAFB3847-8B1B-4BFC-8251-3AD1727A1A22}">
   <ds:schemaRefs>
-    <ds:schemaRef ds:uri="http://schemas.microsoft.com/sharepoint/v3/contenttype/forms"/>
+    <ds:schemaRef ds:uri="Microsoft.SharePoint.Taxonomy.ContentTypeSync"/>
   </ds:schemaRefs>
 </ds:datastoreItem>
 </file>
 
 <file path=customXml/itemProps2.xml><?xml version="1.0" encoding="utf-8"?>
-<ds:datastoreItem xmlns:ds="http://schemas.openxmlformats.org/officeDocument/2006/customXml" ds:itemID="{F5900DEE-58B9-484F-884F-4E670F94CF32}">
-  <ds:schemaRefs>
-    <ds:schemaRef ds:uri="1a4d292e-883c-434b-96e3-060cfff16c86"/>
-    <ds:schemaRef ds:uri="9e8c98dc-1cc2-4e2b-8f63-7b59b1b0454b"/>
-    <ds:schemaRef ds:uri="a5e35b8f-00fd-4376-9624-e7ec14d1a312"/>
-    <ds:schemaRef ds:uri="http://purl.org/dc/dcmitype/"/>
-    <ds:schemaRef ds:uri="http://purl.org/dc/elements/1.1/"/>
-    <ds:schemaRef ds:uri="http://purl.org/dc/terms/"/>
-    <ds:schemaRef ds:uri="http://schemas.microsoft.com/office/2006/documentManagement/types"/>
-    <ds:schemaRef ds:uri="http://schemas.microsoft.com/office/2006/metadata/properties"/>
-    <ds:schemaRef ds:uri="http://schemas.microsoft.com/office/infopath/2007/PartnerControls"/>
-    <ds:schemaRef ds:uri="http://schemas.microsoft.com/sharepoint/v3"/>
-    <ds:schemaRef ds:uri="http://schemas.openxmlformats.org/package/2006/metadata/core-properties"/>
-    <ds:schemaRef ds:uri="http://www.w3.org/XML/1998/namespace"/>
-  </ds:schemaRefs>
-</ds:datastoreItem>
-</file>
-
-<file path=customXml/itemProps3.xml><?xml version="1.0" encoding="utf-8"?>
 <ds:datastoreItem xmlns:ds="http://schemas.openxmlformats.org/officeDocument/2006/customXml" ds:itemID="{4E34579B-8CE0-439D-925A-1B0EE1A58DD6}">
   <ds:schemaRefs>
     <ds:schemaRef ds:uri="1a4d292e-883c-434b-96e3-060cfff16c86"/>
@@ -12616,10 +14808,29 @@
 </ds:datastoreItem>
 </file>
 
+<file path=customXml/itemProps3.xml><?xml version="1.0" encoding="utf-8"?>
+<ds:datastoreItem xmlns:ds="http://schemas.openxmlformats.org/officeDocument/2006/customXml" ds:itemID="{F5900DEE-58B9-484F-884F-4E670F94CF32}">
+  <ds:schemaRefs>
+    <ds:schemaRef ds:uri="1a4d292e-883c-434b-96e3-060cfff16c86"/>
+    <ds:schemaRef ds:uri="9e8c98dc-1cc2-4e2b-8f63-7b59b1b0454b"/>
+    <ds:schemaRef ds:uri="a5e35b8f-00fd-4376-9624-e7ec14d1a312"/>
+    <ds:schemaRef ds:uri="http://purl.org/dc/dcmitype/"/>
+    <ds:schemaRef ds:uri="http://purl.org/dc/elements/1.1/"/>
+    <ds:schemaRef ds:uri="http://purl.org/dc/terms/"/>
+    <ds:schemaRef ds:uri="http://schemas.microsoft.com/office/2006/documentManagement/types"/>
+    <ds:schemaRef ds:uri="http://schemas.microsoft.com/office/2006/metadata/properties"/>
+    <ds:schemaRef ds:uri="http://schemas.microsoft.com/office/infopath/2007/PartnerControls"/>
+    <ds:schemaRef ds:uri="http://schemas.microsoft.com/sharepoint/v3"/>
+    <ds:schemaRef ds:uri="http://schemas.openxmlformats.org/package/2006/metadata/core-properties"/>
+    <ds:schemaRef ds:uri="http://www.w3.org/XML/1998/namespace"/>
+  </ds:schemaRefs>
+</ds:datastoreItem>
+</file>
+
 <file path=customXml/itemProps4.xml><?xml version="1.0" encoding="utf-8"?>
-<ds:datastoreItem xmlns:ds="http://schemas.openxmlformats.org/officeDocument/2006/customXml" ds:itemID="{DAFB3847-8B1B-4BFC-8251-3AD1727A1A22}">
+<ds:datastoreItem xmlns:ds="http://schemas.openxmlformats.org/officeDocument/2006/customXml" ds:itemID="{E92E76FD-DDEE-46BB-B3B6-1BA841480DE6}">
   <ds:schemaRefs>
-    <ds:schemaRef ds:uri="Microsoft.SharePoint.Taxonomy.ContentTypeSync"/>
+    <ds:schemaRef ds:uri="http://schemas.microsoft.com/sharepoint/v3/contenttype/forms"/>
   </ds:schemaRefs>
 </ds:datastoreItem>
 </file>
</xml_diff>